<commit_message>
feat : ElasticSearch 자동완성 기능 API 작성
</commit_message>
<xml_diff>
--- a/ppt/7.SpringBoot - ElasticSearch 도입.pptx
+++ b/ppt/7.SpringBoot - ElasticSearch 도입.pptx
@@ -5,7 +5,7 @@
     <p:sldMasterId id="2147483660" r:id="rId1"/>
   </p:sldMasterIdLst>
   <p:notesMasterIdLst>
-    <p:notesMasterId r:id="rId14"/>
+    <p:notesMasterId r:id="rId22"/>
   </p:notesMasterIdLst>
   <p:sldIdLst>
     <p:sldId id="256" r:id="rId2"/>
@@ -20,9 +20,17 @@
     <p:sldId id="266" r:id="rId11"/>
     <p:sldId id="267" r:id="rId12"/>
     <p:sldId id="268" r:id="rId13"/>
+    <p:sldId id="269" r:id="rId14"/>
+    <p:sldId id="270" r:id="rId15"/>
+    <p:sldId id="271" r:id="rId16"/>
+    <p:sldId id="272" r:id="rId17"/>
+    <p:sldId id="273" r:id="rId18"/>
+    <p:sldId id="274" r:id="rId19"/>
+    <p:sldId id="275" r:id="rId20"/>
+    <p:sldId id="276" r:id="rId21"/>
   </p:sldIdLst>
   <p:sldSz cx="12192000" cy="6858000"/>
-  <p:notesSz cx="6858000" cy="9144000"/>
+  <p:notesSz cx="7105650" cy="10236200"/>
   <p:defaultTextStyle>
     <a:defPPr>
       <a:defRPr lang="en-US"/>
@@ -153,7 +161,30 @@
             <p14:sldId id="268"/>
           </p14:sldIdLst>
         </p14:section>
+        <p14:section name="SpringBoot App ElasticSearch 적용" id="{C7E007AA-E0E6-4D11-907D-812F545908D4}">
+          <p14:sldIdLst>
+            <p14:sldId id="269"/>
+            <p14:sldId id="270"/>
+          </p14:sldIdLst>
+        </p14:section>
+        <p14:section name="상품 등록 및 삭제 기능" id="{F18BDDFD-66E1-4822-B922-01D5AFCD8EF4}">
+          <p14:sldIdLst>
+            <p14:sldId id="271"/>
+            <p14:sldId id="272"/>
+            <p14:sldId id="273"/>
+            <p14:sldId id="274"/>
+          </p14:sldIdLst>
+        </p14:section>
+        <p14:section name="자동완성기능" id="{5868DABF-4193-423E-BB43-60AE492D52D4}">
+          <p14:sldIdLst>
+            <p14:sldId id="275"/>
+            <p14:sldId id="276"/>
+          </p14:sldIdLst>
+        </p14:section>
       </p14:sectionLst>
+    </p:ext>
+    <p:ext uri="{EFAFB233-063F-42B5-8137-9DF3F51BA10A}">
+      <p15:sldGuideLst xmlns:p15="http://schemas.microsoft.com/office/powerpoint/2012/main"/>
     </p:ext>
   </p:extLst>
 </p:presentation>
@@ -194,17 +225,17 @@
         <p:spPr>
           <a:xfrm>
             <a:off x="0" y="0"/>
-            <a:ext cx="2971800" cy="458788"/>
+            <a:ext cx="3079115" cy="513588"/>
           </a:xfrm>
           <a:prstGeom prst="rect">
             <a:avLst/>
           </a:prstGeom>
         </p:spPr>
         <p:txBody>
-          <a:bodyPr vert="horz" lIns="91440" tIns="45720" rIns="91440" bIns="45720" rtlCol="0"/>
+          <a:bodyPr vert="horz" lIns="99094" tIns="49547" rIns="99094" bIns="49547" rtlCol="0"/>
           <a:lstStyle>
             <a:lvl1pPr algn="l">
-              <a:defRPr sz="1200"/>
+              <a:defRPr sz="1300"/>
             </a:lvl1pPr>
           </a:lstStyle>
           <a:p>
@@ -224,24 +255,24 @@
         </p:nvSpPr>
         <p:spPr>
           <a:xfrm>
-            <a:off x="3884613" y="0"/>
-            <a:ext cx="2971800" cy="458788"/>
+            <a:off x="4024891" y="0"/>
+            <a:ext cx="3079115" cy="513588"/>
           </a:xfrm>
           <a:prstGeom prst="rect">
             <a:avLst/>
           </a:prstGeom>
         </p:spPr>
         <p:txBody>
-          <a:bodyPr vert="horz" lIns="91440" tIns="45720" rIns="91440" bIns="45720" rtlCol="0"/>
+          <a:bodyPr vert="horz" lIns="99094" tIns="49547" rIns="99094" bIns="49547" rtlCol="0"/>
           <a:lstStyle>
             <a:lvl1pPr algn="r">
-              <a:defRPr sz="1200"/>
+              <a:defRPr sz="1300"/>
             </a:lvl1pPr>
           </a:lstStyle>
           <a:p>
             <a:fld id="{EBB39729-CD21-4644-AA86-B8B07B68A2D4}" type="datetimeFigureOut">
               <a:rPr lang="ko-KR" altLang="en-US" smtClean="0"/>
-              <a:t>2026-09-05</a:t>
+              <a:t>2026-09-06</a:t>
             </a:fld>
             <a:endParaRPr lang="ko-KR" altLang="en-US"/>
           </a:p>
@@ -259,8 +290,8 @@
         </p:nvSpPr>
         <p:spPr>
           <a:xfrm>
-            <a:off x="685800" y="1143000"/>
-            <a:ext cx="5486400" cy="3086100"/>
+            <a:off x="482600" y="1279525"/>
+            <a:ext cx="6140450" cy="3454400"/>
           </a:xfrm>
           <a:prstGeom prst="rect">
             <a:avLst/>
@@ -273,7 +304,7 @@
           </a:ln>
         </p:spPr>
         <p:txBody>
-          <a:bodyPr vert="horz" lIns="91440" tIns="45720" rIns="91440" bIns="45720" rtlCol="0" anchor="ctr"/>
+          <a:bodyPr vert="horz" lIns="99094" tIns="49547" rIns="99094" bIns="49547" rtlCol="0" anchor="ctr"/>
           <a:lstStyle/>
           <a:p>
             <a:endParaRPr lang="ko-KR" altLang="en-US"/>
@@ -292,15 +323,15 @@
         </p:nvSpPr>
         <p:spPr>
           <a:xfrm>
-            <a:off x="685800" y="4400550"/>
-            <a:ext cx="5486400" cy="3600450"/>
+            <a:off x="710565" y="4926171"/>
+            <a:ext cx="5684520" cy="4030504"/>
           </a:xfrm>
           <a:prstGeom prst="rect">
             <a:avLst/>
           </a:prstGeom>
         </p:spPr>
         <p:txBody>
-          <a:bodyPr vert="horz" lIns="91440" tIns="45720" rIns="91440" bIns="45720" rtlCol="0"/>
+          <a:bodyPr vert="horz" lIns="99094" tIns="49547" rIns="99094" bIns="49547" rtlCol="0"/>
           <a:lstStyle/>
           <a:p>
             <a:pPr lvl="0"/>
@@ -351,18 +382,18 @@
         </p:nvSpPr>
         <p:spPr>
           <a:xfrm>
-            <a:off x="0" y="8685213"/>
-            <a:ext cx="2971800" cy="458787"/>
+            <a:off x="0" y="9722614"/>
+            <a:ext cx="3079115" cy="513587"/>
           </a:xfrm>
           <a:prstGeom prst="rect">
             <a:avLst/>
           </a:prstGeom>
         </p:spPr>
         <p:txBody>
-          <a:bodyPr vert="horz" lIns="91440" tIns="45720" rIns="91440" bIns="45720" rtlCol="0" anchor="b"/>
+          <a:bodyPr vert="horz" lIns="99094" tIns="49547" rIns="99094" bIns="49547" rtlCol="0" anchor="b"/>
           <a:lstStyle>
             <a:lvl1pPr algn="l">
-              <a:defRPr sz="1200"/>
+              <a:defRPr sz="1300"/>
             </a:lvl1pPr>
           </a:lstStyle>
           <a:p>
@@ -382,18 +413,18 @@
         </p:nvSpPr>
         <p:spPr>
           <a:xfrm>
-            <a:off x="3884613" y="8685213"/>
-            <a:ext cx="2971800" cy="458787"/>
+            <a:off x="4024891" y="9722614"/>
+            <a:ext cx="3079115" cy="513587"/>
           </a:xfrm>
           <a:prstGeom prst="rect">
             <a:avLst/>
           </a:prstGeom>
         </p:spPr>
         <p:txBody>
-          <a:bodyPr vert="horz" lIns="91440" tIns="45720" rIns="91440" bIns="45720" rtlCol="0" anchor="b"/>
+          <a:bodyPr vert="horz" lIns="99094" tIns="49547" rIns="99094" bIns="49547" rtlCol="0" anchor="b"/>
           <a:lstStyle>
             <a:lvl1pPr algn="r">
-              <a:defRPr sz="1200"/>
+              <a:defRPr sz="1300"/>
             </a:lvl1pPr>
           </a:lstStyle>
           <a:p>
@@ -818,7 +849,7 @@
           <a:p>
             <a:fld id="{9C052116-9884-49CF-B26E-269C3EFC009F}" type="datetimeFigureOut">
               <a:rPr lang="ko-KR" altLang="en-US" smtClean="0"/>
-              <a:t>2026-09-05</a:t>
+              <a:t>2026-09-06</a:t>
             </a:fld>
             <a:endParaRPr lang="ko-KR" altLang="en-US"/>
           </a:p>
@@ -1026,7 +1057,7 @@
           <a:p>
             <a:fld id="{9C052116-9884-49CF-B26E-269C3EFC009F}" type="datetimeFigureOut">
               <a:rPr lang="ko-KR" altLang="en-US" smtClean="0"/>
-              <a:t>2026-09-05</a:t>
+              <a:t>2026-09-06</a:t>
             </a:fld>
             <a:endParaRPr lang="ko-KR" altLang="en-US"/>
           </a:p>
@@ -1282,7 +1313,7 @@
           <a:p>
             <a:fld id="{9C052116-9884-49CF-B26E-269C3EFC009F}" type="datetimeFigureOut">
               <a:rPr lang="ko-KR" altLang="en-US" smtClean="0"/>
-              <a:t>2026-09-05</a:t>
+              <a:t>2026-09-06</a:t>
             </a:fld>
             <a:endParaRPr lang="ko-KR" altLang="en-US"/>
           </a:p>
@@ -1456,7 +1487,7 @@
           <a:p>
             <a:fld id="{9C052116-9884-49CF-B26E-269C3EFC009F}" type="datetimeFigureOut">
               <a:rPr lang="ko-KR" altLang="en-US" smtClean="0"/>
-              <a:t>2026-09-05</a:t>
+              <a:t>2026-09-06</a:t>
             </a:fld>
             <a:endParaRPr lang="ko-KR" altLang="en-US"/>
           </a:p>
@@ -1799,7 +1830,7 @@
           <a:p>
             <a:fld id="{9C052116-9884-49CF-B26E-269C3EFC009F}" type="datetimeFigureOut">
               <a:rPr lang="ko-KR" altLang="en-US" smtClean="0"/>
-              <a:t>2026-09-05</a:t>
+              <a:t>2026-09-06</a:t>
             </a:fld>
             <a:endParaRPr lang="ko-KR" altLang="en-US"/>
           </a:p>
@@ -2074,7 +2105,7 @@
           <a:p>
             <a:fld id="{9C052116-9884-49CF-B26E-269C3EFC009F}" type="datetimeFigureOut">
               <a:rPr lang="ko-KR" altLang="en-US" smtClean="0"/>
-              <a:t>2026-09-05</a:t>
+              <a:t>2026-09-06</a:t>
             </a:fld>
             <a:endParaRPr lang="ko-KR" altLang="en-US"/>
           </a:p>
@@ -2453,7 +2484,7 @@
           <a:p>
             <a:fld id="{9C052116-9884-49CF-B26E-269C3EFC009F}" type="datetimeFigureOut">
               <a:rPr lang="ko-KR" altLang="en-US" smtClean="0"/>
-              <a:t>2026-09-05</a:t>
+              <a:t>2026-09-06</a:t>
             </a:fld>
             <a:endParaRPr lang="ko-KR" altLang="en-US"/>
           </a:p>
@@ -2571,7 +2602,7 @@
           <a:p>
             <a:fld id="{9C052116-9884-49CF-B26E-269C3EFC009F}" type="datetimeFigureOut">
               <a:rPr lang="ko-KR" altLang="en-US" smtClean="0"/>
-              <a:t>2026-09-05</a:t>
+              <a:t>2026-09-06</a:t>
             </a:fld>
             <a:endParaRPr lang="ko-KR" altLang="en-US"/>
           </a:p>
@@ -2742,7 +2773,7 @@
           <a:p>
             <a:fld id="{9C052116-9884-49CF-B26E-269C3EFC009F}" type="datetimeFigureOut">
               <a:rPr lang="ko-KR" altLang="en-US" smtClean="0"/>
-              <a:t>2026-09-05</a:t>
+              <a:t>2026-09-06</a:t>
             </a:fld>
             <a:endParaRPr lang="ko-KR" altLang="en-US"/>
           </a:p>
@@ -3096,7 +3127,7 @@
           <a:p>
             <a:fld id="{9C052116-9884-49CF-B26E-269C3EFC009F}" type="datetimeFigureOut">
               <a:rPr lang="ko-KR" altLang="en-US" smtClean="0"/>
-              <a:t>2026-09-05</a:t>
+              <a:t>2026-09-06</a:t>
             </a:fld>
             <a:endParaRPr lang="ko-KR" altLang="en-US"/>
           </a:p>
@@ -3478,7 +3509,7 @@
           <a:p>
             <a:fld id="{9C052116-9884-49CF-B26E-269C3EFC009F}" type="datetimeFigureOut">
               <a:rPr lang="ko-KR" altLang="en-US" smtClean="0"/>
-              <a:t>2026-09-05</a:t>
+              <a:t>2026-09-06</a:t>
             </a:fld>
             <a:endParaRPr lang="ko-KR" altLang="en-US"/>
           </a:p>
@@ -3765,7 +3796,7 @@
           <a:p>
             <a:fld id="{9C052116-9884-49CF-B26E-269C3EFC009F}" type="datetimeFigureOut">
               <a:rPr lang="ko-KR" altLang="en-US" smtClean="0"/>
-              <a:t>2026-09-05</a:t>
+              <a:t>2026-09-06</a:t>
             </a:fld>
             <a:endParaRPr lang="ko-KR" altLang="en-US"/>
           </a:p>
@@ -4313,8 +4344,12 @@
           <a:lstStyle/>
           <a:p>
             <a:r>
+              <a:rPr lang="en-US" altLang="ko-KR" sz="6000" dirty="0" err="1"/>
+              <a:t>SpringBoot</a:t>
+            </a:r>
+            <a:r>
               <a:rPr lang="en-US" altLang="ko-KR" sz="6000"/>
-              <a:t>SpringBoot - ElasticSearch </a:t>
+              <a:t> - ElasticSearch </a:t>
             </a:r>
             <a:r>
               <a:rPr lang="ko-KR" altLang="en-US" sz="6000"/>
@@ -7240,6 +7275,3172 @@
 </p:sld>
 </file>
 
+<file path=ppt/slides/slide13.xml><?xml version="1.0" encoding="utf-8"?>
+<p:sld xmlns:a="http://schemas.openxmlformats.org/drawingml/2006/main" xmlns:r="http://schemas.openxmlformats.org/officeDocument/2006/relationships" xmlns:p="http://schemas.openxmlformats.org/presentationml/2006/main">
+  <p:cSld>
+    <p:spTree>
+      <p:nvGrpSpPr>
+        <p:cNvPr id="1" name=""/>
+        <p:cNvGrpSpPr/>
+        <p:nvPr/>
+      </p:nvGrpSpPr>
+      <p:grpSpPr>
+        <a:xfrm>
+          <a:off x="0" y="0"/>
+          <a:ext cx="0" cy="0"/>
+          <a:chOff x="0" y="0"/>
+          <a:chExt cx="0" cy="0"/>
+        </a:xfrm>
+      </p:grpSpPr>
+      <p:sp>
+        <p:nvSpPr>
+          <p:cNvPr id="2" name="제목 1">
+            <a:extLst>
+              <a:ext uri="{FF2B5EF4-FFF2-40B4-BE49-F238E27FC236}">
+                <a16:creationId xmlns:a16="http://schemas.microsoft.com/office/drawing/2014/main" id="{6E4B45BF-A8FB-C0D8-B619-90A41D259575}"/>
+              </a:ext>
+            </a:extLst>
+          </p:cNvPr>
+          <p:cNvSpPr>
+            <a:spLocks noGrp="1"/>
+          </p:cNvSpPr>
+          <p:nvPr>
+            <p:ph type="title"/>
+          </p:nvPr>
+        </p:nvSpPr>
+        <p:spPr/>
+        <p:txBody>
+          <a:bodyPr/>
+          <a:lstStyle/>
+          <a:p>
+            <a:r>
+              <a:rPr lang="en-US" altLang="ko-KR"/>
+              <a:t>Gradle </a:t>
+            </a:r>
+            <a:r>
+              <a:rPr lang="ko-KR" altLang="en-US"/>
+              <a:t>의존성 추가하기</a:t>
+            </a:r>
+          </a:p>
+        </p:txBody>
+      </p:sp>
+      <p:grpSp>
+        <p:nvGrpSpPr>
+          <p:cNvPr id="8" name="그룹 7">
+            <a:extLst>
+              <a:ext uri="{FF2B5EF4-FFF2-40B4-BE49-F238E27FC236}">
+                <a16:creationId xmlns:a16="http://schemas.microsoft.com/office/drawing/2014/main" id="{9E795399-1959-642A-7BD2-B70AB21745A9}"/>
+              </a:ext>
+            </a:extLst>
+          </p:cNvPr>
+          <p:cNvGrpSpPr/>
+          <p:nvPr/>
+        </p:nvGrpSpPr>
+        <p:grpSpPr>
+          <a:xfrm>
+            <a:off x="1262263" y="1890251"/>
+            <a:ext cx="2086266" cy="4124901"/>
+            <a:chOff x="1262263" y="1890251"/>
+            <a:chExt cx="2086266" cy="4124901"/>
+          </a:xfrm>
+        </p:grpSpPr>
+        <p:pic>
+          <p:nvPicPr>
+            <p:cNvPr id="6" name="그림 5">
+              <a:extLst>
+                <a:ext uri="{FF2B5EF4-FFF2-40B4-BE49-F238E27FC236}">
+                  <a16:creationId xmlns:a16="http://schemas.microsoft.com/office/drawing/2014/main" id="{74C17979-BD02-F7F3-353A-1F20A771772A}"/>
+                </a:ext>
+              </a:extLst>
+            </p:cNvPr>
+            <p:cNvPicPr>
+              <a:picLocks noChangeAspect="1"/>
+            </p:cNvPicPr>
+            <p:nvPr/>
+          </p:nvPicPr>
+          <p:blipFill>
+            <a:blip r:embed="rId2"/>
+            <a:stretch>
+              <a:fillRect/>
+            </a:stretch>
+          </p:blipFill>
+          <p:spPr>
+            <a:xfrm>
+              <a:off x="1262263" y="1890251"/>
+              <a:ext cx="2086266" cy="4124901"/>
+            </a:xfrm>
+            <a:prstGeom prst="rect">
+              <a:avLst/>
+            </a:prstGeom>
+          </p:spPr>
+        </p:pic>
+        <p:sp>
+          <p:nvSpPr>
+            <p:cNvPr id="7" name="직사각형 6">
+              <a:extLst>
+                <a:ext uri="{FF2B5EF4-FFF2-40B4-BE49-F238E27FC236}">
+                  <a16:creationId xmlns:a16="http://schemas.microsoft.com/office/drawing/2014/main" id="{1FE5FE27-F398-9A99-DAC8-DBA2C1D40594}"/>
+                </a:ext>
+              </a:extLst>
+            </p:cNvPr>
+            <p:cNvSpPr/>
+            <p:nvPr/>
+          </p:nvSpPr>
+          <p:spPr>
+            <a:xfrm>
+              <a:off x="1388225" y="4921135"/>
+              <a:ext cx="1047404" cy="249381"/>
+            </a:xfrm>
+            <a:prstGeom prst="rect">
+              <a:avLst/>
+            </a:prstGeom>
+            <a:noFill/>
+            <a:ln>
+              <a:solidFill>
+                <a:srgbClr val="FF0000"/>
+              </a:solidFill>
+            </a:ln>
+          </p:spPr>
+          <p:style>
+            <a:lnRef idx="2">
+              <a:schemeClr val="accent1">
+                <a:shade val="15000"/>
+              </a:schemeClr>
+            </a:lnRef>
+            <a:fillRef idx="1">
+              <a:schemeClr val="accent1"/>
+            </a:fillRef>
+            <a:effectRef idx="0">
+              <a:schemeClr val="accent1"/>
+            </a:effectRef>
+            <a:fontRef idx="minor">
+              <a:schemeClr val="lt1"/>
+            </a:fontRef>
+          </p:style>
+          <p:txBody>
+            <a:bodyPr rtlCol="0" anchor="ctr"/>
+            <a:lstStyle/>
+            <a:p>
+              <a:pPr algn="ctr"/>
+              <a:endParaRPr lang="ko-KR" altLang="en-US"/>
+            </a:p>
+          </p:txBody>
+        </p:sp>
+      </p:grpSp>
+      <p:grpSp>
+        <p:nvGrpSpPr>
+          <p:cNvPr id="10" name="그룹 9">
+            <a:extLst>
+              <a:ext uri="{FF2B5EF4-FFF2-40B4-BE49-F238E27FC236}">
+                <a16:creationId xmlns:a16="http://schemas.microsoft.com/office/drawing/2014/main" id="{785A3620-27ED-F894-75DF-12C126F554DB}"/>
+              </a:ext>
+            </a:extLst>
+          </p:cNvPr>
+          <p:cNvGrpSpPr/>
+          <p:nvPr/>
+        </p:nvGrpSpPr>
+        <p:grpSpPr>
+          <a:xfrm>
+            <a:off x="3488450" y="1890251"/>
+            <a:ext cx="6744641" cy="1714739"/>
+            <a:chOff x="3488450" y="1890251"/>
+            <a:chExt cx="6744641" cy="1714739"/>
+          </a:xfrm>
+        </p:grpSpPr>
+        <p:pic>
+          <p:nvPicPr>
+            <p:cNvPr id="4" name="그림 3">
+              <a:extLst>
+                <a:ext uri="{FF2B5EF4-FFF2-40B4-BE49-F238E27FC236}">
+                  <a16:creationId xmlns:a16="http://schemas.microsoft.com/office/drawing/2014/main" id="{EFF0BAAC-427F-FA06-2980-AA6F861C4444}"/>
+                </a:ext>
+              </a:extLst>
+            </p:cNvPr>
+            <p:cNvPicPr>
+              <a:picLocks noChangeAspect="1"/>
+            </p:cNvPicPr>
+            <p:nvPr/>
+          </p:nvPicPr>
+          <p:blipFill>
+            <a:blip r:embed="rId3"/>
+            <a:stretch>
+              <a:fillRect/>
+            </a:stretch>
+          </p:blipFill>
+          <p:spPr>
+            <a:xfrm>
+              <a:off x="3488450" y="1890251"/>
+              <a:ext cx="6744641" cy="1714739"/>
+            </a:xfrm>
+            <a:prstGeom prst="rect">
+              <a:avLst/>
+            </a:prstGeom>
+          </p:spPr>
+        </p:pic>
+        <p:sp>
+          <p:nvSpPr>
+            <p:cNvPr id="9" name="직사각형 8">
+              <a:extLst>
+                <a:ext uri="{FF2B5EF4-FFF2-40B4-BE49-F238E27FC236}">
+                  <a16:creationId xmlns:a16="http://schemas.microsoft.com/office/drawing/2014/main" id="{4593584F-9B69-849D-475B-49651B62EE08}"/>
+                </a:ext>
+              </a:extLst>
+            </p:cNvPr>
+            <p:cNvSpPr/>
+            <p:nvPr/>
+          </p:nvSpPr>
+          <p:spPr>
+            <a:xfrm>
+              <a:off x="4272742" y="2443942"/>
+              <a:ext cx="5893723" cy="241069"/>
+            </a:xfrm>
+            <a:prstGeom prst="rect">
+              <a:avLst/>
+            </a:prstGeom>
+            <a:noFill/>
+            <a:ln>
+              <a:solidFill>
+                <a:srgbClr val="FF0000"/>
+              </a:solidFill>
+            </a:ln>
+          </p:spPr>
+          <p:style>
+            <a:lnRef idx="2">
+              <a:schemeClr val="accent1">
+                <a:shade val="15000"/>
+              </a:schemeClr>
+            </a:lnRef>
+            <a:fillRef idx="1">
+              <a:schemeClr val="accent1"/>
+            </a:fillRef>
+            <a:effectRef idx="0">
+              <a:schemeClr val="accent1"/>
+            </a:effectRef>
+            <a:fontRef idx="minor">
+              <a:schemeClr val="lt1"/>
+            </a:fontRef>
+          </p:style>
+          <p:txBody>
+            <a:bodyPr rtlCol="0" anchor="ctr"/>
+            <a:lstStyle/>
+            <a:p>
+              <a:pPr algn="ctr"/>
+              <a:endParaRPr lang="ko-KR" altLang="en-US"/>
+            </a:p>
+          </p:txBody>
+        </p:sp>
+      </p:grpSp>
+    </p:spTree>
+    <p:extLst>
+      <p:ext uri="{BB962C8B-B14F-4D97-AF65-F5344CB8AC3E}">
+        <p14:creationId xmlns:p14="http://schemas.microsoft.com/office/powerpoint/2010/main" val="1968560901"/>
+      </p:ext>
+    </p:extLst>
+  </p:cSld>
+  <p:clrMapOvr>
+    <a:masterClrMapping/>
+  </p:clrMapOvr>
+</p:sld>
+</file>
+
+<file path=ppt/slides/slide14.xml><?xml version="1.0" encoding="utf-8"?>
+<p:sld xmlns:a="http://schemas.openxmlformats.org/drawingml/2006/main" xmlns:r="http://schemas.openxmlformats.org/officeDocument/2006/relationships" xmlns:p="http://schemas.openxmlformats.org/presentationml/2006/main">
+  <p:cSld>
+    <p:spTree>
+      <p:nvGrpSpPr>
+        <p:cNvPr id="1" name=""/>
+        <p:cNvGrpSpPr/>
+        <p:nvPr/>
+      </p:nvGrpSpPr>
+      <p:grpSpPr>
+        <a:xfrm>
+          <a:off x="0" y="0"/>
+          <a:ext cx="0" cy="0"/>
+          <a:chOff x="0" y="0"/>
+          <a:chExt cx="0" cy="0"/>
+        </a:xfrm>
+      </p:grpSpPr>
+      <p:sp>
+        <p:nvSpPr>
+          <p:cNvPr id="2" name="제목 1">
+            <a:extLst>
+              <a:ext uri="{FF2B5EF4-FFF2-40B4-BE49-F238E27FC236}">
+                <a16:creationId xmlns:a16="http://schemas.microsoft.com/office/drawing/2014/main" id="{45E5E516-25AC-0B78-4408-5066D0FBF6CE}"/>
+              </a:ext>
+            </a:extLst>
+          </p:cNvPr>
+          <p:cNvSpPr>
+            <a:spLocks noGrp="1"/>
+          </p:cNvSpPr>
+          <p:nvPr>
+            <p:ph type="title"/>
+          </p:nvPr>
+        </p:nvSpPr>
+        <p:spPr/>
+        <p:txBody>
+          <a:bodyPr/>
+          <a:lstStyle/>
+          <a:p>
+            <a:r>
+              <a:rPr lang="en-US" altLang="ko-KR"/>
+              <a:t>application.yml </a:t>
+            </a:r>
+            <a:r>
+              <a:rPr lang="ko-KR" altLang="en-US"/>
+              <a:t>수정</a:t>
+            </a:r>
+          </a:p>
+        </p:txBody>
+      </p:sp>
+      <p:grpSp>
+        <p:nvGrpSpPr>
+          <p:cNvPr id="8" name="그룹 7">
+            <a:extLst>
+              <a:ext uri="{FF2B5EF4-FFF2-40B4-BE49-F238E27FC236}">
+                <a16:creationId xmlns:a16="http://schemas.microsoft.com/office/drawing/2014/main" id="{8B4EFD28-4BC2-C261-9503-D6122F542677}"/>
+              </a:ext>
+            </a:extLst>
+          </p:cNvPr>
+          <p:cNvGrpSpPr/>
+          <p:nvPr/>
+        </p:nvGrpSpPr>
+        <p:grpSpPr>
+          <a:xfrm>
+            <a:off x="1097280" y="1928603"/>
+            <a:ext cx="2514951" cy="2905530"/>
+            <a:chOff x="1097280" y="1928603"/>
+            <a:chExt cx="2514951" cy="2905530"/>
+          </a:xfrm>
+        </p:grpSpPr>
+        <p:pic>
+          <p:nvPicPr>
+            <p:cNvPr id="6" name="그림 5">
+              <a:extLst>
+                <a:ext uri="{FF2B5EF4-FFF2-40B4-BE49-F238E27FC236}">
+                  <a16:creationId xmlns:a16="http://schemas.microsoft.com/office/drawing/2014/main" id="{5657639B-8D72-D05C-BA6C-B7F4C4C7DF9B}"/>
+                </a:ext>
+              </a:extLst>
+            </p:cNvPr>
+            <p:cNvPicPr>
+              <a:picLocks noChangeAspect="1"/>
+            </p:cNvPicPr>
+            <p:nvPr/>
+          </p:nvPicPr>
+          <p:blipFill>
+            <a:blip r:embed="rId2"/>
+            <a:stretch>
+              <a:fillRect/>
+            </a:stretch>
+          </p:blipFill>
+          <p:spPr>
+            <a:xfrm>
+              <a:off x="1097280" y="1928603"/>
+              <a:ext cx="2514951" cy="2905530"/>
+            </a:xfrm>
+            <a:prstGeom prst="rect">
+              <a:avLst/>
+            </a:prstGeom>
+          </p:spPr>
+        </p:pic>
+        <p:sp>
+          <p:nvSpPr>
+            <p:cNvPr id="7" name="직사각형 6">
+              <a:extLst>
+                <a:ext uri="{FF2B5EF4-FFF2-40B4-BE49-F238E27FC236}">
+                  <a16:creationId xmlns:a16="http://schemas.microsoft.com/office/drawing/2014/main" id="{415374F5-471C-5A3F-8F8E-263403865E86}"/>
+                </a:ext>
+              </a:extLst>
+            </p:cNvPr>
+            <p:cNvSpPr/>
+            <p:nvPr/>
+          </p:nvSpPr>
+          <p:spPr>
+            <a:xfrm>
+              <a:off x="1313411" y="4613564"/>
+              <a:ext cx="1130531" cy="220569"/>
+            </a:xfrm>
+            <a:prstGeom prst="rect">
+              <a:avLst/>
+            </a:prstGeom>
+            <a:noFill/>
+            <a:ln>
+              <a:solidFill>
+                <a:srgbClr val="FF0000"/>
+              </a:solidFill>
+            </a:ln>
+          </p:spPr>
+          <p:style>
+            <a:lnRef idx="2">
+              <a:schemeClr val="accent1">
+                <a:shade val="15000"/>
+              </a:schemeClr>
+            </a:lnRef>
+            <a:fillRef idx="1">
+              <a:schemeClr val="accent1"/>
+            </a:fillRef>
+            <a:effectRef idx="0">
+              <a:schemeClr val="accent1"/>
+            </a:effectRef>
+            <a:fontRef idx="minor">
+              <a:schemeClr val="lt1"/>
+            </a:fontRef>
+          </p:style>
+          <p:txBody>
+            <a:bodyPr rtlCol="0" anchor="ctr"/>
+            <a:lstStyle/>
+            <a:p>
+              <a:pPr algn="ctr"/>
+              <a:endParaRPr lang="ko-KR" altLang="en-US"/>
+            </a:p>
+          </p:txBody>
+        </p:sp>
+      </p:grpSp>
+      <p:grpSp>
+        <p:nvGrpSpPr>
+          <p:cNvPr id="10" name="그룹 9">
+            <a:extLst>
+              <a:ext uri="{FF2B5EF4-FFF2-40B4-BE49-F238E27FC236}">
+                <a16:creationId xmlns:a16="http://schemas.microsoft.com/office/drawing/2014/main" id="{81DDF9D5-11EA-EAFF-82D2-EF0AF466A12E}"/>
+              </a:ext>
+            </a:extLst>
+          </p:cNvPr>
+          <p:cNvGrpSpPr/>
+          <p:nvPr/>
+        </p:nvGrpSpPr>
+        <p:grpSpPr>
+          <a:xfrm>
+            <a:off x="3832487" y="1928603"/>
+            <a:ext cx="4105848" cy="3000794"/>
+            <a:chOff x="3832487" y="1928603"/>
+            <a:chExt cx="4105848" cy="3000794"/>
+          </a:xfrm>
+        </p:grpSpPr>
+        <p:pic>
+          <p:nvPicPr>
+            <p:cNvPr id="4" name="그림 3">
+              <a:extLst>
+                <a:ext uri="{FF2B5EF4-FFF2-40B4-BE49-F238E27FC236}">
+                  <a16:creationId xmlns:a16="http://schemas.microsoft.com/office/drawing/2014/main" id="{9830F5EE-122C-A189-CD2C-71C54FA7EE03}"/>
+                </a:ext>
+              </a:extLst>
+            </p:cNvPr>
+            <p:cNvPicPr>
+              <a:picLocks noChangeAspect="1"/>
+            </p:cNvPicPr>
+            <p:nvPr/>
+          </p:nvPicPr>
+          <p:blipFill>
+            <a:blip r:embed="rId3"/>
+            <a:stretch>
+              <a:fillRect/>
+            </a:stretch>
+          </p:blipFill>
+          <p:spPr>
+            <a:xfrm>
+              <a:off x="3832487" y="1928603"/>
+              <a:ext cx="4105848" cy="3000794"/>
+            </a:xfrm>
+            <a:prstGeom prst="rect">
+              <a:avLst/>
+            </a:prstGeom>
+          </p:spPr>
+        </p:pic>
+        <p:sp>
+          <p:nvSpPr>
+            <p:cNvPr id="9" name="직사각형 8">
+              <a:extLst>
+                <a:ext uri="{FF2B5EF4-FFF2-40B4-BE49-F238E27FC236}">
+                  <a16:creationId xmlns:a16="http://schemas.microsoft.com/office/drawing/2014/main" id="{D64D4BA4-CAE9-6AFD-A024-0F77852A66A2}"/>
+                </a:ext>
+              </a:extLst>
+            </p:cNvPr>
+            <p:cNvSpPr/>
+            <p:nvPr/>
+          </p:nvSpPr>
+          <p:spPr>
+            <a:xfrm>
+              <a:off x="4364182" y="3823855"/>
+              <a:ext cx="2643447" cy="1105542"/>
+            </a:xfrm>
+            <a:prstGeom prst="rect">
+              <a:avLst/>
+            </a:prstGeom>
+            <a:noFill/>
+            <a:ln>
+              <a:solidFill>
+                <a:srgbClr val="FF0000"/>
+              </a:solidFill>
+            </a:ln>
+          </p:spPr>
+          <p:style>
+            <a:lnRef idx="2">
+              <a:schemeClr val="accent1">
+                <a:shade val="15000"/>
+              </a:schemeClr>
+            </a:lnRef>
+            <a:fillRef idx="1">
+              <a:schemeClr val="accent1"/>
+            </a:fillRef>
+            <a:effectRef idx="0">
+              <a:schemeClr val="accent1"/>
+            </a:effectRef>
+            <a:fontRef idx="minor">
+              <a:schemeClr val="lt1"/>
+            </a:fontRef>
+          </p:style>
+          <p:txBody>
+            <a:bodyPr rtlCol="0" anchor="ctr"/>
+            <a:lstStyle/>
+            <a:p>
+              <a:pPr algn="ctr"/>
+              <a:endParaRPr lang="ko-KR" altLang="en-US"/>
+            </a:p>
+          </p:txBody>
+        </p:sp>
+      </p:grpSp>
+    </p:spTree>
+    <p:extLst>
+      <p:ext uri="{BB962C8B-B14F-4D97-AF65-F5344CB8AC3E}">
+        <p14:creationId xmlns:p14="http://schemas.microsoft.com/office/powerpoint/2010/main" val="1446590106"/>
+      </p:ext>
+    </p:extLst>
+  </p:cSld>
+  <p:clrMapOvr>
+    <a:masterClrMapping/>
+  </p:clrMapOvr>
+</p:sld>
+</file>
+
+<file path=ppt/slides/slide15.xml><?xml version="1.0" encoding="utf-8"?>
+<p:sld xmlns:a="http://schemas.openxmlformats.org/drawingml/2006/main" xmlns:r="http://schemas.openxmlformats.org/officeDocument/2006/relationships" xmlns:p="http://schemas.openxmlformats.org/presentationml/2006/main">
+  <p:cSld>
+    <p:spTree>
+      <p:nvGrpSpPr>
+        <p:cNvPr id="1" name=""/>
+        <p:cNvGrpSpPr/>
+        <p:nvPr/>
+      </p:nvGrpSpPr>
+      <p:grpSpPr>
+        <a:xfrm>
+          <a:off x="0" y="0"/>
+          <a:ext cx="0" cy="0"/>
+          <a:chOff x="0" y="0"/>
+          <a:chExt cx="0" cy="0"/>
+        </a:xfrm>
+      </p:grpSpPr>
+      <p:sp>
+        <p:nvSpPr>
+          <p:cNvPr id="2" name="제목 1">
+            <a:extLst>
+              <a:ext uri="{FF2B5EF4-FFF2-40B4-BE49-F238E27FC236}">
+                <a16:creationId xmlns:a16="http://schemas.microsoft.com/office/drawing/2014/main" id="{C8303924-6C67-F6B3-383F-651A90389E7C}"/>
+              </a:ext>
+            </a:extLst>
+          </p:cNvPr>
+          <p:cNvSpPr>
+            <a:spLocks noGrp="1"/>
+          </p:cNvSpPr>
+          <p:nvPr>
+            <p:ph type="title"/>
+          </p:nvPr>
+        </p:nvSpPr>
+        <p:spPr/>
+        <p:txBody>
+          <a:bodyPr>
+            <a:normAutofit/>
+          </a:bodyPr>
+          <a:lstStyle/>
+          <a:p>
+            <a:r>
+              <a:rPr lang="en-US" altLang="ko-KR" sz="4000"/>
+              <a:t>ElasticSearch</a:t>
+            </a:r>
+            <a:r>
+              <a:rPr lang="ko-KR" altLang="en-US" sz="4000"/>
+              <a:t>의 </a:t>
+            </a:r>
+            <a:r>
+              <a:rPr lang="en-US" altLang="ko-KR" sz="4000"/>
+              <a:t>index - mapping</a:t>
+            </a:r>
+            <a:r>
+              <a:rPr lang="ko-KR" altLang="en-US" sz="4000"/>
+              <a:t> 작성</a:t>
+            </a:r>
+          </a:p>
+        </p:txBody>
+      </p:sp>
+      <p:grpSp>
+        <p:nvGrpSpPr>
+          <p:cNvPr id="6" name="그룹 5">
+            <a:extLst>
+              <a:ext uri="{FF2B5EF4-FFF2-40B4-BE49-F238E27FC236}">
+                <a16:creationId xmlns:a16="http://schemas.microsoft.com/office/drawing/2014/main" id="{6E5AE6B0-B354-7410-419C-89073A6498CA}"/>
+              </a:ext>
+            </a:extLst>
+          </p:cNvPr>
+          <p:cNvGrpSpPr/>
+          <p:nvPr/>
+        </p:nvGrpSpPr>
+        <p:grpSpPr>
+          <a:xfrm>
+            <a:off x="419703" y="1944654"/>
+            <a:ext cx="2524477" cy="2553056"/>
+            <a:chOff x="419703" y="1944654"/>
+            <a:chExt cx="2524477" cy="2553056"/>
+          </a:xfrm>
+        </p:grpSpPr>
+        <p:pic>
+          <p:nvPicPr>
+            <p:cNvPr id="4" name="그림 3">
+              <a:extLst>
+                <a:ext uri="{FF2B5EF4-FFF2-40B4-BE49-F238E27FC236}">
+                  <a16:creationId xmlns:a16="http://schemas.microsoft.com/office/drawing/2014/main" id="{F8738274-312A-00FA-C4A9-200F5EE0792A}"/>
+                </a:ext>
+              </a:extLst>
+            </p:cNvPr>
+            <p:cNvPicPr>
+              <a:picLocks noChangeAspect="1"/>
+            </p:cNvPicPr>
+            <p:nvPr/>
+          </p:nvPicPr>
+          <p:blipFill>
+            <a:blip r:embed="rId2"/>
+            <a:stretch>
+              <a:fillRect/>
+            </a:stretch>
+          </p:blipFill>
+          <p:spPr>
+            <a:xfrm>
+              <a:off x="419703" y="1944654"/>
+              <a:ext cx="2524477" cy="2553056"/>
+            </a:xfrm>
+            <a:prstGeom prst="rect">
+              <a:avLst/>
+            </a:prstGeom>
+          </p:spPr>
+        </p:pic>
+        <p:sp>
+          <p:nvSpPr>
+            <p:cNvPr id="5" name="직사각형 4">
+              <a:extLst>
+                <a:ext uri="{FF2B5EF4-FFF2-40B4-BE49-F238E27FC236}">
+                  <a16:creationId xmlns:a16="http://schemas.microsoft.com/office/drawing/2014/main" id="{88B977AD-065E-0D7F-E647-60779B56787C}"/>
+                </a:ext>
+              </a:extLst>
+            </p:cNvPr>
+            <p:cNvSpPr/>
+            <p:nvPr/>
+          </p:nvSpPr>
+          <p:spPr>
+            <a:xfrm>
+              <a:off x="847898" y="4239491"/>
+              <a:ext cx="1537855" cy="258219"/>
+            </a:xfrm>
+            <a:prstGeom prst="rect">
+              <a:avLst/>
+            </a:prstGeom>
+            <a:noFill/>
+            <a:ln>
+              <a:solidFill>
+                <a:srgbClr val="FF0000"/>
+              </a:solidFill>
+            </a:ln>
+          </p:spPr>
+          <p:style>
+            <a:lnRef idx="2">
+              <a:schemeClr val="accent1">
+                <a:shade val="15000"/>
+              </a:schemeClr>
+            </a:lnRef>
+            <a:fillRef idx="1">
+              <a:schemeClr val="accent1"/>
+            </a:fillRef>
+            <a:effectRef idx="0">
+              <a:schemeClr val="accent1"/>
+            </a:effectRef>
+            <a:fontRef idx="minor">
+              <a:schemeClr val="lt1"/>
+            </a:fontRef>
+          </p:style>
+          <p:txBody>
+            <a:bodyPr rtlCol="0" anchor="ctr"/>
+            <a:lstStyle/>
+            <a:p>
+              <a:pPr algn="ctr"/>
+              <a:endParaRPr lang="ko-KR" altLang="en-US"/>
+            </a:p>
+          </p:txBody>
+        </p:sp>
+      </p:grpSp>
+      <p:sp>
+        <p:nvSpPr>
+          <p:cNvPr id="12" name="TextBox 11">
+            <a:extLst>
+              <a:ext uri="{FF2B5EF4-FFF2-40B4-BE49-F238E27FC236}">
+                <a16:creationId xmlns:a16="http://schemas.microsoft.com/office/drawing/2014/main" id="{D2E7F680-23F4-7334-67B0-11B510DAE170}"/>
+              </a:ext>
+            </a:extLst>
+          </p:cNvPr>
+          <p:cNvSpPr txBox="1"/>
+          <p:nvPr/>
+        </p:nvSpPr>
+        <p:spPr>
+          <a:xfrm>
+            <a:off x="6907876" y="1730046"/>
+            <a:ext cx="4946073" cy="276999"/>
+          </a:xfrm>
+          <a:prstGeom prst="rect">
+            <a:avLst/>
+          </a:prstGeom>
+          <a:noFill/>
+        </p:spPr>
+        <p:txBody>
+          <a:bodyPr wrap="square" rtlCol="0">
+            <a:spAutoFit/>
+          </a:bodyPr>
+          <a:lstStyle/>
+          <a:p>
+            <a:r>
+              <a:rPr lang="en-US" altLang="ko-KR" sz="1200" b="1"/>
+              <a:t>※kibana</a:t>
+            </a:r>
+            <a:r>
+              <a:rPr lang="ko-KR" altLang="en-US" sz="1200" b="1"/>
+              <a:t>에 작성한 쿼리를 참고하여 작성한다</a:t>
+            </a:r>
+            <a:r>
+              <a:rPr lang="en-US" altLang="ko-KR" sz="1200" b="1"/>
+              <a:t>.</a:t>
+            </a:r>
+            <a:endParaRPr lang="ko-KR" altLang="en-US" sz="1200" b="1"/>
+          </a:p>
+        </p:txBody>
+      </p:sp>
+      <p:grpSp>
+        <p:nvGrpSpPr>
+          <p:cNvPr id="69" name="그룹 68">
+            <a:extLst>
+              <a:ext uri="{FF2B5EF4-FFF2-40B4-BE49-F238E27FC236}">
+                <a16:creationId xmlns:a16="http://schemas.microsoft.com/office/drawing/2014/main" id="{507EB598-E77B-C048-678C-8F4E4F769626}"/>
+              </a:ext>
+            </a:extLst>
+          </p:cNvPr>
+          <p:cNvGrpSpPr/>
+          <p:nvPr/>
+        </p:nvGrpSpPr>
+        <p:grpSpPr>
+          <a:xfrm>
+            <a:off x="3017520" y="1944654"/>
+            <a:ext cx="8395855" cy="4538963"/>
+            <a:chOff x="3017520" y="1944654"/>
+            <a:chExt cx="8395855" cy="4538963"/>
+          </a:xfrm>
+        </p:grpSpPr>
+        <p:grpSp>
+          <p:nvGrpSpPr>
+            <p:cNvPr id="66" name="그룹 65">
+              <a:extLst>
+                <a:ext uri="{FF2B5EF4-FFF2-40B4-BE49-F238E27FC236}">
+                  <a16:creationId xmlns:a16="http://schemas.microsoft.com/office/drawing/2014/main" id="{AFF2285A-4AFA-13A7-DE88-F06F97F8AC05}"/>
+                </a:ext>
+              </a:extLst>
+            </p:cNvPr>
+            <p:cNvGrpSpPr/>
+            <p:nvPr/>
+          </p:nvGrpSpPr>
+          <p:grpSpPr>
+            <a:xfrm>
+              <a:off x="3017520" y="1944654"/>
+              <a:ext cx="8395855" cy="4538963"/>
+              <a:chOff x="3017520" y="1944654"/>
+              <a:chExt cx="8395855" cy="4538963"/>
+            </a:xfrm>
+          </p:grpSpPr>
+          <p:grpSp>
+            <p:nvGrpSpPr>
+              <p:cNvPr id="59" name="그룹 58">
+                <a:extLst>
+                  <a:ext uri="{FF2B5EF4-FFF2-40B4-BE49-F238E27FC236}">
+                    <a16:creationId xmlns:a16="http://schemas.microsoft.com/office/drawing/2014/main" id="{71F52D0E-2244-DEB3-E644-01FAA8B982A4}"/>
+                  </a:ext>
+                </a:extLst>
+              </p:cNvPr>
+              <p:cNvGrpSpPr/>
+              <p:nvPr/>
+            </p:nvGrpSpPr>
+            <p:grpSpPr>
+              <a:xfrm>
+                <a:off x="3017520" y="1944654"/>
+                <a:ext cx="8395855" cy="4218992"/>
+                <a:chOff x="3042458" y="1944654"/>
+                <a:chExt cx="8395855" cy="4218992"/>
+              </a:xfrm>
+            </p:grpSpPr>
+            <p:cxnSp>
+              <p:nvCxnSpPr>
+                <p:cNvPr id="17" name="직선 화살표 연결선 16">
+                  <a:extLst>
+                    <a:ext uri="{FF2B5EF4-FFF2-40B4-BE49-F238E27FC236}">
+                      <a16:creationId xmlns:a16="http://schemas.microsoft.com/office/drawing/2014/main" id="{75315A19-C552-65A0-5E0D-8AC5A04ABADF}"/>
+                    </a:ext>
+                  </a:extLst>
+                </p:cNvPr>
+                <p:cNvCxnSpPr>
+                  <a:cxnSpLocks/>
+                  <a:stCxn id="15" idx="3"/>
+                  <a:endCxn id="14" idx="1"/>
+                </p:cNvCxnSpPr>
+                <p:nvPr/>
+              </p:nvCxnSpPr>
+              <p:spPr>
+                <a:xfrm>
+                  <a:off x="4954385" y="2040514"/>
+                  <a:ext cx="2010383" cy="9961"/>
+                </a:xfrm>
+                <a:prstGeom prst="straightConnector1">
+                  <a:avLst/>
+                </a:prstGeom>
+                <a:ln>
+                  <a:solidFill>
+                    <a:srgbClr val="FF0000"/>
+                  </a:solidFill>
+                  <a:tailEnd type="triangle"/>
+                </a:ln>
+              </p:spPr>
+              <p:style>
+                <a:lnRef idx="1">
+                  <a:schemeClr val="accent1"/>
+                </a:lnRef>
+                <a:fillRef idx="0">
+                  <a:schemeClr val="accent1"/>
+                </a:fillRef>
+                <a:effectRef idx="0">
+                  <a:schemeClr val="accent1"/>
+                </a:effectRef>
+                <a:fontRef idx="minor">
+                  <a:schemeClr val="tx1"/>
+                </a:fontRef>
+              </p:style>
+            </p:cxnSp>
+            <p:grpSp>
+              <p:nvGrpSpPr>
+                <p:cNvPr id="29" name="그룹 28">
+                  <a:extLst>
+                    <a:ext uri="{FF2B5EF4-FFF2-40B4-BE49-F238E27FC236}">
+                      <a16:creationId xmlns:a16="http://schemas.microsoft.com/office/drawing/2014/main" id="{8B6939E2-047D-ECFB-AF7F-119B651510F2}"/>
+                    </a:ext>
+                  </a:extLst>
+                </p:cNvPr>
+                <p:cNvGrpSpPr/>
+                <p:nvPr/>
+              </p:nvGrpSpPr>
+              <p:grpSpPr>
+                <a:xfrm>
+                  <a:off x="3042458" y="1944654"/>
+                  <a:ext cx="6106730" cy="4218992"/>
+                  <a:chOff x="3042458" y="1944654"/>
+                  <a:chExt cx="6106730" cy="4218992"/>
+                </a:xfrm>
+              </p:grpSpPr>
+              <p:grpSp>
+                <p:nvGrpSpPr>
+                  <p:cNvPr id="22" name="그룹 21">
+                    <a:extLst>
+                      <a:ext uri="{FF2B5EF4-FFF2-40B4-BE49-F238E27FC236}">
+                        <a16:creationId xmlns:a16="http://schemas.microsoft.com/office/drawing/2014/main" id="{4399F957-A73B-D34E-4FF8-F14B067C6563}"/>
+                      </a:ext>
+                    </a:extLst>
+                  </p:cNvPr>
+                  <p:cNvGrpSpPr/>
+                  <p:nvPr/>
+                </p:nvGrpSpPr>
+                <p:grpSpPr>
+                  <a:xfrm>
+                    <a:off x="3042458" y="1944654"/>
+                    <a:ext cx="5305223" cy="4218992"/>
+                    <a:chOff x="3042458" y="1944654"/>
+                    <a:chExt cx="5305223" cy="4218992"/>
+                  </a:xfrm>
+                </p:grpSpPr>
+                <p:grpSp>
+                  <p:nvGrpSpPr>
+                    <p:cNvPr id="10" name="그룹 9">
+                      <a:extLst>
+                        <a:ext uri="{FF2B5EF4-FFF2-40B4-BE49-F238E27FC236}">
+                          <a16:creationId xmlns:a16="http://schemas.microsoft.com/office/drawing/2014/main" id="{36C87B8F-526F-00BA-5B1B-A8D3DCCD1D56}"/>
+                        </a:ext>
+                      </a:extLst>
+                    </p:cNvPr>
+                    <p:cNvGrpSpPr/>
+                    <p:nvPr/>
+                  </p:nvGrpSpPr>
+                  <p:grpSpPr>
+                    <a:xfrm>
+                      <a:off x="3042458" y="1945331"/>
+                      <a:ext cx="3865418" cy="4218315"/>
+                      <a:chOff x="3042458" y="1945331"/>
+                      <a:chExt cx="3865418" cy="4218315"/>
+                    </a:xfrm>
+                  </p:grpSpPr>
+                  <p:pic>
+                    <p:nvPicPr>
+                      <p:cNvPr id="8" name="그림 7">
+                        <a:extLst>
+                          <a:ext uri="{FF2B5EF4-FFF2-40B4-BE49-F238E27FC236}">
+                            <a16:creationId xmlns:a16="http://schemas.microsoft.com/office/drawing/2014/main" id="{A98F9FFE-2C0D-8BA0-D772-E7C024A23C40}"/>
+                          </a:ext>
+                        </a:extLst>
+                      </p:cNvPr>
+                      <p:cNvPicPr>
+                        <a:picLocks noChangeAspect="1"/>
+                      </p:cNvPicPr>
+                      <p:nvPr/>
+                    </p:nvPicPr>
+                    <p:blipFill>
+                      <a:blip r:embed="rId3"/>
+                      <a:stretch>
+                        <a:fillRect/>
+                      </a:stretch>
+                    </p:blipFill>
+                    <p:spPr>
+                      <a:xfrm>
+                        <a:off x="3042812" y="1945331"/>
+                        <a:ext cx="3823324" cy="3906829"/>
+                      </a:xfrm>
+                      <a:prstGeom prst="rect">
+                        <a:avLst/>
+                      </a:prstGeom>
+                    </p:spPr>
+                  </p:pic>
+                  <p:sp>
+                    <p:nvSpPr>
+                      <p:cNvPr id="9" name="TextBox 8">
+                        <a:extLst>
+                          <a:ext uri="{FF2B5EF4-FFF2-40B4-BE49-F238E27FC236}">
+                            <a16:creationId xmlns:a16="http://schemas.microsoft.com/office/drawing/2014/main" id="{6AEBF312-A47E-79F0-F689-0D8E0DDEB68D}"/>
+                          </a:ext>
+                        </a:extLst>
+                      </p:cNvPr>
+                      <p:cNvSpPr txBox="1"/>
+                      <p:nvPr/>
+                    </p:nvSpPr>
+                    <p:spPr>
+                      <a:xfrm>
+                        <a:off x="3042458" y="5902036"/>
+                        <a:ext cx="3865418" cy="261610"/>
+                      </a:xfrm>
+                      <a:prstGeom prst="rect">
+                        <a:avLst/>
+                      </a:prstGeom>
+                      <a:noFill/>
+                    </p:spPr>
+                    <p:txBody>
+                      <a:bodyPr wrap="square" rtlCol="0">
+                        <a:spAutoFit/>
+                      </a:bodyPr>
+                      <a:lstStyle/>
+                      <a:p>
+                        <a:r>
+                          <a:rPr lang="en-US" altLang="ko-KR" sz="1100"/>
+                          <a:t>45</a:t>
+                        </a:r>
+                        <a:r>
+                          <a:rPr lang="ko-KR" altLang="en-US" sz="1100"/>
+                          <a:t>라인 이후</a:t>
+                        </a:r>
+                        <a:r>
+                          <a:rPr lang="en-US" altLang="ko-KR" sz="1100"/>
+                          <a:t>. getter</a:t>
+                        </a:r>
+                        <a:r>
+                          <a:rPr lang="ko-KR" altLang="en-US" sz="1100"/>
+                          <a:t>와 </a:t>
+                        </a:r>
+                        <a:r>
+                          <a:rPr lang="en-US" altLang="ko-KR" sz="1100"/>
+                          <a:t>setter </a:t>
+                        </a:r>
+                        <a:r>
+                          <a:rPr lang="ko-KR" altLang="en-US" sz="1100"/>
+                          <a:t>추가</a:t>
+                        </a:r>
+                      </a:p>
+                    </p:txBody>
+                  </p:sp>
+                </p:grpSp>
+                <p:pic>
+                  <p:nvPicPr>
+                    <p:cNvPr id="14" name="그림 13">
+                      <a:extLst>
+                        <a:ext uri="{FF2B5EF4-FFF2-40B4-BE49-F238E27FC236}">
+                          <a16:creationId xmlns:a16="http://schemas.microsoft.com/office/drawing/2014/main" id="{59E566F5-CDD8-5CB4-249D-58FFC6A2B50C}"/>
+                        </a:ext>
+                      </a:extLst>
+                    </p:cNvPr>
+                    <p:cNvPicPr>
+                      <a:picLocks noChangeAspect="1"/>
+                    </p:cNvPicPr>
+                    <p:nvPr/>
+                  </p:nvPicPr>
+                  <p:blipFill>
+                    <a:blip r:embed="rId4"/>
+                    <a:stretch>
+                      <a:fillRect/>
+                    </a:stretch>
+                  </p:blipFill>
+                  <p:spPr>
+                    <a:xfrm>
+                      <a:off x="6964768" y="1944654"/>
+                      <a:ext cx="1382913" cy="211641"/>
+                    </a:xfrm>
+                    <a:prstGeom prst="rect">
+                      <a:avLst/>
+                    </a:prstGeom>
+                    <a:ln>
+                      <a:solidFill>
+                        <a:srgbClr val="FF0000"/>
+                      </a:solidFill>
+                    </a:ln>
+                  </p:spPr>
+                </p:pic>
+                <p:sp>
+                  <p:nvSpPr>
+                    <p:cNvPr id="15" name="직사각형 14">
+                      <a:extLst>
+                        <a:ext uri="{FF2B5EF4-FFF2-40B4-BE49-F238E27FC236}">
+                          <a16:creationId xmlns:a16="http://schemas.microsoft.com/office/drawing/2014/main" id="{D7BB102B-82F4-C89A-8544-C4CD0DCA79BF}"/>
+                        </a:ext>
+                      </a:extLst>
+                    </p:cNvPr>
+                    <p:cNvSpPr/>
+                    <p:nvPr/>
+                  </p:nvSpPr>
+                  <p:spPr>
+                    <a:xfrm>
+                      <a:off x="3250276" y="1977906"/>
+                      <a:ext cx="1704109" cy="125215"/>
+                    </a:xfrm>
+                    <a:prstGeom prst="rect">
+                      <a:avLst/>
+                    </a:prstGeom>
+                    <a:noFill/>
+                    <a:ln>
+                      <a:solidFill>
+                        <a:srgbClr val="FF0000"/>
+                      </a:solidFill>
+                    </a:ln>
+                  </p:spPr>
+                  <p:style>
+                    <a:lnRef idx="2">
+                      <a:schemeClr val="accent1">
+                        <a:shade val="15000"/>
+                      </a:schemeClr>
+                    </a:lnRef>
+                    <a:fillRef idx="1">
+                      <a:schemeClr val="accent1"/>
+                    </a:fillRef>
+                    <a:effectRef idx="0">
+                      <a:schemeClr val="accent1"/>
+                    </a:effectRef>
+                    <a:fontRef idx="minor">
+                      <a:schemeClr val="lt1"/>
+                    </a:fontRef>
+                  </p:style>
+                  <p:txBody>
+                    <a:bodyPr rtlCol="0" anchor="ctr"/>
+                    <a:lstStyle/>
+                    <a:p>
+                      <a:pPr algn="ctr"/>
+                      <a:endParaRPr lang="ko-KR" altLang="en-US"/>
+                    </a:p>
+                  </p:txBody>
+                </p:sp>
+              </p:grpSp>
+              <p:sp>
+                <p:nvSpPr>
+                  <p:cNvPr id="25" name="직사각형 24">
+                    <a:extLst>
+                      <a:ext uri="{FF2B5EF4-FFF2-40B4-BE49-F238E27FC236}">
+                        <a16:creationId xmlns:a16="http://schemas.microsoft.com/office/drawing/2014/main" id="{77967B8C-B1D2-0D8A-B03E-8F72E8FAE738}"/>
+                      </a:ext>
+                    </a:extLst>
+                  </p:cNvPr>
+                  <p:cNvSpPr/>
+                  <p:nvPr/>
+                </p:nvSpPr>
+                <p:spPr>
+                  <a:xfrm>
+                    <a:off x="3241963" y="2092039"/>
+                    <a:ext cx="2984269" cy="125216"/>
+                  </a:xfrm>
+                  <a:prstGeom prst="rect">
+                    <a:avLst/>
+                  </a:prstGeom>
+                  <a:noFill/>
+                  <a:ln>
+                    <a:solidFill>
+                      <a:srgbClr val="00B0F0"/>
+                    </a:solidFill>
+                  </a:ln>
+                </p:spPr>
+                <p:style>
+                  <a:lnRef idx="2">
+                    <a:schemeClr val="accent1">
+                      <a:shade val="15000"/>
+                    </a:schemeClr>
+                  </a:lnRef>
+                  <a:fillRef idx="1">
+                    <a:schemeClr val="accent1"/>
+                  </a:fillRef>
+                  <a:effectRef idx="0">
+                    <a:schemeClr val="accent1"/>
+                  </a:effectRef>
+                  <a:fontRef idx="minor">
+                    <a:schemeClr val="lt1"/>
+                  </a:fontRef>
+                </p:style>
+                <p:txBody>
+                  <a:bodyPr rtlCol="0" anchor="ctr"/>
+                  <a:lstStyle/>
+                  <a:p>
+                    <a:pPr algn="ctr"/>
+                    <a:endParaRPr lang="ko-KR" altLang="en-US"/>
+                  </a:p>
+                </p:txBody>
+              </p:sp>
+              <p:cxnSp>
+                <p:nvCxnSpPr>
+                  <p:cNvPr id="27" name="직선 화살표 연결선 26">
+                    <a:extLst>
+                      <a:ext uri="{FF2B5EF4-FFF2-40B4-BE49-F238E27FC236}">
+                        <a16:creationId xmlns:a16="http://schemas.microsoft.com/office/drawing/2014/main" id="{BA0ECD28-6D29-8B2F-3F25-C23886AA5FC5}"/>
+                      </a:ext>
+                    </a:extLst>
+                  </p:cNvPr>
+                  <p:cNvCxnSpPr>
+                    <a:cxnSpLocks/>
+                    <a:stCxn id="25" idx="3"/>
+                  </p:cNvCxnSpPr>
+                  <p:nvPr/>
+                </p:nvCxnSpPr>
+                <p:spPr>
+                  <a:xfrm>
+                    <a:off x="6226232" y="2154647"/>
+                    <a:ext cx="814648" cy="95486"/>
+                  </a:xfrm>
+                  <a:prstGeom prst="straightConnector1">
+                    <a:avLst/>
+                  </a:prstGeom>
+                  <a:ln>
+                    <a:solidFill>
+                      <a:srgbClr val="00B0F0"/>
+                    </a:solidFill>
+                    <a:tailEnd type="triangle"/>
+                  </a:ln>
+                </p:spPr>
+                <p:style>
+                  <a:lnRef idx="1">
+                    <a:schemeClr val="accent1"/>
+                  </a:lnRef>
+                  <a:fillRef idx="0">
+                    <a:schemeClr val="accent1"/>
+                  </a:fillRef>
+                  <a:effectRef idx="0">
+                    <a:schemeClr val="accent1"/>
+                  </a:effectRef>
+                  <a:fontRef idx="minor">
+                    <a:schemeClr val="tx1"/>
+                  </a:fontRef>
+                </p:style>
+              </p:cxnSp>
+              <p:sp>
+                <p:nvSpPr>
+                  <p:cNvPr id="28" name="TextBox 27">
+                    <a:extLst>
+                      <a:ext uri="{FF2B5EF4-FFF2-40B4-BE49-F238E27FC236}">
+                        <a16:creationId xmlns:a16="http://schemas.microsoft.com/office/drawing/2014/main" id="{222A825D-801E-DF32-A7DF-CA61B9CD8D4C}"/>
+                      </a:ext>
+                    </a:extLst>
+                  </p:cNvPr>
+                  <p:cNvSpPr txBox="1"/>
+                  <p:nvPr/>
+                </p:nvSpPr>
+                <p:spPr>
+                  <a:xfrm>
+                    <a:off x="7057505" y="2156295"/>
+                    <a:ext cx="2091683" cy="230832"/>
+                  </a:xfrm>
+                  <a:prstGeom prst="rect">
+                    <a:avLst/>
+                  </a:prstGeom>
+                  <a:noFill/>
+                  <a:ln>
+                    <a:solidFill>
+                      <a:srgbClr val="00B0F0"/>
+                    </a:solidFill>
+                  </a:ln>
+                </p:spPr>
+                <p:txBody>
+                  <a:bodyPr wrap="square" rtlCol="0">
+                    <a:spAutoFit/>
+                  </a:bodyPr>
+                  <a:lstStyle/>
+                  <a:p>
+                    <a:r>
+                      <a:rPr lang="ko-KR" altLang="en-US" sz="900"/>
+                      <a:t>인덱스 </a:t>
+                    </a:r>
+                    <a:r>
+                      <a:rPr lang="en-US" altLang="ko-KR" sz="900"/>
+                      <a:t>setting </a:t>
+                    </a:r>
+                    <a:r>
+                      <a:rPr lang="ko-KR" altLang="en-US" sz="900"/>
+                      <a:t>정보가 정의되어있음</a:t>
+                    </a:r>
+                  </a:p>
+                </p:txBody>
+              </p:sp>
+            </p:grpSp>
+            <p:grpSp>
+              <p:nvGrpSpPr>
+                <p:cNvPr id="47" name="그룹 46">
+                  <a:extLst>
+                    <a:ext uri="{FF2B5EF4-FFF2-40B4-BE49-F238E27FC236}">
+                      <a16:creationId xmlns:a16="http://schemas.microsoft.com/office/drawing/2014/main" id="{D0037DDA-446B-113D-51CB-D3C13E06A3FD}"/>
+                    </a:ext>
+                  </a:extLst>
+                </p:cNvPr>
+                <p:cNvGrpSpPr/>
+                <p:nvPr/>
+              </p:nvGrpSpPr>
+              <p:grpSpPr>
+                <a:xfrm>
+                  <a:off x="3462251" y="2250355"/>
+                  <a:ext cx="3295996" cy="415498"/>
+                  <a:chOff x="3462251" y="2250355"/>
+                  <a:chExt cx="3295996" cy="415498"/>
+                </a:xfrm>
+              </p:grpSpPr>
+              <p:sp>
+                <p:nvSpPr>
+                  <p:cNvPr id="31" name="직사각형 30">
+                    <a:extLst>
+                      <a:ext uri="{FF2B5EF4-FFF2-40B4-BE49-F238E27FC236}">
+                        <a16:creationId xmlns:a16="http://schemas.microsoft.com/office/drawing/2014/main" id="{BDBC8084-FB96-FCE9-CD2A-C49B5CC78BEA}"/>
+                      </a:ext>
+                    </a:extLst>
+                  </p:cNvPr>
+                  <p:cNvSpPr/>
+                  <p:nvPr/>
+                </p:nvSpPr>
+                <p:spPr>
+                  <a:xfrm>
+                    <a:off x="3462251" y="2311092"/>
+                    <a:ext cx="951808" cy="274166"/>
+                  </a:xfrm>
+                  <a:prstGeom prst="rect">
+                    <a:avLst/>
+                  </a:prstGeom>
+                  <a:noFill/>
+                  <a:ln>
+                    <a:solidFill>
+                      <a:srgbClr val="FFC000"/>
+                    </a:solidFill>
+                  </a:ln>
+                </p:spPr>
+                <p:style>
+                  <a:lnRef idx="2">
+                    <a:schemeClr val="accent1">
+                      <a:shade val="15000"/>
+                    </a:schemeClr>
+                  </a:lnRef>
+                  <a:fillRef idx="1">
+                    <a:schemeClr val="accent1"/>
+                  </a:fillRef>
+                  <a:effectRef idx="0">
+                    <a:schemeClr val="accent1"/>
+                  </a:effectRef>
+                  <a:fontRef idx="minor">
+                    <a:schemeClr val="lt1"/>
+                  </a:fontRef>
+                </p:style>
+                <p:txBody>
+                  <a:bodyPr rtlCol="0" anchor="ctr"/>
+                  <a:lstStyle/>
+                  <a:p>
+                    <a:pPr algn="ctr"/>
+                    <a:endParaRPr lang="ko-KR" altLang="en-US"/>
+                  </a:p>
+                </p:txBody>
+              </p:sp>
+              <p:cxnSp>
+                <p:nvCxnSpPr>
+                  <p:cNvPr id="33" name="직선 화살표 연결선 32">
+                    <a:extLst>
+                      <a:ext uri="{FF2B5EF4-FFF2-40B4-BE49-F238E27FC236}">
+                        <a16:creationId xmlns:a16="http://schemas.microsoft.com/office/drawing/2014/main" id="{CABD77A8-8C13-D0FA-89ED-5CBBB44E2D4D}"/>
+                      </a:ext>
+                    </a:extLst>
+                  </p:cNvPr>
+                  <p:cNvCxnSpPr>
+                    <a:cxnSpLocks/>
+                    <a:stCxn id="31" idx="3"/>
+                    <a:endCxn id="36" idx="1"/>
+                  </p:cNvCxnSpPr>
+                  <p:nvPr/>
+                </p:nvCxnSpPr>
+                <p:spPr>
+                  <a:xfrm>
+                    <a:off x="4414059" y="2448175"/>
+                    <a:ext cx="419439" cy="9929"/>
+                  </a:xfrm>
+                  <a:prstGeom prst="straightConnector1">
+                    <a:avLst/>
+                  </a:prstGeom>
+                  <a:ln>
+                    <a:solidFill>
+                      <a:srgbClr val="FFC000"/>
+                    </a:solidFill>
+                    <a:tailEnd type="triangle"/>
+                  </a:ln>
+                </p:spPr>
+                <p:style>
+                  <a:lnRef idx="1">
+                    <a:schemeClr val="accent1"/>
+                  </a:lnRef>
+                  <a:fillRef idx="0">
+                    <a:schemeClr val="accent1"/>
+                  </a:fillRef>
+                  <a:effectRef idx="0">
+                    <a:schemeClr val="accent1"/>
+                  </a:effectRef>
+                  <a:fontRef idx="minor">
+                    <a:schemeClr val="tx1"/>
+                  </a:fontRef>
+                </p:style>
+              </p:cxnSp>
+              <p:sp>
+                <p:nvSpPr>
+                  <p:cNvPr id="36" name="TextBox 35">
+                    <a:extLst>
+                      <a:ext uri="{FF2B5EF4-FFF2-40B4-BE49-F238E27FC236}">
+                        <a16:creationId xmlns:a16="http://schemas.microsoft.com/office/drawing/2014/main" id="{E83B5703-4E97-60AD-2434-54D6FF368200}"/>
+                      </a:ext>
+                    </a:extLst>
+                  </p:cNvPr>
+                  <p:cNvSpPr txBox="1"/>
+                  <p:nvPr/>
+                </p:nvSpPr>
+                <p:spPr>
+                  <a:xfrm>
+                    <a:off x="4833498" y="2250355"/>
+                    <a:ext cx="1924749" cy="415498"/>
+                  </a:xfrm>
+                  <a:prstGeom prst="rect">
+                    <a:avLst/>
+                  </a:prstGeom>
+                  <a:noFill/>
+                  <a:ln>
+                    <a:solidFill>
+                      <a:srgbClr val="FFC000"/>
+                    </a:solidFill>
+                  </a:ln>
+                </p:spPr>
+                <p:txBody>
+                  <a:bodyPr wrap="square" rtlCol="0">
+                    <a:spAutoFit/>
+                  </a:bodyPr>
+                  <a:lstStyle/>
+                  <a:p>
+                    <a:r>
+                      <a:rPr lang="en-US" altLang="ko-KR" sz="1000">
+                        <a:solidFill>
+                          <a:srgbClr val="FFFF00"/>
+                        </a:solidFill>
+                      </a:rPr>
+                      <a:t>ElasticSearch</a:t>
+                    </a:r>
+                    <a:r>
+                      <a:rPr lang="ko-KR" altLang="en-US" sz="1000">
+                        <a:solidFill>
+                          <a:srgbClr val="FFFF00"/>
+                        </a:solidFill>
+                      </a:rPr>
+                      <a:t>에서 </a:t>
+                    </a:r>
+                    <a:r>
+                      <a:rPr lang="en-US" altLang="ko-KR" sz="1000">
+                        <a:solidFill>
+                          <a:srgbClr val="FFFF00"/>
+                        </a:solidFill>
+                      </a:rPr>
+                      <a:t>ID </a:t>
+                    </a:r>
+                    <a:r>
+                      <a:rPr lang="ko-KR" altLang="en-US" sz="1000">
+                        <a:solidFill>
+                          <a:srgbClr val="FFFF00"/>
+                        </a:solidFill>
+                      </a:rPr>
+                      <a:t>값은 기본적으로 문자열로 만들어짐</a:t>
+                    </a:r>
+                  </a:p>
+                </p:txBody>
+              </p:sp>
+            </p:grpSp>
+            <p:grpSp>
+              <p:nvGrpSpPr>
+                <p:cNvPr id="46" name="그룹 45">
+                  <a:extLst>
+                    <a:ext uri="{FF2B5EF4-FFF2-40B4-BE49-F238E27FC236}">
+                      <a16:creationId xmlns:a16="http://schemas.microsoft.com/office/drawing/2014/main" id="{AE4724E4-C6F4-5ADD-06C3-84C7AB4FCFE6}"/>
+                    </a:ext>
+                  </a:extLst>
+                </p:cNvPr>
+                <p:cNvGrpSpPr/>
+                <p:nvPr/>
+              </p:nvGrpSpPr>
+              <p:grpSpPr>
+                <a:xfrm>
+                  <a:off x="3462251" y="2665853"/>
+                  <a:ext cx="7976062" cy="1070025"/>
+                  <a:chOff x="3462251" y="2665853"/>
+                  <a:chExt cx="7976062" cy="1070025"/>
+                </a:xfrm>
+              </p:grpSpPr>
+              <p:sp>
+                <p:nvSpPr>
+                  <p:cNvPr id="42" name="직사각형 41">
+                    <a:extLst>
+                      <a:ext uri="{FF2B5EF4-FFF2-40B4-BE49-F238E27FC236}">
+                        <a16:creationId xmlns:a16="http://schemas.microsoft.com/office/drawing/2014/main" id="{27B023A9-D044-E97A-CD6D-7D9D447734F1}"/>
+                      </a:ext>
+                    </a:extLst>
+                  </p:cNvPr>
+                  <p:cNvSpPr/>
+                  <p:nvPr/>
+                </p:nvSpPr>
+                <p:spPr>
+                  <a:xfrm>
+                    <a:off x="3462251" y="2665853"/>
+                    <a:ext cx="2880360" cy="1070025"/>
+                  </a:xfrm>
+                  <a:prstGeom prst="rect">
+                    <a:avLst/>
+                  </a:prstGeom>
+                  <a:noFill/>
+                  <a:ln>
+                    <a:solidFill>
+                      <a:srgbClr val="92D050"/>
+                    </a:solidFill>
+                  </a:ln>
+                </p:spPr>
+                <p:style>
+                  <a:lnRef idx="2">
+                    <a:schemeClr val="accent1">
+                      <a:shade val="15000"/>
+                    </a:schemeClr>
+                  </a:lnRef>
+                  <a:fillRef idx="1">
+                    <a:schemeClr val="accent1"/>
+                  </a:fillRef>
+                  <a:effectRef idx="0">
+                    <a:schemeClr val="accent1"/>
+                  </a:effectRef>
+                  <a:fontRef idx="minor">
+                    <a:schemeClr val="lt1"/>
+                  </a:fontRef>
+                </p:style>
+                <p:txBody>
+                  <a:bodyPr rtlCol="0" anchor="ctr"/>
+                  <a:lstStyle/>
+                  <a:p>
+                    <a:pPr algn="ctr"/>
+                    <a:endParaRPr lang="ko-KR" altLang="en-US"/>
+                  </a:p>
+                </p:txBody>
+              </p:sp>
+              <p:cxnSp>
+                <p:nvCxnSpPr>
+                  <p:cNvPr id="44" name="직선 화살표 연결선 43">
+                    <a:extLst>
+                      <a:ext uri="{FF2B5EF4-FFF2-40B4-BE49-F238E27FC236}">
+                        <a16:creationId xmlns:a16="http://schemas.microsoft.com/office/drawing/2014/main" id="{7B5AAED0-8D1F-AEA3-0272-819C30809225}"/>
+                      </a:ext>
+                    </a:extLst>
+                  </p:cNvPr>
+                  <p:cNvCxnSpPr>
+                    <a:cxnSpLocks/>
+                    <a:stCxn id="42" idx="3"/>
+                  </p:cNvCxnSpPr>
+                  <p:nvPr/>
+                </p:nvCxnSpPr>
+                <p:spPr>
+                  <a:xfrm flipV="1">
+                    <a:off x="6342611" y="2959331"/>
+                    <a:ext cx="714894" cy="241535"/>
+                  </a:xfrm>
+                  <a:prstGeom prst="straightConnector1">
+                    <a:avLst/>
+                  </a:prstGeom>
+                  <a:ln>
+                    <a:solidFill>
+                      <a:srgbClr val="92D050"/>
+                    </a:solidFill>
+                    <a:tailEnd type="triangle"/>
+                  </a:ln>
+                </p:spPr>
+                <p:style>
+                  <a:lnRef idx="1">
+                    <a:schemeClr val="accent1"/>
+                  </a:lnRef>
+                  <a:fillRef idx="0">
+                    <a:schemeClr val="accent1"/>
+                  </a:fillRef>
+                  <a:effectRef idx="0">
+                    <a:schemeClr val="accent1"/>
+                  </a:effectRef>
+                  <a:fontRef idx="minor">
+                    <a:schemeClr val="tx1"/>
+                  </a:fontRef>
+                </p:style>
+              </p:cxnSp>
+              <p:sp>
+                <p:nvSpPr>
+                  <p:cNvPr id="45" name="TextBox 44">
+                    <a:extLst>
+                      <a:ext uri="{FF2B5EF4-FFF2-40B4-BE49-F238E27FC236}">
+                        <a16:creationId xmlns:a16="http://schemas.microsoft.com/office/drawing/2014/main" id="{9E044316-E84F-A745-A7D1-00D4BA268A59}"/>
+                      </a:ext>
+                    </a:extLst>
+                  </p:cNvPr>
+                  <p:cNvSpPr txBox="1"/>
+                  <p:nvPr/>
+                </p:nvSpPr>
+                <p:spPr>
+                  <a:xfrm>
+                    <a:off x="7057505" y="2836220"/>
+                    <a:ext cx="4380808" cy="553998"/>
+                  </a:xfrm>
+                  <a:prstGeom prst="rect">
+                    <a:avLst/>
+                  </a:prstGeom>
+                  <a:noFill/>
+                  <a:ln>
+                    <a:solidFill>
+                      <a:srgbClr val="92D050"/>
+                    </a:solidFill>
+                  </a:ln>
+                </p:spPr>
+                <p:txBody>
+                  <a:bodyPr wrap="square" rtlCol="0">
+                    <a:spAutoFit/>
+                  </a:bodyPr>
+                  <a:lstStyle/>
+                  <a:p>
+                    <a:r>
+                      <a:rPr lang="ko-KR" altLang="en-US" sz="1000"/>
+                      <a:t>복수개의 자료형을 가질경우 </a:t>
+                    </a:r>
+                    <a:r>
+                      <a:rPr lang="en-US" altLang="ko-KR" sz="1000"/>
+                      <a:t>@MultiField</a:t>
+                    </a:r>
+                    <a:r>
+                      <a:rPr lang="ko-KR" altLang="en-US" sz="1000"/>
+                      <a:t>를 사용한다</a:t>
+                    </a:r>
+                    <a:r>
+                      <a:rPr lang="en-US" altLang="ko-KR" sz="1000"/>
+                      <a:t>.</a:t>
+                    </a:r>
+                  </a:p>
+                  <a:p>
+                    <a:r>
+                      <a:rPr lang="en-US" altLang="ko-KR" sz="1000"/>
+                      <a:t>@MultiField </a:t>
+                    </a:r>
+                    <a:r>
+                      <a:rPr lang="ko-KR" altLang="en-US" sz="1000"/>
+                      <a:t>애노테이션은 </a:t>
+                    </a:r>
+                    <a:r>
+                      <a:rPr lang="en-US" altLang="ko-KR" sz="1000"/>
+                      <a:t>mainField </a:t>
+                    </a:r>
+                    <a:r>
+                      <a:rPr lang="ko-KR" altLang="en-US" sz="1000"/>
+                      <a:t>속성을 통해 </a:t>
+                    </a:r>
+                    <a:br>
+                      <a:rPr lang="en-US" altLang="ko-KR" sz="1000"/>
+                    </a:br>
+                    <a:r>
+                      <a:rPr lang="ko-KR" altLang="en-US" sz="1000"/>
+                      <a:t>메인 자료형을 지정하며</a:t>
+                    </a:r>
+                    <a:r>
+                      <a:rPr lang="en-US" altLang="ko-KR" sz="1000"/>
+                      <a:t>, otherField </a:t>
+                    </a:r>
+                    <a:r>
+                      <a:rPr lang="ko-KR" altLang="en-US" sz="1000"/>
+                      <a:t>속성을 통해 다른 자료형을 설정한다</a:t>
+                    </a:r>
+                    <a:r>
+                      <a:rPr lang="en-US" altLang="ko-KR" sz="1000"/>
+                      <a:t>.</a:t>
+                    </a:r>
+                    <a:endParaRPr lang="ko-KR" altLang="en-US" sz="1000"/>
+                  </a:p>
+                </p:txBody>
+              </p:sp>
+            </p:grpSp>
+            <p:grpSp>
+              <p:nvGrpSpPr>
+                <p:cNvPr id="58" name="그룹 57">
+                  <a:extLst>
+                    <a:ext uri="{FF2B5EF4-FFF2-40B4-BE49-F238E27FC236}">
+                      <a16:creationId xmlns:a16="http://schemas.microsoft.com/office/drawing/2014/main" id="{A9B23AED-C601-3399-3F25-399E972CB223}"/>
+                    </a:ext>
+                  </a:extLst>
+                </p:cNvPr>
+                <p:cNvGrpSpPr/>
+                <p:nvPr/>
+              </p:nvGrpSpPr>
+              <p:grpSpPr>
+                <a:xfrm>
+                  <a:off x="3462251" y="4779818"/>
+                  <a:ext cx="3798386" cy="1070025"/>
+                  <a:chOff x="3462251" y="4779818"/>
+                  <a:chExt cx="3798386" cy="1070025"/>
+                </a:xfrm>
+              </p:grpSpPr>
+              <p:sp>
+                <p:nvSpPr>
+                  <p:cNvPr id="55" name="직사각형 54">
+                    <a:extLst>
+                      <a:ext uri="{FF2B5EF4-FFF2-40B4-BE49-F238E27FC236}">
+                        <a16:creationId xmlns:a16="http://schemas.microsoft.com/office/drawing/2014/main" id="{4F2C15A4-B8E6-D1F8-E4A2-3E5F1E5E169A}"/>
+                      </a:ext>
+                    </a:extLst>
+                  </p:cNvPr>
+                  <p:cNvSpPr/>
+                  <p:nvPr/>
+                </p:nvSpPr>
+                <p:spPr>
+                  <a:xfrm>
+                    <a:off x="3462251" y="4779818"/>
+                    <a:ext cx="2880360" cy="1070025"/>
+                  </a:xfrm>
+                  <a:prstGeom prst="rect">
+                    <a:avLst/>
+                  </a:prstGeom>
+                  <a:noFill/>
+                  <a:ln>
+                    <a:solidFill>
+                      <a:srgbClr val="7030A0"/>
+                    </a:solidFill>
+                  </a:ln>
+                </p:spPr>
+                <p:style>
+                  <a:lnRef idx="2">
+                    <a:schemeClr val="accent1">
+                      <a:shade val="15000"/>
+                    </a:schemeClr>
+                  </a:lnRef>
+                  <a:fillRef idx="1">
+                    <a:schemeClr val="accent1"/>
+                  </a:fillRef>
+                  <a:effectRef idx="0">
+                    <a:schemeClr val="accent1"/>
+                  </a:effectRef>
+                  <a:fontRef idx="minor">
+                    <a:schemeClr val="lt1"/>
+                  </a:fontRef>
+                </p:style>
+                <p:txBody>
+                  <a:bodyPr rtlCol="0" anchor="ctr"/>
+                  <a:lstStyle/>
+                  <a:p>
+                    <a:pPr algn="ctr"/>
+                    <a:endParaRPr lang="ko-KR" altLang="en-US"/>
+                  </a:p>
+                </p:txBody>
+              </p:sp>
+              <p:cxnSp>
+                <p:nvCxnSpPr>
+                  <p:cNvPr id="57" name="직선 화살표 연결선 56">
+                    <a:extLst>
+                      <a:ext uri="{FF2B5EF4-FFF2-40B4-BE49-F238E27FC236}">
+                        <a16:creationId xmlns:a16="http://schemas.microsoft.com/office/drawing/2014/main" id="{6C00C795-D77C-8512-705F-DE189D95C07F}"/>
+                      </a:ext>
+                    </a:extLst>
+                  </p:cNvPr>
+                  <p:cNvCxnSpPr>
+                    <a:cxnSpLocks/>
+                    <a:stCxn id="55" idx="3"/>
+                    <a:endCxn id="62" idx="1"/>
+                  </p:cNvCxnSpPr>
+                  <p:nvPr/>
+                </p:nvCxnSpPr>
+                <p:spPr>
+                  <a:xfrm>
+                    <a:off x="6342611" y="5314831"/>
+                    <a:ext cx="918026" cy="462359"/>
+                  </a:xfrm>
+                  <a:prstGeom prst="straightConnector1">
+                    <a:avLst/>
+                  </a:prstGeom>
+                  <a:ln>
+                    <a:solidFill>
+                      <a:srgbClr val="7030A0"/>
+                    </a:solidFill>
+                    <a:tailEnd type="triangle"/>
+                  </a:ln>
+                </p:spPr>
+                <p:style>
+                  <a:lnRef idx="1">
+                    <a:schemeClr val="accent1"/>
+                  </a:lnRef>
+                  <a:fillRef idx="0">
+                    <a:schemeClr val="accent1"/>
+                  </a:fillRef>
+                  <a:effectRef idx="0">
+                    <a:schemeClr val="accent1"/>
+                  </a:effectRef>
+                  <a:fontRef idx="minor">
+                    <a:schemeClr val="tx1"/>
+                  </a:fontRef>
+                </p:style>
+              </p:cxnSp>
+            </p:grpSp>
+          </p:grpSp>
+          <p:pic>
+            <p:nvPicPr>
+              <p:cNvPr id="62" name="그림 61">
+                <a:extLst>
+                  <a:ext uri="{FF2B5EF4-FFF2-40B4-BE49-F238E27FC236}">
+                    <a16:creationId xmlns:a16="http://schemas.microsoft.com/office/drawing/2014/main" id="{44F459DB-5696-7EEF-B54A-01EB00C41A17}"/>
+                  </a:ext>
+                </a:extLst>
+              </p:cNvPr>
+              <p:cNvPicPr>
+                <a:picLocks noChangeAspect="1"/>
+              </p:cNvPicPr>
+              <p:nvPr/>
+            </p:nvPicPr>
+            <p:blipFill>
+              <a:blip r:embed="rId5"/>
+              <a:srcRect t="3694"/>
+              <a:stretch>
+                <a:fillRect/>
+              </a:stretch>
+            </p:blipFill>
+            <p:spPr>
+              <a:xfrm>
+                <a:off x="7260637" y="5070763"/>
+                <a:ext cx="2886478" cy="1412854"/>
+              </a:xfrm>
+              <a:prstGeom prst="rect">
+                <a:avLst/>
+              </a:prstGeom>
+              <a:ln>
+                <a:solidFill>
+                  <a:srgbClr val="7030A0"/>
+                </a:solidFill>
+              </a:ln>
+            </p:spPr>
+          </p:pic>
+        </p:grpSp>
+        <p:pic>
+          <p:nvPicPr>
+            <p:cNvPr id="68" name="그림 67">
+              <a:extLst>
+                <a:ext uri="{FF2B5EF4-FFF2-40B4-BE49-F238E27FC236}">
+                  <a16:creationId xmlns:a16="http://schemas.microsoft.com/office/drawing/2014/main" id="{26FEDDA2-BB14-AB75-C29F-1B9B20E64773}"/>
+                </a:ext>
+              </a:extLst>
+            </p:cNvPr>
+            <p:cNvPicPr>
+              <a:picLocks noChangeAspect="1"/>
+            </p:cNvPicPr>
+            <p:nvPr/>
+          </p:nvPicPr>
+          <p:blipFill>
+            <a:blip r:embed="rId6"/>
+            <a:stretch>
+              <a:fillRect/>
+            </a:stretch>
+          </p:blipFill>
+          <p:spPr>
+            <a:xfrm>
+              <a:off x="7035337" y="3390218"/>
+              <a:ext cx="2025535" cy="1621616"/>
+            </a:xfrm>
+            <a:prstGeom prst="rect">
+              <a:avLst/>
+            </a:prstGeom>
+            <a:ln>
+              <a:solidFill>
+                <a:srgbClr val="92D050"/>
+              </a:solidFill>
+            </a:ln>
+          </p:spPr>
+        </p:pic>
+      </p:grpSp>
+    </p:spTree>
+    <p:extLst>
+      <p:ext uri="{BB962C8B-B14F-4D97-AF65-F5344CB8AC3E}">
+        <p14:creationId xmlns:p14="http://schemas.microsoft.com/office/powerpoint/2010/main" val="2909814376"/>
+      </p:ext>
+    </p:extLst>
+  </p:cSld>
+  <p:clrMapOvr>
+    <a:masterClrMapping/>
+  </p:clrMapOvr>
+</p:sld>
+</file>
+
+<file path=ppt/slides/slide16.xml><?xml version="1.0" encoding="utf-8"?>
+<p:sld xmlns:a="http://schemas.openxmlformats.org/drawingml/2006/main" xmlns:r="http://schemas.openxmlformats.org/officeDocument/2006/relationships" xmlns:p="http://schemas.openxmlformats.org/presentationml/2006/main">
+  <p:cSld>
+    <p:spTree>
+      <p:nvGrpSpPr>
+        <p:cNvPr id="1" name=""/>
+        <p:cNvGrpSpPr/>
+        <p:nvPr/>
+      </p:nvGrpSpPr>
+      <p:grpSpPr>
+        <a:xfrm>
+          <a:off x="0" y="0"/>
+          <a:ext cx="0" cy="0"/>
+          <a:chOff x="0" y="0"/>
+          <a:chExt cx="0" cy="0"/>
+        </a:xfrm>
+      </p:grpSpPr>
+      <p:sp>
+        <p:nvSpPr>
+          <p:cNvPr id="2" name="제목 1">
+            <a:extLst>
+              <a:ext uri="{FF2B5EF4-FFF2-40B4-BE49-F238E27FC236}">
+                <a16:creationId xmlns:a16="http://schemas.microsoft.com/office/drawing/2014/main" id="{6388ADF5-1115-25A6-10AF-65479868D26A}"/>
+              </a:ext>
+            </a:extLst>
+          </p:cNvPr>
+          <p:cNvSpPr>
+            <a:spLocks noGrp="1"/>
+          </p:cNvSpPr>
+          <p:nvPr>
+            <p:ph type="title"/>
+          </p:nvPr>
+        </p:nvSpPr>
+        <p:spPr/>
+        <p:txBody>
+          <a:bodyPr>
+            <a:normAutofit/>
+          </a:bodyPr>
+          <a:lstStyle/>
+          <a:p>
+            <a:r>
+              <a:rPr lang="en-US" altLang="ko-KR" sz="3600"/>
+              <a:t>elesticsearch/product-settings.json </a:t>
+            </a:r>
+            <a:r>
+              <a:rPr lang="ko-KR" altLang="en-US" sz="3600"/>
+              <a:t>파일 생성</a:t>
+            </a:r>
+          </a:p>
+        </p:txBody>
+      </p:sp>
+      <p:grpSp>
+        <p:nvGrpSpPr>
+          <p:cNvPr id="6" name="그룹 5">
+            <a:extLst>
+              <a:ext uri="{FF2B5EF4-FFF2-40B4-BE49-F238E27FC236}">
+                <a16:creationId xmlns:a16="http://schemas.microsoft.com/office/drawing/2014/main" id="{74979114-F522-E577-BF79-DF3918EF121E}"/>
+              </a:ext>
+            </a:extLst>
+          </p:cNvPr>
+          <p:cNvGrpSpPr/>
+          <p:nvPr/>
+        </p:nvGrpSpPr>
+        <p:grpSpPr>
+          <a:xfrm>
+            <a:off x="496273" y="1845475"/>
+            <a:ext cx="2534004" cy="3000794"/>
+            <a:chOff x="1097280" y="1845475"/>
+            <a:chExt cx="2534004" cy="3000794"/>
+          </a:xfrm>
+        </p:grpSpPr>
+        <p:pic>
+          <p:nvPicPr>
+            <p:cNvPr id="4" name="그림 3">
+              <a:extLst>
+                <a:ext uri="{FF2B5EF4-FFF2-40B4-BE49-F238E27FC236}">
+                  <a16:creationId xmlns:a16="http://schemas.microsoft.com/office/drawing/2014/main" id="{8B539C58-F41C-DEC9-CAB6-83B3BE54FD78}"/>
+                </a:ext>
+              </a:extLst>
+            </p:cNvPr>
+            <p:cNvPicPr>
+              <a:picLocks noChangeAspect="1"/>
+            </p:cNvPicPr>
+            <p:nvPr/>
+          </p:nvPicPr>
+          <p:blipFill>
+            <a:blip r:embed="rId2"/>
+            <a:stretch>
+              <a:fillRect/>
+            </a:stretch>
+          </p:blipFill>
+          <p:spPr>
+            <a:xfrm>
+              <a:off x="1097280" y="1845475"/>
+              <a:ext cx="2534004" cy="3000794"/>
+            </a:xfrm>
+            <a:prstGeom prst="rect">
+              <a:avLst/>
+            </a:prstGeom>
+          </p:spPr>
+        </p:pic>
+        <p:sp>
+          <p:nvSpPr>
+            <p:cNvPr id="5" name="직사각형 4">
+              <a:extLst>
+                <a:ext uri="{FF2B5EF4-FFF2-40B4-BE49-F238E27FC236}">
+                  <a16:creationId xmlns:a16="http://schemas.microsoft.com/office/drawing/2014/main" id="{5D24F71D-6995-B427-0244-BA937D872D11}"/>
+                </a:ext>
+              </a:extLst>
+            </p:cNvPr>
+            <p:cNvSpPr/>
+            <p:nvPr/>
+          </p:nvSpPr>
+          <p:spPr>
+            <a:xfrm>
+              <a:off x="1421476" y="4580313"/>
+              <a:ext cx="1512917" cy="265956"/>
+            </a:xfrm>
+            <a:prstGeom prst="rect">
+              <a:avLst/>
+            </a:prstGeom>
+            <a:noFill/>
+            <a:ln>
+              <a:solidFill>
+                <a:srgbClr val="FF0000"/>
+              </a:solidFill>
+            </a:ln>
+          </p:spPr>
+          <p:style>
+            <a:lnRef idx="2">
+              <a:schemeClr val="accent1">
+                <a:shade val="15000"/>
+              </a:schemeClr>
+            </a:lnRef>
+            <a:fillRef idx="1">
+              <a:schemeClr val="accent1"/>
+            </a:fillRef>
+            <a:effectRef idx="0">
+              <a:schemeClr val="accent1"/>
+            </a:effectRef>
+            <a:fontRef idx="minor">
+              <a:schemeClr val="lt1"/>
+            </a:fontRef>
+          </p:style>
+          <p:txBody>
+            <a:bodyPr rtlCol="0" anchor="ctr"/>
+            <a:lstStyle/>
+            <a:p>
+              <a:pPr algn="ctr"/>
+              <a:endParaRPr lang="ko-KR" altLang="en-US"/>
+            </a:p>
+          </p:txBody>
+        </p:sp>
+      </p:grpSp>
+      <p:sp>
+        <p:nvSpPr>
+          <p:cNvPr id="7" name="TextBox 6">
+            <a:extLst>
+              <a:ext uri="{FF2B5EF4-FFF2-40B4-BE49-F238E27FC236}">
+                <a16:creationId xmlns:a16="http://schemas.microsoft.com/office/drawing/2014/main" id="{7628A656-77D1-1790-30F0-02F93D541DC5}"/>
+              </a:ext>
+            </a:extLst>
+          </p:cNvPr>
+          <p:cNvSpPr txBox="1"/>
+          <p:nvPr/>
+        </p:nvSpPr>
+        <p:spPr>
+          <a:xfrm>
+            <a:off x="3152823" y="1845475"/>
+            <a:ext cx="8163099" cy="276999"/>
+          </a:xfrm>
+          <a:prstGeom prst="rect">
+            <a:avLst/>
+          </a:prstGeom>
+          <a:noFill/>
+        </p:spPr>
+        <p:txBody>
+          <a:bodyPr wrap="square" rtlCol="0">
+            <a:spAutoFit/>
+          </a:bodyPr>
+          <a:lstStyle/>
+          <a:p>
+            <a:r>
+              <a:rPr lang="en-US" altLang="ko-KR" sz="1200"/>
+              <a:t>resources </a:t>
+            </a:r>
+            <a:r>
+              <a:rPr lang="ko-KR" altLang="en-US" sz="1200"/>
+              <a:t>하위에 </a:t>
+            </a:r>
+            <a:r>
+              <a:rPr lang="en-US" altLang="ko-KR" sz="1200"/>
+              <a:t>elasticsearch/product-settings.json </a:t>
+            </a:r>
+            <a:r>
+              <a:rPr lang="ko-KR" altLang="en-US" sz="1200"/>
+              <a:t>파일 생성</a:t>
+            </a:r>
+          </a:p>
+        </p:txBody>
+      </p:sp>
+      <p:pic>
+        <p:nvPicPr>
+          <p:cNvPr id="9" name="그림 8">
+            <a:extLst>
+              <a:ext uri="{FF2B5EF4-FFF2-40B4-BE49-F238E27FC236}">
+                <a16:creationId xmlns:a16="http://schemas.microsoft.com/office/drawing/2014/main" id="{096616B2-A155-4C4C-2956-7F9807AC2E81}"/>
+              </a:ext>
+            </a:extLst>
+          </p:cNvPr>
+          <p:cNvPicPr>
+            <a:picLocks noChangeAspect="1"/>
+          </p:cNvPicPr>
+          <p:nvPr/>
+        </p:nvPicPr>
+        <p:blipFill>
+          <a:blip r:embed="rId3"/>
+          <a:stretch>
+            <a:fillRect/>
+          </a:stretch>
+        </p:blipFill>
+        <p:spPr>
+          <a:xfrm>
+            <a:off x="3152823" y="2230589"/>
+            <a:ext cx="4495075" cy="3588320"/>
+          </a:xfrm>
+          <a:prstGeom prst="rect">
+            <a:avLst/>
+          </a:prstGeom>
+        </p:spPr>
+      </p:pic>
+      <p:grpSp>
+        <p:nvGrpSpPr>
+          <p:cNvPr id="13" name="그룹 12">
+            <a:extLst>
+              <a:ext uri="{FF2B5EF4-FFF2-40B4-BE49-F238E27FC236}">
+                <a16:creationId xmlns:a16="http://schemas.microsoft.com/office/drawing/2014/main" id="{3637E6EF-9331-AA9D-6F97-8BC6A5BF353D}"/>
+              </a:ext>
+            </a:extLst>
+          </p:cNvPr>
+          <p:cNvGrpSpPr/>
+          <p:nvPr/>
+        </p:nvGrpSpPr>
+        <p:grpSpPr>
+          <a:xfrm>
+            <a:off x="7735041" y="2230589"/>
+            <a:ext cx="4301789" cy="3871536"/>
+            <a:chOff x="7735041" y="2230589"/>
+            <a:chExt cx="4301789" cy="3871536"/>
+          </a:xfrm>
+        </p:grpSpPr>
+        <p:pic>
+          <p:nvPicPr>
+            <p:cNvPr id="11" name="그림 10">
+              <a:extLst>
+                <a:ext uri="{FF2B5EF4-FFF2-40B4-BE49-F238E27FC236}">
+                  <a16:creationId xmlns:a16="http://schemas.microsoft.com/office/drawing/2014/main" id="{A52C0AF6-540A-5CC2-B39B-8D132C89FDB2}"/>
+                </a:ext>
+              </a:extLst>
+            </p:cNvPr>
+            <p:cNvPicPr>
+              <a:picLocks noChangeAspect="1"/>
+            </p:cNvPicPr>
+            <p:nvPr/>
+          </p:nvPicPr>
+          <p:blipFill>
+            <a:blip r:embed="rId4"/>
+            <a:stretch>
+              <a:fillRect/>
+            </a:stretch>
+          </p:blipFill>
+          <p:spPr>
+            <a:xfrm>
+              <a:off x="7735041" y="2230589"/>
+              <a:ext cx="4301788" cy="3871536"/>
+            </a:xfrm>
+            <a:prstGeom prst="rect">
+              <a:avLst/>
+            </a:prstGeom>
+          </p:spPr>
+        </p:pic>
+        <p:sp>
+          <p:nvSpPr>
+            <p:cNvPr id="12" name="직사각형 11">
+              <a:extLst>
+                <a:ext uri="{FF2B5EF4-FFF2-40B4-BE49-F238E27FC236}">
+                  <a16:creationId xmlns:a16="http://schemas.microsoft.com/office/drawing/2014/main" id="{ABCEBA44-CB82-3D88-A7B9-9B34BA25971C}"/>
+                </a:ext>
+              </a:extLst>
+            </p:cNvPr>
+            <p:cNvSpPr/>
+            <p:nvPr/>
+          </p:nvSpPr>
+          <p:spPr>
+            <a:xfrm>
+              <a:off x="8262852" y="2568633"/>
+              <a:ext cx="3773978" cy="3458094"/>
+            </a:xfrm>
+            <a:prstGeom prst="rect">
+              <a:avLst/>
+            </a:prstGeom>
+            <a:noFill/>
+            <a:ln>
+              <a:solidFill>
+                <a:srgbClr val="FF0000"/>
+              </a:solidFill>
+            </a:ln>
+          </p:spPr>
+          <p:style>
+            <a:lnRef idx="2">
+              <a:schemeClr val="accent1">
+                <a:shade val="15000"/>
+              </a:schemeClr>
+            </a:lnRef>
+            <a:fillRef idx="1">
+              <a:schemeClr val="accent1"/>
+            </a:fillRef>
+            <a:effectRef idx="0">
+              <a:schemeClr val="accent1"/>
+            </a:effectRef>
+            <a:fontRef idx="minor">
+              <a:schemeClr val="lt1"/>
+            </a:fontRef>
+          </p:style>
+          <p:txBody>
+            <a:bodyPr rtlCol="0" anchor="ctr"/>
+            <a:lstStyle/>
+            <a:p>
+              <a:pPr algn="ctr"/>
+              <a:endParaRPr lang="ko-KR" altLang="en-US"/>
+            </a:p>
+          </p:txBody>
+        </p:sp>
+      </p:grpSp>
+      <p:sp>
+        <p:nvSpPr>
+          <p:cNvPr id="14" name="TextBox 13">
+            <a:extLst>
+              <a:ext uri="{FF2B5EF4-FFF2-40B4-BE49-F238E27FC236}">
+                <a16:creationId xmlns:a16="http://schemas.microsoft.com/office/drawing/2014/main" id="{0B3C6563-91FB-DE22-8D72-B874F1191914}"/>
+              </a:ext>
+            </a:extLst>
+          </p:cNvPr>
+          <p:cNvSpPr txBox="1"/>
+          <p:nvPr/>
+        </p:nvSpPr>
+        <p:spPr>
+          <a:xfrm>
+            <a:off x="9567949" y="2668385"/>
+            <a:ext cx="2468880" cy="430887"/>
+          </a:xfrm>
+          <a:prstGeom prst="rect">
+            <a:avLst/>
+          </a:prstGeom>
+          <a:noFill/>
+        </p:spPr>
+        <p:txBody>
+          <a:bodyPr wrap="square" rtlCol="0">
+            <a:spAutoFit/>
+          </a:bodyPr>
+          <a:lstStyle/>
+          <a:p>
+            <a:r>
+              <a:rPr lang="en-US" altLang="ko-KR" sz="1100"/>
+              <a:t>settings </a:t>
+            </a:r>
+            <a:r>
+              <a:rPr lang="ko-KR" altLang="en-US" sz="1100"/>
+              <a:t>내부의 코드가 곧 </a:t>
+            </a:r>
+            <a:br>
+              <a:rPr lang="en-US" altLang="ko-KR" sz="1100"/>
+            </a:br>
+            <a:r>
+              <a:rPr lang="en-US" altLang="ko-KR" sz="1100"/>
+              <a:t>product-settings.json </a:t>
+            </a:r>
+            <a:r>
+              <a:rPr lang="ko-KR" altLang="en-US" sz="1100"/>
+              <a:t>내용이 된다</a:t>
+            </a:r>
+            <a:r>
+              <a:rPr lang="en-US" altLang="ko-KR" sz="1100"/>
+              <a:t>.</a:t>
+            </a:r>
+            <a:endParaRPr lang="ko-KR" altLang="en-US" sz="1100"/>
+          </a:p>
+        </p:txBody>
+      </p:sp>
+    </p:spTree>
+    <p:extLst>
+      <p:ext uri="{BB962C8B-B14F-4D97-AF65-F5344CB8AC3E}">
+        <p14:creationId xmlns:p14="http://schemas.microsoft.com/office/powerpoint/2010/main" val="2024770622"/>
+      </p:ext>
+    </p:extLst>
+  </p:cSld>
+  <p:clrMapOvr>
+    <a:masterClrMapping/>
+  </p:clrMapOvr>
+</p:sld>
+</file>
+
+<file path=ppt/slides/slide17.xml><?xml version="1.0" encoding="utf-8"?>
+<p:sld xmlns:a="http://schemas.openxmlformats.org/drawingml/2006/main" xmlns:r="http://schemas.openxmlformats.org/officeDocument/2006/relationships" xmlns:p="http://schemas.openxmlformats.org/presentationml/2006/main">
+  <p:cSld>
+    <p:spTree>
+      <p:nvGrpSpPr>
+        <p:cNvPr id="1" name=""/>
+        <p:cNvGrpSpPr/>
+        <p:nvPr/>
+      </p:nvGrpSpPr>
+      <p:grpSpPr>
+        <a:xfrm>
+          <a:off x="0" y="0"/>
+          <a:ext cx="0" cy="0"/>
+          <a:chOff x="0" y="0"/>
+          <a:chExt cx="0" cy="0"/>
+        </a:xfrm>
+      </p:grpSpPr>
+      <p:sp>
+        <p:nvSpPr>
+          <p:cNvPr id="2" name="제목 1">
+            <a:extLst>
+              <a:ext uri="{FF2B5EF4-FFF2-40B4-BE49-F238E27FC236}">
+                <a16:creationId xmlns:a16="http://schemas.microsoft.com/office/drawing/2014/main" id="{4340F74E-5593-12E0-B565-7EC2F7489584}"/>
+              </a:ext>
+            </a:extLst>
+          </p:cNvPr>
+          <p:cNvSpPr>
+            <a:spLocks noGrp="1"/>
+          </p:cNvSpPr>
+          <p:nvPr>
+            <p:ph type="title"/>
+          </p:nvPr>
+        </p:nvSpPr>
+        <p:spPr/>
+        <p:txBody>
+          <a:bodyPr>
+            <a:normAutofit/>
+          </a:bodyPr>
+          <a:lstStyle/>
+          <a:p>
+            <a:r>
+              <a:rPr lang="en-US" altLang="ko-KR" sz="3200"/>
+              <a:t>ElasticSearch </a:t>
+            </a:r>
+            <a:r>
+              <a:rPr lang="ko-KR" altLang="en-US" sz="3200"/>
+              <a:t>조작을 위한 </a:t>
+            </a:r>
+            <a:r>
+              <a:rPr lang="en-US" altLang="ko-KR" sz="3200"/>
+              <a:t>ProductDocumentRepository </a:t>
+            </a:r>
+            <a:r>
+              <a:rPr lang="ko-KR" altLang="en-US" sz="3200"/>
+              <a:t>작성</a:t>
+            </a:r>
+          </a:p>
+        </p:txBody>
+      </p:sp>
+      <p:pic>
+        <p:nvPicPr>
+          <p:cNvPr id="4" name="그림 3">
+            <a:extLst>
+              <a:ext uri="{FF2B5EF4-FFF2-40B4-BE49-F238E27FC236}">
+                <a16:creationId xmlns:a16="http://schemas.microsoft.com/office/drawing/2014/main" id="{9EDC173B-46F5-4083-39DB-7326938647A5}"/>
+              </a:ext>
+            </a:extLst>
+          </p:cNvPr>
+          <p:cNvPicPr>
+            <a:picLocks noChangeAspect="1"/>
+          </p:cNvPicPr>
+          <p:nvPr/>
+        </p:nvPicPr>
+        <p:blipFill>
+          <a:blip r:embed="rId2"/>
+          <a:stretch>
+            <a:fillRect/>
+          </a:stretch>
+        </p:blipFill>
+        <p:spPr>
+          <a:xfrm>
+            <a:off x="3768136" y="1837775"/>
+            <a:ext cx="8030696" cy="1686160"/>
+          </a:xfrm>
+          <a:prstGeom prst="rect">
+            <a:avLst/>
+          </a:prstGeom>
+        </p:spPr>
+      </p:pic>
+      <p:grpSp>
+        <p:nvGrpSpPr>
+          <p:cNvPr id="8" name="그룹 7">
+            <a:extLst>
+              <a:ext uri="{FF2B5EF4-FFF2-40B4-BE49-F238E27FC236}">
+                <a16:creationId xmlns:a16="http://schemas.microsoft.com/office/drawing/2014/main" id="{53CD13BD-1DBA-8F1A-9555-B2A1BB0E8A86}"/>
+              </a:ext>
+            </a:extLst>
+          </p:cNvPr>
+          <p:cNvGrpSpPr/>
+          <p:nvPr/>
+        </p:nvGrpSpPr>
+        <p:grpSpPr>
+          <a:xfrm>
+            <a:off x="1097280" y="1837775"/>
+            <a:ext cx="2553056" cy="2343477"/>
+            <a:chOff x="1097280" y="1837775"/>
+            <a:chExt cx="2553056" cy="2343477"/>
+          </a:xfrm>
+        </p:grpSpPr>
+        <p:pic>
+          <p:nvPicPr>
+            <p:cNvPr id="6" name="그림 5">
+              <a:extLst>
+                <a:ext uri="{FF2B5EF4-FFF2-40B4-BE49-F238E27FC236}">
+                  <a16:creationId xmlns:a16="http://schemas.microsoft.com/office/drawing/2014/main" id="{9168C449-2464-917F-8039-545061F6403A}"/>
+                </a:ext>
+              </a:extLst>
+            </p:cNvPr>
+            <p:cNvPicPr>
+              <a:picLocks noChangeAspect="1"/>
+            </p:cNvPicPr>
+            <p:nvPr/>
+          </p:nvPicPr>
+          <p:blipFill>
+            <a:blip r:embed="rId3"/>
+            <a:stretch>
+              <a:fillRect/>
+            </a:stretch>
+          </p:blipFill>
+          <p:spPr>
+            <a:xfrm>
+              <a:off x="1097280" y="1837775"/>
+              <a:ext cx="2553056" cy="2343477"/>
+            </a:xfrm>
+            <a:prstGeom prst="rect">
+              <a:avLst/>
+            </a:prstGeom>
+          </p:spPr>
+        </p:pic>
+        <p:sp>
+          <p:nvSpPr>
+            <p:cNvPr id="7" name="직사각형 6">
+              <a:extLst>
+                <a:ext uri="{FF2B5EF4-FFF2-40B4-BE49-F238E27FC236}">
+                  <a16:creationId xmlns:a16="http://schemas.microsoft.com/office/drawing/2014/main" id="{1DD97F44-AF69-79A7-814C-42906AB96018}"/>
+                </a:ext>
+              </a:extLst>
+            </p:cNvPr>
+            <p:cNvSpPr/>
+            <p:nvPr/>
+          </p:nvSpPr>
+          <p:spPr>
+            <a:xfrm>
+              <a:off x="1379913" y="3931920"/>
+              <a:ext cx="2103120" cy="249332"/>
+            </a:xfrm>
+            <a:prstGeom prst="rect">
+              <a:avLst/>
+            </a:prstGeom>
+            <a:noFill/>
+            <a:ln>
+              <a:solidFill>
+                <a:srgbClr val="FF0000"/>
+              </a:solidFill>
+            </a:ln>
+          </p:spPr>
+          <p:style>
+            <a:lnRef idx="2">
+              <a:schemeClr val="accent1">
+                <a:shade val="15000"/>
+              </a:schemeClr>
+            </a:lnRef>
+            <a:fillRef idx="1">
+              <a:schemeClr val="accent1"/>
+            </a:fillRef>
+            <a:effectRef idx="0">
+              <a:schemeClr val="accent1"/>
+            </a:effectRef>
+            <a:fontRef idx="minor">
+              <a:schemeClr val="lt1"/>
+            </a:fontRef>
+          </p:style>
+          <p:txBody>
+            <a:bodyPr rtlCol="0" anchor="ctr"/>
+            <a:lstStyle/>
+            <a:p>
+              <a:pPr algn="ctr"/>
+              <a:endParaRPr lang="ko-KR" altLang="en-US"/>
+            </a:p>
+          </p:txBody>
+        </p:sp>
+      </p:grpSp>
+      <p:sp>
+        <p:nvSpPr>
+          <p:cNvPr id="9" name="TextBox 8">
+            <a:extLst>
+              <a:ext uri="{FF2B5EF4-FFF2-40B4-BE49-F238E27FC236}">
+                <a16:creationId xmlns:a16="http://schemas.microsoft.com/office/drawing/2014/main" id="{482F30A9-628F-418B-B867-395C0FFDED71}"/>
+              </a:ext>
+            </a:extLst>
+          </p:cNvPr>
+          <p:cNvSpPr txBox="1"/>
+          <p:nvPr/>
+        </p:nvSpPr>
+        <p:spPr>
+          <a:xfrm>
+            <a:off x="3768136" y="3599411"/>
+            <a:ext cx="8030696" cy="600164"/>
+          </a:xfrm>
+          <a:prstGeom prst="rect">
+            <a:avLst/>
+          </a:prstGeom>
+          <a:noFill/>
+        </p:spPr>
+        <p:txBody>
+          <a:bodyPr wrap="square" rtlCol="0">
+            <a:spAutoFit/>
+          </a:bodyPr>
+          <a:lstStyle/>
+          <a:p>
+            <a:r>
+              <a:rPr lang="en-US" altLang="ko-KR" sz="1100"/>
+              <a:t>JpaRepository</a:t>
+            </a:r>
+            <a:r>
+              <a:rPr lang="ko-KR" altLang="en-US" sz="1100"/>
+              <a:t>를 인터페이스에 상속받듯이 </a:t>
+            </a:r>
+            <a:r>
+              <a:rPr lang="en-US" altLang="ko-KR" sz="1100"/>
+              <a:t>ElasticSearch</a:t>
+            </a:r>
+            <a:r>
+              <a:rPr lang="ko-KR" altLang="en-US" sz="1100"/>
+              <a:t>도 동일하다</a:t>
+            </a:r>
+            <a:r>
+              <a:rPr lang="en-US" altLang="ko-KR" sz="1100"/>
+              <a:t>.</a:t>
+            </a:r>
+          </a:p>
+          <a:p>
+            <a:endParaRPr lang="en-US" altLang="ko-KR" sz="1100"/>
+          </a:p>
+          <a:p>
+            <a:r>
+              <a:rPr lang="en-US" altLang="ko-KR" sz="1100"/>
+              <a:t>interface </a:t>
+            </a:r>
+            <a:r>
+              <a:rPr lang="ko-KR" altLang="en-US" sz="1100"/>
+              <a:t>클래스에 </a:t>
+            </a:r>
+            <a:r>
+              <a:rPr lang="en-US" altLang="ko-KR" sz="1100"/>
+              <a:t>ElasticsearchRepository</a:t>
+            </a:r>
+            <a:r>
+              <a:rPr lang="ko-KR" altLang="en-US" sz="1100"/>
+              <a:t>를 상속받는다</a:t>
+            </a:r>
+            <a:r>
+              <a:rPr lang="en-US" altLang="ko-KR" sz="1100"/>
+              <a:t>.</a:t>
+            </a:r>
+            <a:endParaRPr lang="ko-KR" altLang="en-US" sz="1100"/>
+          </a:p>
+        </p:txBody>
+      </p:sp>
+    </p:spTree>
+    <p:extLst>
+      <p:ext uri="{BB962C8B-B14F-4D97-AF65-F5344CB8AC3E}">
+        <p14:creationId xmlns:p14="http://schemas.microsoft.com/office/powerpoint/2010/main" val="1778850591"/>
+      </p:ext>
+    </p:extLst>
+  </p:cSld>
+  <p:clrMapOvr>
+    <a:masterClrMapping/>
+  </p:clrMapOvr>
+</p:sld>
+</file>
+
+<file path=ppt/slides/slide18.xml><?xml version="1.0" encoding="utf-8"?>
+<p:sld xmlns:a="http://schemas.openxmlformats.org/drawingml/2006/main" xmlns:r="http://schemas.openxmlformats.org/officeDocument/2006/relationships" xmlns:p="http://schemas.openxmlformats.org/presentationml/2006/main">
+  <p:cSld>
+    <p:spTree>
+      <p:nvGrpSpPr>
+        <p:cNvPr id="1" name=""/>
+        <p:cNvGrpSpPr/>
+        <p:nvPr/>
+      </p:nvGrpSpPr>
+      <p:grpSpPr>
+        <a:xfrm>
+          <a:off x="0" y="0"/>
+          <a:ext cx="0" cy="0"/>
+          <a:chOff x="0" y="0"/>
+          <a:chExt cx="0" cy="0"/>
+        </a:xfrm>
+      </p:grpSpPr>
+      <p:sp>
+        <p:nvSpPr>
+          <p:cNvPr id="2" name="제목 1">
+            <a:extLst>
+              <a:ext uri="{FF2B5EF4-FFF2-40B4-BE49-F238E27FC236}">
+                <a16:creationId xmlns:a16="http://schemas.microsoft.com/office/drawing/2014/main" id="{388F1917-1D49-0AF7-EF21-7C7A4B5B86AB}"/>
+              </a:ext>
+            </a:extLst>
+          </p:cNvPr>
+          <p:cNvSpPr>
+            <a:spLocks noGrp="1"/>
+          </p:cNvSpPr>
+          <p:nvPr>
+            <p:ph type="title"/>
+          </p:nvPr>
+        </p:nvSpPr>
+        <p:spPr/>
+        <p:txBody>
+          <a:bodyPr>
+            <a:normAutofit/>
+          </a:bodyPr>
+          <a:lstStyle/>
+          <a:p>
+            <a:r>
+              <a:rPr lang="en-US" altLang="ko-KR" sz="3600" dirty="0" err="1"/>
+              <a:t>ProductService</a:t>
+            </a:r>
+            <a:r>
+              <a:rPr lang="en-US" altLang="ko-KR" sz="3600"/>
+              <a:t> </a:t>
+            </a:r>
+            <a:r>
+              <a:rPr lang="ko-KR" altLang="en-US" sz="3600"/>
+              <a:t>데이터 삽입</a:t>
+            </a:r>
+            <a:r>
+              <a:rPr lang="en-US" altLang="ko-KR" sz="3600"/>
+              <a:t>, </a:t>
+            </a:r>
+            <a:r>
+              <a:rPr lang="ko-KR" altLang="en-US" sz="3600"/>
+              <a:t>삭제 로직 수정</a:t>
+            </a:r>
+          </a:p>
+        </p:txBody>
+      </p:sp>
+      <p:grpSp>
+        <p:nvGrpSpPr>
+          <p:cNvPr id="6" name="그룹 5">
+            <a:extLst>
+              <a:ext uri="{FF2B5EF4-FFF2-40B4-BE49-F238E27FC236}">
+                <a16:creationId xmlns:a16="http://schemas.microsoft.com/office/drawing/2014/main" id="{25F58845-1A81-04D9-249F-63B5E17EA61E}"/>
+              </a:ext>
+            </a:extLst>
+          </p:cNvPr>
+          <p:cNvGrpSpPr/>
+          <p:nvPr/>
+        </p:nvGrpSpPr>
+        <p:grpSpPr>
+          <a:xfrm>
+            <a:off x="340125" y="1852575"/>
+            <a:ext cx="2534004" cy="3019846"/>
+            <a:chOff x="340125" y="1852575"/>
+            <a:chExt cx="2534004" cy="3019846"/>
+          </a:xfrm>
+        </p:grpSpPr>
+        <p:pic>
+          <p:nvPicPr>
+            <p:cNvPr id="4" name="그림 3">
+              <a:extLst>
+                <a:ext uri="{FF2B5EF4-FFF2-40B4-BE49-F238E27FC236}">
+                  <a16:creationId xmlns:a16="http://schemas.microsoft.com/office/drawing/2014/main" id="{04BA0563-6410-868F-F315-2A1879FE4582}"/>
+                </a:ext>
+              </a:extLst>
+            </p:cNvPr>
+            <p:cNvPicPr>
+              <a:picLocks noChangeAspect="1"/>
+            </p:cNvPicPr>
+            <p:nvPr/>
+          </p:nvPicPr>
+          <p:blipFill>
+            <a:blip r:embed="rId2"/>
+            <a:stretch>
+              <a:fillRect/>
+            </a:stretch>
+          </p:blipFill>
+          <p:spPr>
+            <a:xfrm>
+              <a:off x="340125" y="1852575"/>
+              <a:ext cx="2534004" cy="3019846"/>
+            </a:xfrm>
+            <a:prstGeom prst="rect">
+              <a:avLst/>
+            </a:prstGeom>
+          </p:spPr>
+        </p:pic>
+        <p:sp>
+          <p:nvSpPr>
+            <p:cNvPr id="5" name="직사각형 4">
+              <a:extLst>
+                <a:ext uri="{FF2B5EF4-FFF2-40B4-BE49-F238E27FC236}">
+                  <a16:creationId xmlns:a16="http://schemas.microsoft.com/office/drawing/2014/main" id="{346B4355-92FF-A0B7-C914-A4A2BA9BDE6D}"/>
+                </a:ext>
+              </a:extLst>
+            </p:cNvPr>
+            <p:cNvSpPr/>
+            <p:nvPr/>
+          </p:nvSpPr>
+          <p:spPr>
+            <a:xfrm>
+              <a:off x="656705" y="4621876"/>
+              <a:ext cx="1321724" cy="191193"/>
+            </a:xfrm>
+            <a:prstGeom prst="rect">
+              <a:avLst/>
+            </a:prstGeom>
+            <a:noFill/>
+            <a:ln>
+              <a:solidFill>
+                <a:srgbClr val="FF0000"/>
+              </a:solidFill>
+            </a:ln>
+          </p:spPr>
+          <p:style>
+            <a:lnRef idx="2">
+              <a:schemeClr val="accent1">
+                <a:shade val="15000"/>
+              </a:schemeClr>
+            </a:lnRef>
+            <a:fillRef idx="1">
+              <a:schemeClr val="accent1"/>
+            </a:fillRef>
+            <a:effectRef idx="0">
+              <a:schemeClr val="accent1"/>
+            </a:effectRef>
+            <a:fontRef idx="minor">
+              <a:schemeClr val="lt1"/>
+            </a:fontRef>
+          </p:style>
+          <p:txBody>
+            <a:bodyPr rtlCol="0" anchor="ctr"/>
+            <a:lstStyle/>
+            <a:p>
+              <a:pPr algn="ctr"/>
+              <a:endParaRPr lang="ko-KR" altLang="en-US"/>
+            </a:p>
+          </p:txBody>
+        </p:sp>
+      </p:grpSp>
+      <p:pic>
+        <p:nvPicPr>
+          <p:cNvPr id="8" name="그림 7">
+            <a:extLst>
+              <a:ext uri="{FF2B5EF4-FFF2-40B4-BE49-F238E27FC236}">
+                <a16:creationId xmlns:a16="http://schemas.microsoft.com/office/drawing/2014/main" id="{A092DF30-2E37-5F37-DF0A-91AA8B66CDCF}"/>
+              </a:ext>
+            </a:extLst>
+          </p:cNvPr>
+          <p:cNvPicPr>
+            <a:picLocks noChangeAspect="1"/>
+          </p:cNvPicPr>
+          <p:nvPr/>
+        </p:nvPicPr>
+        <p:blipFill>
+          <a:blip r:embed="rId3"/>
+          <a:stretch>
+            <a:fillRect/>
+          </a:stretch>
+        </p:blipFill>
+        <p:spPr>
+          <a:xfrm>
+            <a:off x="2947822" y="1852575"/>
+            <a:ext cx="5390334" cy="2004530"/>
+          </a:xfrm>
+          <a:prstGeom prst="rect">
+            <a:avLst/>
+          </a:prstGeom>
+        </p:spPr>
+      </p:pic>
+      <p:pic>
+        <p:nvPicPr>
+          <p:cNvPr id="10" name="그림 9">
+            <a:extLst>
+              <a:ext uri="{FF2B5EF4-FFF2-40B4-BE49-F238E27FC236}">
+                <a16:creationId xmlns:a16="http://schemas.microsoft.com/office/drawing/2014/main" id="{A3617FDC-E97C-8D30-2451-2FF046AFF9BA}"/>
+              </a:ext>
+            </a:extLst>
+          </p:cNvPr>
+          <p:cNvPicPr>
+            <a:picLocks noChangeAspect="1"/>
+          </p:cNvPicPr>
+          <p:nvPr/>
+        </p:nvPicPr>
+        <p:blipFill>
+          <a:blip r:embed="rId4"/>
+          <a:stretch>
+            <a:fillRect/>
+          </a:stretch>
+        </p:blipFill>
+        <p:spPr>
+          <a:xfrm>
+            <a:off x="2947822" y="3918534"/>
+            <a:ext cx="4656444" cy="2939466"/>
+          </a:xfrm>
+          <a:prstGeom prst="rect">
+            <a:avLst/>
+          </a:prstGeom>
+        </p:spPr>
+      </p:pic>
+      <p:pic>
+        <p:nvPicPr>
+          <p:cNvPr id="12" name="그림 11">
+            <a:extLst>
+              <a:ext uri="{FF2B5EF4-FFF2-40B4-BE49-F238E27FC236}">
+                <a16:creationId xmlns:a16="http://schemas.microsoft.com/office/drawing/2014/main" id="{FD5A73F1-61BB-43A6-04F4-8E23508FC2D6}"/>
+              </a:ext>
+            </a:extLst>
+          </p:cNvPr>
+          <p:cNvPicPr>
+            <a:picLocks noChangeAspect="1"/>
+          </p:cNvPicPr>
+          <p:nvPr/>
+        </p:nvPicPr>
+        <p:blipFill>
+          <a:blip r:embed="rId5"/>
+          <a:stretch>
+            <a:fillRect/>
+          </a:stretch>
+        </p:blipFill>
+        <p:spPr>
+          <a:xfrm>
+            <a:off x="7765407" y="3918534"/>
+            <a:ext cx="4086468" cy="824020"/>
+          </a:xfrm>
+          <a:prstGeom prst="rect">
+            <a:avLst/>
+          </a:prstGeom>
+        </p:spPr>
+      </p:pic>
+      <p:sp>
+        <p:nvSpPr>
+          <p:cNvPr id="13" name="TextBox 12">
+            <a:extLst>
+              <a:ext uri="{FF2B5EF4-FFF2-40B4-BE49-F238E27FC236}">
+                <a16:creationId xmlns:a16="http://schemas.microsoft.com/office/drawing/2014/main" id="{D03F524B-4471-46FA-D52B-9607564ADBD8}"/>
+              </a:ext>
+            </a:extLst>
+          </p:cNvPr>
+          <p:cNvSpPr txBox="1"/>
+          <p:nvPr/>
+        </p:nvSpPr>
+        <p:spPr>
+          <a:xfrm>
+            <a:off x="8429105" y="1852575"/>
+            <a:ext cx="3422770" cy="577081"/>
+          </a:xfrm>
+          <a:prstGeom prst="rect">
+            <a:avLst/>
+          </a:prstGeom>
+          <a:noFill/>
+        </p:spPr>
+        <p:txBody>
+          <a:bodyPr wrap="square" rtlCol="0">
+            <a:spAutoFit/>
+          </a:bodyPr>
+          <a:lstStyle/>
+          <a:p>
+            <a:r>
+              <a:rPr lang="en-US" altLang="ko-KR" sz="1050"/>
+              <a:t>ElasticSearch Repository (ProductDocumentRepository Bean</a:t>
+            </a:r>
+            <a:r>
+              <a:rPr lang="ko-KR" altLang="en-US" sz="1050"/>
+              <a:t> 생성자주입 추가</a:t>
+            </a:r>
+            <a:r>
+              <a:rPr lang="en-US" altLang="ko-KR" sz="1050"/>
+              <a:t>)</a:t>
+            </a:r>
+          </a:p>
+          <a:p>
+            <a:endParaRPr lang="ko-KR" altLang="en-US" sz="1050"/>
+          </a:p>
+        </p:txBody>
+      </p:sp>
+      <p:sp>
+        <p:nvSpPr>
+          <p:cNvPr id="14" name="TextBox 13">
+            <a:extLst>
+              <a:ext uri="{FF2B5EF4-FFF2-40B4-BE49-F238E27FC236}">
+                <a16:creationId xmlns:a16="http://schemas.microsoft.com/office/drawing/2014/main" id="{30B8C910-02B2-35F5-C4F6-B47679D8D7E0}"/>
+              </a:ext>
+            </a:extLst>
+          </p:cNvPr>
+          <p:cNvSpPr txBox="1"/>
+          <p:nvPr/>
+        </p:nvSpPr>
+        <p:spPr>
+          <a:xfrm>
+            <a:off x="5006335" y="5547893"/>
+            <a:ext cx="2458494" cy="415498"/>
+          </a:xfrm>
+          <a:prstGeom prst="rect">
+            <a:avLst/>
+          </a:prstGeom>
+          <a:noFill/>
+        </p:spPr>
+        <p:txBody>
+          <a:bodyPr wrap="square" rtlCol="0">
+            <a:spAutoFit/>
+          </a:bodyPr>
+          <a:lstStyle/>
+          <a:p>
+            <a:r>
+              <a:rPr lang="en-US" altLang="ko-KR" sz="1050">
+                <a:solidFill>
+                  <a:srgbClr val="FFFF00"/>
+                </a:solidFill>
+              </a:rPr>
+              <a:t>JPA</a:t>
+            </a:r>
+            <a:r>
+              <a:rPr lang="ko-KR" altLang="en-US" sz="1050">
+                <a:solidFill>
+                  <a:srgbClr val="FFFF00"/>
+                </a:solidFill>
+              </a:rPr>
+              <a:t> 데이터 저장후 </a:t>
+            </a:r>
+            <a:r>
+              <a:rPr lang="en-US" altLang="ko-KR" sz="1050">
+                <a:solidFill>
+                  <a:srgbClr val="FFFF00"/>
+                </a:solidFill>
+              </a:rPr>
+              <a:t>ElasticSearch Document</a:t>
+            </a:r>
+            <a:r>
+              <a:rPr lang="ko-KR" altLang="en-US" sz="1050">
+                <a:solidFill>
+                  <a:srgbClr val="FFFF00"/>
+                </a:solidFill>
+              </a:rPr>
+              <a:t> 입력</a:t>
+            </a:r>
+            <a:r>
+              <a:rPr lang="en-US" altLang="ko-KR" sz="1050">
+                <a:solidFill>
+                  <a:srgbClr val="FFFF00"/>
+                </a:solidFill>
+              </a:rPr>
+              <a:t>(</a:t>
+            </a:r>
+            <a:r>
+              <a:rPr lang="ko-KR" altLang="en-US" sz="1050">
+                <a:solidFill>
+                  <a:srgbClr val="FFFF00"/>
+                </a:solidFill>
+              </a:rPr>
+              <a:t>저장</a:t>
+            </a:r>
+            <a:r>
+              <a:rPr lang="en-US" altLang="ko-KR" sz="1050">
+                <a:solidFill>
+                  <a:srgbClr val="FFFF00"/>
+                </a:solidFill>
+              </a:rPr>
+              <a:t>)</a:t>
+            </a:r>
+            <a:endParaRPr lang="ko-KR" altLang="en-US" sz="1050">
+              <a:solidFill>
+                <a:srgbClr val="FFFF00"/>
+              </a:solidFill>
+            </a:endParaRPr>
+          </a:p>
+        </p:txBody>
+      </p:sp>
+      <p:sp>
+        <p:nvSpPr>
+          <p:cNvPr id="15" name="TextBox 14">
+            <a:extLst>
+              <a:ext uri="{FF2B5EF4-FFF2-40B4-BE49-F238E27FC236}">
+                <a16:creationId xmlns:a16="http://schemas.microsoft.com/office/drawing/2014/main" id="{227427A3-B31E-E27A-E2D0-7C1B4BC741B0}"/>
+              </a:ext>
+            </a:extLst>
+          </p:cNvPr>
+          <p:cNvSpPr txBox="1"/>
+          <p:nvPr/>
+        </p:nvSpPr>
+        <p:spPr>
+          <a:xfrm>
+            <a:off x="7765407" y="4803983"/>
+            <a:ext cx="2887984" cy="253916"/>
+          </a:xfrm>
+          <a:prstGeom prst="rect">
+            <a:avLst/>
+          </a:prstGeom>
+          <a:noFill/>
+        </p:spPr>
+        <p:txBody>
+          <a:bodyPr wrap="square" rtlCol="0">
+            <a:spAutoFit/>
+          </a:bodyPr>
+          <a:lstStyle/>
+          <a:p>
+            <a:r>
+              <a:rPr lang="en-US" altLang="ko-KR" sz="1050"/>
+              <a:t>JPA </a:t>
+            </a:r>
+            <a:r>
+              <a:rPr lang="ko-KR" altLang="en-US" sz="1050"/>
+              <a:t>데이터 삭제 후 </a:t>
+            </a:r>
+            <a:r>
+              <a:rPr lang="en-US" altLang="ko-KR" sz="1050"/>
+              <a:t>Elasticsearch </a:t>
+            </a:r>
+            <a:r>
+              <a:rPr lang="ko-KR" altLang="en-US" sz="1050"/>
+              <a:t>내 데이터 삭제</a:t>
+            </a:r>
+          </a:p>
+        </p:txBody>
+      </p:sp>
+    </p:spTree>
+    <p:extLst>
+      <p:ext uri="{BB962C8B-B14F-4D97-AF65-F5344CB8AC3E}">
+        <p14:creationId xmlns:p14="http://schemas.microsoft.com/office/powerpoint/2010/main" val="2587884928"/>
+      </p:ext>
+    </p:extLst>
+  </p:cSld>
+  <p:clrMapOvr>
+    <a:masterClrMapping/>
+  </p:clrMapOvr>
+</p:sld>
+</file>
+
+<file path=ppt/slides/slide19.xml><?xml version="1.0" encoding="utf-8"?>
+<p:sld xmlns:a="http://schemas.openxmlformats.org/drawingml/2006/main" xmlns:r="http://schemas.openxmlformats.org/officeDocument/2006/relationships" xmlns:p="http://schemas.openxmlformats.org/presentationml/2006/main">
+  <p:cSld>
+    <p:spTree>
+      <p:nvGrpSpPr>
+        <p:cNvPr id="1" name=""/>
+        <p:cNvGrpSpPr/>
+        <p:nvPr/>
+      </p:nvGrpSpPr>
+      <p:grpSpPr>
+        <a:xfrm>
+          <a:off x="0" y="0"/>
+          <a:ext cx="0" cy="0"/>
+          <a:chOff x="0" y="0"/>
+          <a:chExt cx="0" cy="0"/>
+        </a:xfrm>
+      </p:grpSpPr>
+      <p:sp>
+        <p:nvSpPr>
+          <p:cNvPr id="2" name="제목 1">
+            <a:extLst>
+              <a:ext uri="{FF2B5EF4-FFF2-40B4-BE49-F238E27FC236}">
+                <a16:creationId xmlns:a16="http://schemas.microsoft.com/office/drawing/2014/main" id="{EB63307F-AEBA-8B10-71D9-BE2E8C8127A1}"/>
+              </a:ext>
+            </a:extLst>
+          </p:cNvPr>
+          <p:cNvSpPr>
+            <a:spLocks noGrp="1"/>
+          </p:cNvSpPr>
+          <p:nvPr>
+            <p:ph type="title"/>
+          </p:nvPr>
+        </p:nvSpPr>
+        <p:spPr/>
+        <p:txBody>
+          <a:bodyPr/>
+          <a:lstStyle/>
+          <a:p>
+            <a:r>
+              <a:rPr lang="ko-KR" altLang="en-US"/>
+              <a:t>자동 완성 </a:t>
+            </a:r>
+            <a:r>
+              <a:rPr lang="en-US" altLang="ko-KR"/>
+              <a:t>URL </a:t>
+            </a:r>
+            <a:r>
+              <a:rPr lang="ko-KR" altLang="en-US"/>
+              <a:t>작성</a:t>
+            </a:r>
+          </a:p>
+        </p:txBody>
+      </p:sp>
+      <p:pic>
+        <p:nvPicPr>
+          <p:cNvPr id="4" name="그림 3">
+            <a:extLst>
+              <a:ext uri="{FF2B5EF4-FFF2-40B4-BE49-F238E27FC236}">
+                <a16:creationId xmlns:a16="http://schemas.microsoft.com/office/drawing/2014/main" id="{F357E650-85F4-7FCD-5FCA-4B15FBD8780D}"/>
+              </a:ext>
+            </a:extLst>
+          </p:cNvPr>
+          <p:cNvPicPr>
+            <a:picLocks noChangeAspect="1"/>
+          </p:cNvPicPr>
+          <p:nvPr/>
+        </p:nvPicPr>
+        <p:blipFill>
+          <a:blip r:embed="rId2"/>
+          <a:stretch>
+            <a:fillRect/>
+          </a:stretch>
+        </p:blipFill>
+        <p:spPr>
+          <a:xfrm>
+            <a:off x="3538834" y="1886413"/>
+            <a:ext cx="8011643" cy="1009791"/>
+          </a:xfrm>
+          <a:prstGeom prst="rect">
+            <a:avLst/>
+          </a:prstGeom>
+        </p:spPr>
+      </p:pic>
+      <p:grpSp>
+        <p:nvGrpSpPr>
+          <p:cNvPr id="8" name="그룹 7">
+            <a:extLst>
+              <a:ext uri="{FF2B5EF4-FFF2-40B4-BE49-F238E27FC236}">
+                <a16:creationId xmlns:a16="http://schemas.microsoft.com/office/drawing/2014/main" id="{299CC11E-A7AE-09DC-2D41-D3BC15A096BF}"/>
+              </a:ext>
+            </a:extLst>
+          </p:cNvPr>
+          <p:cNvGrpSpPr/>
+          <p:nvPr/>
+        </p:nvGrpSpPr>
+        <p:grpSpPr>
+          <a:xfrm>
+            <a:off x="1212351" y="1886413"/>
+            <a:ext cx="2162400" cy="4799820"/>
+            <a:chOff x="1212351" y="1886413"/>
+            <a:chExt cx="2162400" cy="4799820"/>
+          </a:xfrm>
+        </p:grpSpPr>
+        <p:pic>
+          <p:nvPicPr>
+            <p:cNvPr id="6" name="그림 5">
+              <a:extLst>
+                <a:ext uri="{FF2B5EF4-FFF2-40B4-BE49-F238E27FC236}">
+                  <a16:creationId xmlns:a16="http://schemas.microsoft.com/office/drawing/2014/main" id="{7F9B26E6-E4EC-3CAF-A9A7-D5C667C98791}"/>
+                </a:ext>
+              </a:extLst>
+            </p:cNvPr>
+            <p:cNvPicPr>
+              <a:picLocks noChangeAspect="1"/>
+            </p:cNvPicPr>
+            <p:nvPr/>
+          </p:nvPicPr>
+          <p:blipFill>
+            <a:blip r:embed="rId3"/>
+            <a:stretch>
+              <a:fillRect/>
+            </a:stretch>
+          </p:blipFill>
+          <p:spPr>
+            <a:xfrm>
+              <a:off x="1212351" y="1886413"/>
+              <a:ext cx="2162400" cy="4799820"/>
+            </a:xfrm>
+            <a:prstGeom prst="rect">
+              <a:avLst/>
+            </a:prstGeom>
+          </p:spPr>
+        </p:pic>
+        <p:sp>
+          <p:nvSpPr>
+            <p:cNvPr id="7" name="직사각형 6">
+              <a:extLst>
+                <a:ext uri="{FF2B5EF4-FFF2-40B4-BE49-F238E27FC236}">
+                  <a16:creationId xmlns:a16="http://schemas.microsoft.com/office/drawing/2014/main" id="{BD0923D2-4F9C-C4CE-45B7-655E916C57D9}"/>
+                </a:ext>
+              </a:extLst>
+            </p:cNvPr>
+            <p:cNvSpPr/>
+            <p:nvPr/>
+          </p:nvSpPr>
+          <p:spPr>
+            <a:xfrm>
+              <a:off x="1489753" y="4736387"/>
+              <a:ext cx="1202076" cy="215757"/>
+            </a:xfrm>
+            <a:prstGeom prst="rect">
+              <a:avLst/>
+            </a:prstGeom>
+            <a:noFill/>
+            <a:ln>
+              <a:solidFill>
+                <a:srgbClr val="FF0000"/>
+              </a:solidFill>
+            </a:ln>
+          </p:spPr>
+          <p:style>
+            <a:lnRef idx="2">
+              <a:schemeClr val="accent1">
+                <a:shade val="15000"/>
+              </a:schemeClr>
+            </a:lnRef>
+            <a:fillRef idx="1">
+              <a:schemeClr val="accent1"/>
+            </a:fillRef>
+            <a:effectRef idx="0">
+              <a:schemeClr val="accent1"/>
+            </a:effectRef>
+            <a:fontRef idx="minor">
+              <a:schemeClr val="lt1"/>
+            </a:fontRef>
+          </p:style>
+          <p:txBody>
+            <a:bodyPr rtlCol="0" anchor="ctr"/>
+            <a:lstStyle/>
+            <a:p>
+              <a:pPr algn="ctr"/>
+              <a:endParaRPr lang="ko-KR" altLang="en-US"/>
+            </a:p>
+          </p:txBody>
+        </p:sp>
+      </p:grpSp>
+    </p:spTree>
+    <p:extLst>
+      <p:ext uri="{BB962C8B-B14F-4D97-AF65-F5344CB8AC3E}">
+        <p14:creationId xmlns:p14="http://schemas.microsoft.com/office/powerpoint/2010/main" val="3225236400"/>
+      </p:ext>
+    </p:extLst>
+  </p:cSld>
+  <p:clrMapOvr>
+    <a:masterClrMapping/>
+  </p:clrMapOvr>
+</p:sld>
+</file>
+
 <file path=ppt/slides/slide2.xml><?xml version="1.0" encoding="utf-8"?>
 <p:sld xmlns:a="http://schemas.openxmlformats.org/drawingml/2006/main" xmlns:r="http://schemas.openxmlformats.org/officeDocument/2006/relationships" xmlns:p="http://schemas.openxmlformats.org/presentationml/2006/main">
   <p:cSld>
@@ -7375,6 +10576,766 @@
     <p:extLst>
       <p:ext uri="{BB962C8B-B14F-4D97-AF65-F5344CB8AC3E}">
         <p14:creationId xmlns:p14="http://schemas.microsoft.com/office/powerpoint/2010/main" val="1979980087"/>
+      </p:ext>
+    </p:extLst>
+  </p:cSld>
+  <p:clrMapOvr>
+    <a:masterClrMapping/>
+  </p:clrMapOvr>
+</p:sld>
+</file>
+
+<file path=ppt/slides/slide20.xml><?xml version="1.0" encoding="utf-8"?>
+<p:sld xmlns:a="http://schemas.openxmlformats.org/drawingml/2006/main" xmlns:r="http://schemas.openxmlformats.org/officeDocument/2006/relationships" xmlns:p="http://schemas.openxmlformats.org/presentationml/2006/main">
+  <p:cSld>
+    <p:spTree>
+      <p:nvGrpSpPr>
+        <p:cNvPr id="1" name=""/>
+        <p:cNvGrpSpPr/>
+        <p:nvPr/>
+      </p:nvGrpSpPr>
+      <p:grpSpPr>
+        <a:xfrm>
+          <a:off x="0" y="0"/>
+          <a:ext cx="0" cy="0"/>
+          <a:chOff x="0" y="0"/>
+          <a:chExt cx="0" cy="0"/>
+        </a:xfrm>
+      </p:grpSpPr>
+      <p:sp>
+        <p:nvSpPr>
+          <p:cNvPr id="2" name="제목 1">
+            <a:extLst>
+              <a:ext uri="{FF2B5EF4-FFF2-40B4-BE49-F238E27FC236}">
+                <a16:creationId xmlns:a16="http://schemas.microsoft.com/office/drawing/2014/main" id="{91FD6854-5087-B1D6-9B04-181017F6A75C}"/>
+              </a:ext>
+            </a:extLst>
+          </p:cNvPr>
+          <p:cNvSpPr>
+            <a:spLocks noGrp="1"/>
+          </p:cNvSpPr>
+          <p:nvPr>
+            <p:ph type="title"/>
+          </p:nvPr>
+        </p:nvSpPr>
+        <p:spPr/>
+        <p:txBody>
+          <a:bodyPr/>
+          <a:lstStyle/>
+          <a:p>
+            <a:r>
+              <a:rPr lang="ko-KR" altLang="en-US"/>
+              <a:t>자동완성서비스 작성 </a:t>
+            </a:r>
+            <a:r>
+              <a:rPr lang="en-US" altLang="ko-KR"/>
+              <a:t>- ProductService</a:t>
+            </a:r>
+            <a:endParaRPr lang="ko-KR" altLang="en-US"/>
+          </a:p>
+        </p:txBody>
+      </p:sp>
+      <p:grpSp>
+        <p:nvGrpSpPr>
+          <p:cNvPr id="6" name="그룹 5">
+            <a:extLst>
+              <a:ext uri="{FF2B5EF4-FFF2-40B4-BE49-F238E27FC236}">
+                <a16:creationId xmlns:a16="http://schemas.microsoft.com/office/drawing/2014/main" id="{431E186A-DD7A-8D40-17D5-2845B303AD00}"/>
+              </a:ext>
+            </a:extLst>
+          </p:cNvPr>
+          <p:cNvGrpSpPr/>
+          <p:nvPr/>
+        </p:nvGrpSpPr>
+        <p:grpSpPr>
+          <a:xfrm>
+            <a:off x="450631" y="1884443"/>
+            <a:ext cx="2886478" cy="4686954"/>
+            <a:chOff x="450631" y="1884443"/>
+            <a:chExt cx="2886478" cy="4686954"/>
+          </a:xfrm>
+        </p:grpSpPr>
+        <p:pic>
+          <p:nvPicPr>
+            <p:cNvPr id="4" name="그림 3">
+              <a:extLst>
+                <a:ext uri="{FF2B5EF4-FFF2-40B4-BE49-F238E27FC236}">
+                  <a16:creationId xmlns:a16="http://schemas.microsoft.com/office/drawing/2014/main" id="{F14CD643-60AC-EA2F-0108-F0FDD6479912}"/>
+                </a:ext>
+              </a:extLst>
+            </p:cNvPr>
+            <p:cNvPicPr>
+              <a:picLocks noChangeAspect="1"/>
+            </p:cNvPicPr>
+            <p:nvPr/>
+          </p:nvPicPr>
+          <p:blipFill>
+            <a:blip r:embed="rId2"/>
+            <a:stretch>
+              <a:fillRect/>
+            </a:stretch>
+          </p:blipFill>
+          <p:spPr>
+            <a:xfrm>
+              <a:off x="450631" y="1884443"/>
+              <a:ext cx="2886478" cy="4686954"/>
+            </a:xfrm>
+            <a:prstGeom prst="rect">
+              <a:avLst/>
+            </a:prstGeom>
+          </p:spPr>
+        </p:pic>
+        <p:sp>
+          <p:nvSpPr>
+            <p:cNvPr id="5" name="직사각형 4">
+              <a:extLst>
+                <a:ext uri="{FF2B5EF4-FFF2-40B4-BE49-F238E27FC236}">
+                  <a16:creationId xmlns:a16="http://schemas.microsoft.com/office/drawing/2014/main" id="{D9BE16D9-768B-716B-7B9A-3CC943BFDF5D}"/>
+                </a:ext>
+              </a:extLst>
+            </p:cNvPr>
+            <p:cNvSpPr/>
+            <p:nvPr/>
+          </p:nvSpPr>
+          <p:spPr>
+            <a:xfrm>
+              <a:off x="780836" y="5876818"/>
+              <a:ext cx="1387011" cy="287676"/>
+            </a:xfrm>
+            <a:prstGeom prst="rect">
+              <a:avLst/>
+            </a:prstGeom>
+            <a:noFill/>
+            <a:ln>
+              <a:solidFill>
+                <a:srgbClr val="FF0000"/>
+              </a:solidFill>
+            </a:ln>
+          </p:spPr>
+          <p:style>
+            <a:lnRef idx="2">
+              <a:schemeClr val="accent1">
+                <a:shade val="15000"/>
+              </a:schemeClr>
+            </a:lnRef>
+            <a:fillRef idx="1">
+              <a:schemeClr val="accent1"/>
+            </a:fillRef>
+            <a:effectRef idx="0">
+              <a:schemeClr val="accent1"/>
+            </a:effectRef>
+            <a:fontRef idx="minor">
+              <a:schemeClr val="lt1"/>
+            </a:fontRef>
+          </p:style>
+          <p:txBody>
+            <a:bodyPr rtlCol="0" anchor="ctr"/>
+            <a:lstStyle/>
+            <a:p>
+              <a:pPr algn="ctr"/>
+              <a:endParaRPr lang="ko-KR" altLang="en-US"/>
+            </a:p>
+          </p:txBody>
+        </p:sp>
+      </p:grpSp>
+      <p:pic>
+        <p:nvPicPr>
+          <p:cNvPr id="8" name="그림 7">
+            <a:extLst>
+              <a:ext uri="{FF2B5EF4-FFF2-40B4-BE49-F238E27FC236}">
+                <a16:creationId xmlns:a16="http://schemas.microsoft.com/office/drawing/2014/main" id="{2B4A4F6E-0413-CBC0-4E8D-7686125BC9D9}"/>
+              </a:ext>
+            </a:extLst>
+          </p:cNvPr>
+          <p:cNvPicPr>
+            <a:picLocks noChangeAspect="1"/>
+          </p:cNvPicPr>
+          <p:nvPr/>
+        </p:nvPicPr>
+        <p:blipFill>
+          <a:blip r:embed="rId3"/>
+          <a:stretch>
+            <a:fillRect/>
+          </a:stretch>
+        </p:blipFill>
+        <p:spPr>
+          <a:xfrm>
+            <a:off x="3484601" y="1884443"/>
+            <a:ext cx="4467598" cy="2076980"/>
+          </a:xfrm>
+          <a:prstGeom prst="rect">
+            <a:avLst/>
+          </a:prstGeom>
+        </p:spPr>
+      </p:pic>
+      <p:pic>
+        <p:nvPicPr>
+          <p:cNvPr id="10" name="그림 9">
+            <a:extLst>
+              <a:ext uri="{FF2B5EF4-FFF2-40B4-BE49-F238E27FC236}">
+                <a16:creationId xmlns:a16="http://schemas.microsoft.com/office/drawing/2014/main" id="{64F54AF2-7640-41F3-F4E2-CCCE60ACBF2E}"/>
+              </a:ext>
+            </a:extLst>
+          </p:cNvPr>
+          <p:cNvPicPr>
+            <a:picLocks noChangeAspect="1"/>
+          </p:cNvPicPr>
+          <p:nvPr/>
+        </p:nvPicPr>
+        <p:blipFill>
+          <a:blip r:embed="rId4"/>
+          <a:stretch>
+            <a:fillRect/>
+          </a:stretch>
+        </p:blipFill>
+        <p:spPr>
+          <a:xfrm>
+            <a:off x="3484601" y="4002520"/>
+            <a:ext cx="6265574" cy="2777100"/>
+          </a:xfrm>
+          <a:prstGeom prst="rect">
+            <a:avLst/>
+          </a:prstGeom>
+        </p:spPr>
+      </p:pic>
+      <p:sp>
+        <p:nvSpPr>
+          <p:cNvPr id="11" name="TextBox 10">
+            <a:extLst>
+              <a:ext uri="{FF2B5EF4-FFF2-40B4-BE49-F238E27FC236}">
+                <a16:creationId xmlns:a16="http://schemas.microsoft.com/office/drawing/2014/main" id="{CB8FF748-1EEC-FD57-CC32-DBFDDC0F1D52}"/>
+              </a:ext>
+            </a:extLst>
+          </p:cNvPr>
+          <p:cNvSpPr txBox="1"/>
+          <p:nvPr/>
+        </p:nvSpPr>
+        <p:spPr>
+          <a:xfrm>
+            <a:off x="8047973" y="1884443"/>
+            <a:ext cx="3977013" cy="1015663"/>
+          </a:xfrm>
+          <a:prstGeom prst="rect">
+            <a:avLst/>
+          </a:prstGeom>
+          <a:noFill/>
+        </p:spPr>
+        <p:txBody>
+          <a:bodyPr wrap="square" rtlCol="0">
+            <a:spAutoFit/>
+          </a:bodyPr>
+          <a:lstStyle/>
+          <a:p>
+            <a:r>
+              <a:rPr lang="en-US" altLang="ko-KR" sz="1000"/>
+              <a:t>※Elasticsearch</a:t>
+            </a:r>
+            <a:r>
+              <a:rPr lang="ko-KR" altLang="en-US" sz="1000"/>
+              <a:t>의 검색기능은 </a:t>
+            </a:r>
+            <a:r>
+              <a:rPr lang="en-US" altLang="ko-KR" sz="1000"/>
+              <a:t>ElasticsearchOperations </a:t>
+            </a:r>
+            <a:r>
+              <a:rPr lang="ko-KR" altLang="en-US" sz="1000"/>
+              <a:t>를 사용한다</a:t>
+            </a:r>
+            <a:r>
+              <a:rPr lang="en-US" altLang="ko-KR" sz="1000"/>
+              <a:t>.</a:t>
+            </a:r>
+          </a:p>
+          <a:p>
+            <a:endParaRPr lang="en-US" altLang="ko-KR" sz="1000"/>
+          </a:p>
+          <a:p>
+            <a:pPr marL="228600" indent="-228600">
+              <a:buAutoNum type="arabicPeriod"/>
+            </a:pPr>
+            <a:r>
+              <a:rPr lang="en-US" altLang="ko-KR" sz="1000"/>
+              <a:t>elasticsearch</a:t>
+            </a:r>
+            <a:r>
+              <a:rPr lang="ko-KR" altLang="en-US" sz="1000"/>
+              <a:t>의 검색 요청을 위한 </a:t>
+            </a:r>
+            <a:r>
+              <a:rPr lang="en-US" altLang="ko-KR" sz="1000"/>
+              <a:t>ElasticsearchOperations </a:t>
+            </a:r>
+            <a:br>
+              <a:rPr lang="en-US" altLang="ko-KR" sz="1000"/>
+            </a:br>
+            <a:r>
+              <a:rPr lang="en-US" altLang="ko-KR" sz="1000"/>
+              <a:t>Bean </a:t>
+            </a:r>
+            <a:r>
+              <a:rPr lang="ko-KR" altLang="en-US" sz="1000"/>
+              <a:t>생성자 주입 </a:t>
+            </a:r>
+            <a:endParaRPr lang="en-US" altLang="ko-KR" sz="1000"/>
+          </a:p>
+          <a:p>
+            <a:pPr marL="228600" indent="-228600">
+              <a:buAutoNum type="arabicPeriod"/>
+            </a:pPr>
+            <a:endParaRPr lang="en-US" altLang="ko-KR" sz="1000"/>
+          </a:p>
+          <a:p>
+            <a:pPr marL="228600" indent="-228600">
+              <a:buAutoNum type="arabicPeriod"/>
+            </a:pPr>
+            <a:endParaRPr lang="ko-KR" altLang="en-US" sz="1000"/>
+          </a:p>
+        </p:txBody>
+      </p:sp>
+      <p:sp>
+        <p:nvSpPr>
+          <p:cNvPr id="12" name="TextBox 11">
+            <a:extLst>
+              <a:ext uri="{FF2B5EF4-FFF2-40B4-BE49-F238E27FC236}">
+                <a16:creationId xmlns:a16="http://schemas.microsoft.com/office/drawing/2014/main" id="{AF394FC3-BE22-6EA7-932A-C7AB2B762244}"/>
+              </a:ext>
+            </a:extLst>
+          </p:cNvPr>
+          <p:cNvSpPr txBox="1"/>
+          <p:nvPr/>
+        </p:nvSpPr>
+        <p:spPr>
+          <a:xfrm>
+            <a:off x="9750175" y="3867576"/>
+            <a:ext cx="2441825" cy="3046988"/>
+          </a:xfrm>
+          <a:prstGeom prst="rect">
+            <a:avLst/>
+          </a:prstGeom>
+          <a:noFill/>
+        </p:spPr>
+        <p:txBody>
+          <a:bodyPr wrap="square" rtlCol="0">
+            <a:spAutoFit/>
+          </a:bodyPr>
+          <a:lstStyle/>
+          <a:p>
+            <a:r>
+              <a:rPr lang="en-US" altLang="ko-KR" sz="800"/>
+              <a:t>2. </a:t>
+            </a:r>
+            <a:r>
+              <a:rPr lang="ko-KR" altLang="en-US" sz="800"/>
+              <a:t>검색을 위한 </a:t>
+            </a:r>
+            <a:r>
+              <a:rPr lang="en-US" altLang="ko-KR" sz="800"/>
+              <a:t>Query</a:t>
+            </a:r>
+            <a:r>
+              <a:rPr lang="ko-KR" altLang="en-US" sz="800"/>
+              <a:t>를 작성한다</a:t>
+            </a:r>
+            <a:r>
+              <a:rPr lang="en-US" altLang="ko-KR" sz="800"/>
+              <a:t>.</a:t>
+            </a:r>
+            <a:br>
+              <a:rPr lang="en-US" altLang="ko-KR" sz="800"/>
+            </a:br>
+            <a:r>
+              <a:rPr lang="en-US" altLang="ko-KR" sz="800"/>
+              <a:t>     </a:t>
+            </a:r>
+            <a:r>
+              <a:rPr lang="ko-KR" altLang="en-US" sz="800"/>
+              <a:t>멀티 검색조건 </a:t>
+            </a:r>
+            <a:r>
+              <a:rPr lang="en-US" altLang="ko-KR" sz="800"/>
+              <a:t>MultiMatchQuery</a:t>
+            </a:r>
+            <a:r>
+              <a:rPr lang="ko-KR" altLang="en-US" sz="800"/>
+              <a:t>작성</a:t>
+            </a:r>
+            <a:endParaRPr lang="en-US" altLang="ko-KR" sz="800"/>
+          </a:p>
+          <a:p>
+            <a:r>
+              <a:rPr lang="en-US" altLang="ko-KR" sz="800"/>
+              <a:t>     (Query</a:t>
+            </a:r>
+            <a:r>
+              <a:rPr lang="ko-KR" altLang="en-US" sz="800"/>
+              <a:t>는 </a:t>
+            </a:r>
+            <a:r>
+              <a:rPr lang="en-US" altLang="ko-KR" sz="800"/>
+              <a:t>MultiMatchQuery, BoolQuery, </a:t>
+            </a:r>
+            <a:br>
+              <a:rPr lang="en-US" altLang="ko-KR" sz="800"/>
+            </a:br>
+            <a:r>
+              <a:rPr lang="en-US" altLang="ko-KR" sz="800"/>
+              <a:t>      TermQuery </a:t>
+            </a:r>
+            <a:r>
+              <a:rPr lang="ko-KR" altLang="en-US" sz="800"/>
+              <a:t>등을 포괄하여 </a:t>
+            </a:r>
+            <a:br>
+              <a:rPr lang="en-US" altLang="ko-KR" sz="800"/>
+            </a:br>
+            <a:r>
+              <a:rPr lang="en-US" altLang="ko-KR" sz="800"/>
+              <a:t>      </a:t>
+            </a:r>
+            <a:r>
+              <a:rPr lang="ko-KR" altLang="en-US" sz="800"/>
+              <a:t>받을수 있는 부모 클래스이다</a:t>
+            </a:r>
+            <a:r>
+              <a:rPr lang="en-US" altLang="ko-KR" sz="800"/>
+              <a:t>.)</a:t>
+            </a:r>
+          </a:p>
+          <a:p>
+            <a:endParaRPr lang="en-US" altLang="ko-KR" sz="800"/>
+          </a:p>
+          <a:p>
+            <a:r>
+              <a:rPr lang="en-US" altLang="ko-KR" sz="800"/>
+              <a:t>3. MultiMatchQuery</a:t>
+            </a:r>
+            <a:r>
+              <a:rPr lang="ko-KR" altLang="en-US" sz="800"/>
+              <a:t>의 </a:t>
+            </a:r>
+            <a:r>
+              <a:rPr lang="en-US" altLang="ko-KR" sz="800"/>
+              <a:t>of </a:t>
+            </a:r>
+            <a:r>
+              <a:rPr lang="ko-KR" altLang="en-US" sz="800"/>
+              <a:t>의 </a:t>
+            </a:r>
+            <a:r>
+              <a:rPr lang="en-US" altLang="ko-KR" sz="800"/>
+              <a:t>m </a:t>
+            </a:r>
+            <a:r>
+              <a:rPr lang="ko-KR" altLang="en-US" sz="800"/>
+              <a:t>은 </a:t>
+            </a:r>
+            <a:br>
+              <a:rPr lang="en-US" altLang="ko-KR" sz="800"/>
+            </a:br>
+            <a:r>
+              <a:rPr lang="en-US" altLang="ko-KR" sz="800"/>
+              <a:t>    </a:t>
+            </a:r>
+            <a:r>
+              <a:rPr lang="ko-KR" altLang="en-US" sz="800"/>
+              <a:t>조회 쿼리에서 </a:t>
+            </a:r>
+            <a:r>
+              <a:rPr lang="en-US" altLang="ko-KR" sz="800"/>
+              <a:t>multi_match</a:t>
+            </a:r>
+            <a:r>
+              <a:rPr lang="ko-KR" altLang="en-US" sz="800"/>
+              <a:t> 를 의미하며</a:t>
+            </a:r>
+            <a:r>
+              <a:rPr lang="en-US" altLang="ko-KR" sz="800"/>
+              <a:t>,</a:t>
+            </a:r>
+            <a:br>
+              <a:rPr lang="en-US" altLang="ko-KR" sz="800"/>
+            </a:br>
+            <a:r>
+              <a:rPr lang="en-US" altLang="ko-KR" sz="800"/>
+              <a:t>    query / type / fields </a:t>
+            </a:r>
+            <a:r>
+              <a:rPr lang="ko-KR" altLang="en-US" sz="800"/>
+              <a:t>를 동일한 이름의 </a:t>
+            </a:r>
+            <a:br>
+              <a:rPr lang="en-US" altLang="ko-KR" sz="800"/>
+            </a:br>
+            <a:r>
+              <a:rPr lang="en-US" altLang="ko-KR" sz="800"/>
+              <a:t>    </a:t>
+            </a:r>
+            <a:r>
+              <a:rPr lang="ko-KR" altLang="en-US" sz="800"/>
+              <a:t>메소드로 정의한다</a:t>
+            </a:r>
+            <a:r>
+              <a:rPr lang="en-US" altLang="ko-KR" sz="800"/>
+              <a:t>.</a:t>
+            </a:r>
+          </a:p>
+          <a:p>
+            <a:endParaRPr lang="en-US" altLang="ko-KR" sz="800"/>
+          </a:p>
+          <a:p>
+            <a:r>
+              <a:rPr lang="en-US" altLang="ko-KR" sz="800"/>
+              <a:t>4. NativeQuery </a:t>
+            </a:r>
+            <a:r>
+              <a:rPr lang="ko-KR" altLang="en-US" sz="800"/>
+              <a:t>는 조회쿼리에서 </a:t>
+            </a:r>
+            <a:r>
+              <a:rPr lang="en-US" altLang="ko-KR" sz="800"/>
+              <a:t>query</a:t>
+            </a:r>
+            <a:r>
+              <a:rPr lang="ko-KR" altLang="en-US" sz="800"/>
+              <a:t>에 </a:t>
+            </a:r>
+            <a:br>
+              <a:rPr lang="en-US" altLang="ko-KR" sz="800"/>
+            </a:br>
+            <a:r>
+              <a:rPr lang="en-US" altLang="ko-KR" sz="800"/>
+              <a:t>    </a:t>
+            </a:r>
+            <a:r>
+              <a:rPr lang="ko-KR" altLang="en-US" sz="800"/>
+              <a:t>해당한다 </a:t>
+            </a:r>
+            <a:r>
+              <a:rPr lang="en-US" altLang="ko-KR" sz="800"/>
+              <a:t>. </a:t>
+            </a:r>
+            <a:r>
+              <a:rPr lang="ko-KR" altLang="en-US" sz="800"/>
+              <a:t>정의한 </a:t>
+            </a:r>
+            <a:r>
+              <a:rPr lang="en-US" altLang="ko-KR" sz="800"/>
+              <a:t>MultiMatchQuery</a:t>
+            </a:r>
+            <a:r>
+              <a:rPr lang="ko-KR" altLang="en-US" sz="800"/>
+              <a:t>를 </a:t>
+            </a:r>
+            <a:br>
+              <a:rPr lang="en-US" altLang="ko-KR" sz="800"/>
+            </a:br>
+            <a:r>
+              <a:rPr lang="en-US" altLang="ko-KR" sz="800"/>
+              <a:t>    </a:t>
+            </a:r>
+            <a:r>
+              <a:rPr lang="ko-KR" altLang="en-US" sz="800"/>
+              <a:t>셋팅</a:t>
+            </a:r>
+            <a:r>
+              <a:rPr lang="en-US" altLang="ko-KR" sz="800"/>
+              <a:t>(= .withQuery )</a:t>
+            </a:r>
+            <a:r>
+              <a:rPr lang="ko-KR" altLang="en-US" sz="800"/>
+              <a:t>하고 </a:t>
+            </a:r>
+            <a:br>
+              <a:rPr lang="en-US" altLang="ko-KR" sz="800"/>
+            </a:br>
+            <a:r>
+              <a:rPr lang="en-US" altLang="ko-KR" sz="800"/>
+              <a:t>    </a:t>
+            </a:r>
+            <a:r>
+              <a:rPr lang="ko-KR" altLang="en-US" sz="800"/>
+              <a:t>결과를 </a:t>
+            </a:r>
+            <a:r>
+              <a:rPr lang="en-US" altLang="ko-KR" sz="800"/>
+              <a:t>5</a:t>
+            </a:r>
+            <a:r>
+              <a:rPr lang="ko-KR" altLang="en-US" sz="800"/>
+              <a:t>개만 반환하기 위해 </a:t>
+            </a:r>
+            <a:br>
+              <a:rPr lang="en-US" altLang="ko-KR" sz="800"/>
+            </a:br>
+            <a:r>
+              <a:rPr lang="en-US" altLang="ko-KR" sz="800"/>
+              <a:t>     page</a:t>
+            </a:r>
+            <a:r>
+              <a:rPr lang="ko-KR" altLang="en-US" sz="800"/>
+              <a:t>처리</a:t>
+            </a:r>
+            <a:r>
+              <a:rPr lang="en-US" altLang="ko-KR" sz="800"/>
+              <a:t>(=.withPageable())</a:t>
+            </a:r>
+            <a:r>
+              <a:rPr lang="ko-KR" altLang="en-US" sz="800"/>
+              <a:t>를 한다</a:t>
+            </a:r>
+            <a:r>
+              <a:rPr lang="en-US" altLang="ko-KR" sz="800"/>
+              <a:t>.</a:t>
+            </a:r>
+          </a:p>
+          <a:p>
+            <a:endParaRPr lang="en-US" altLang="ko-KR" sz="800"/>
+          </a:p>
+          <a:p>
+            <a:r>
+              <a:rPr lang="en-US" altLang="ko-KR" sz="800"/>
+              <a:t>5. searchHits.getSearchHits()</a:t>
+            </a:r>
+            <a:r>
+              <a:rPr lang="ko-KR" altLang="en-US" sz="800"/>
+              <a:t>는 검색조건에 </a:t>
+            </a:r>
+            <a:br>
+              <a:rPr lang="en-US" altLang="ko-KR" sz="800"/>
+            </a:br>
+            <a:r>
+              <a:rPr lang="en-US" altLang="ko-KR" sz="800"/>
+              <a:t>    </a:t>
+            </a:r>
+            <a:r>
+              <a:rPr lang="ko-KR" altLang="en-US" sz="800"/>
+              <a:t>맞는 정보를 가져오는 행위이며</a:t>
+            </a:r>
+            <a:r>
+              <a:rPr lang="en-US" altLang="ko-KR" sz="800"/>
+              <a:t>, </a:t>
+            </a:r>
+            <a:r>
+              <a:rPr lang="ko-KR" altLang="en-US" sz="800"/>
+              <a:t>정의한 </a:t>
+            </a:r>
+            <a:br>
+              <a:rPr lang="en-US" altLang="ko-KR" sz="800"/>
+            </a:br>
+            <a:r>
+              <a:rPr lang="en-US" altLang="ko-KR" sz="800"/>
+              <a:t>    Document  </a:t>
+            </a:r>
+            <a:r>
+              <a:rPr lang="ko-KR" altLang="en-US" sz="800"/>
+              <a:t>맵핑을 위해 </a:t>
+            </a:r>
+            <a:r>
+              <a:rPr lang="en-US" altLang="ko-KR" sz="800"/>
+              <a:t>.steam().map() </a:t>
+            </a:r>
+            <a:br>
+              <a:rPr lang="en-US" altLang="ko-KR" sz="800"/>
+            </a:br>
+            <a:r>
+              <a:rPr lang="en-US" altLang="ko-KR" sz="800"/>
+              <a:t>    </a:t>
+            </a:r>
+            <a:r>
+              <a:rPr lang="ko-KR" altLang="en-US" sz="800"/>
+              <a:t>모든 </a:t>
+            </a:r>
+            <a:r>
+              <a:rPr lang="en-US" altLang="ko-KR" sz="800"/>
+              <a:t>Document </a:t>
+            </a:r>
+            <a:r>
+              <a:rPr lang="ko-KR" altLang="en-US" sz="800"/>
+              <a:t>요소들의 상품명 만을 </a:t>
+            </a:r>
+            <a:br>
+              <a:rPr lang="en-US" altLang="ko-KR" sz="800"/>
+            </a:br>
+            <a:r>
+              <a:rPr lang="en-US" altLang="ko-KR" sz="800"/>
+              <a:t>    </a:t>
+            </a:r>
+            <a:r>
+              <a:rPr lang="ko-KR" altLang="en-US" sz="800"/>
+              <a:t>뽑기 위해 </a:t>
+            </a:r>
+            <a:r>
+              <a:rPr lang="en-US" altLang="ko-KR" sz="800"/>
+              <a:t>.getContent().getName()</a:t>
+            </a:r>
+            <a:br>
+              <a:rPr lang="en-US" altLang="ko-KR" sz="800"/>
+            </a:br>
+            <a:r>
+              <a:rPr lang="en-US" altLang="ko-KR" sz="800"/>
+              <a:t> </a:t>
+            </a:r>
+            <a:r>
+              <a:rPr lang="ko-KR" altLang="en-US" sz="800"/>
+              <a:t>   리스트로 의 반환을 위해 </a:t>
+            </a:r>
+            <a:r>
+              <a:rPr lang="en-US" altLang="ko-KR" sz="800"/>
+              <a:t>.toList()</a:t>
+            </a:r>
+            <a:r>
+              <a:rPr lang="ko-KR" altLang="en-US" sz="800"/>
+              <a:t>를 사용한다</a:t>
+            </a:r>
+            <a:r>
+              <a:rPr lang="en-US" altLang="ko-KR" sz="800"/>
+              <a:t>.</a:t>
+            </a:r>
+            <a:br>
+              <a:rPr lang="en-US" altLang="ko-KR" sz="800"/>
+            </a:br>
+            <a:r>
+              <a:rPr lang="en-US" altLang="ko-KR" sz="800"/>
+              <a:t>    </a:t>
+            </a:r>
+          </a:p>
+        </p:txBody>
+      </p:sp>
+      <p:pic>
+        <p:nvPicPr>
+          <p:cNvPr id="14" name="그림 13">
+            <a:extLst>
+              <a:ext uri="{FF2B5EF4-FFF2-40B4-BE49-F238E27FC236}">
+                <a16:creationId xmlns:a16="http://schemas.microsoft.com/office/drawing/2014/main" id="{AE5A1B6B-D3CD-F75C-0ADB-589A948F8032}"/>
+              </a:ext>
+            </a:extLst>
+          </p:cNvPr>
+          <p:cNvPicPr>
+            <a:picLocks noChangeAspect="1"/>
+          </p:cNvPicPr>
+          <p:nvPr/>
+        </p:nvPicPr>
+        <p:blipFill>
+          <a:blip r:embed="rId5"/>
+          <a:stretch>
+            <a:fillRect/>
+          </a:stretch>
+        </p:blipFill>
+        <p:spPr>
+          <a:xfrm>
+            <a:off x="8099692" y="2760231"/>
+            <a:ext cx="3818824" cy="1057436"/>
+          </a:xfrm>
+          <a:prstGeom prst="rect">
+            <a:avLst/>
+          </a:prstGeom>
+        </p:spPr>
+      </p:pic>
+    </p:spTree>
+    <p:extLst>
+      <p:ext uri="{BB962C8B-B14F-4D97-AF65-F5344CB8AC3E}">
+        <p14:creationId xmlns:p14="http://schemas.microsoft.com/office/powerpoint/2010/main" val="1725924694"/>
       </p:ext>
     </p:extLst>
   </p:cSld>

</xml_diff>

<commit_message>
feat : 검색 기능(kibana검색쿼리) SpringBoot 작성
</commit_message>
<xml_diff>
--- a/ppt/7.SpringBoot - ElasticSearch 도입.pptx
+++ b/ppt/7.SpringBoot - ElasticSearch 도입.pptx
@@ -5,7 +5,7 @@
     <p:sldMasterId id="2147483660" r:id="rId1"/>
   </p:sldMasterIdLst>
   <p:notesMasterIdLst>
-    <p:notesMasterId r:id="rId22"/>
+    <p:notesMasterId r:id="rId27"/>
   </p:notesMasterIdLst>
   <p:sldIdLst>
     <p:sldId id="256" r:id="rId2"/>
@@ -28,6 +28,11 @@
     <p:sldId id="274" r:id="rId19"/>
     <p:sldId id="275" r:id="rId20"/>
     <p:sldId id="276" r:id="rId21"/>
+    <p:sldId id="277" r:id="rId22"/>
+    <p:sldId id="278" r:id="rId23"/>
+    <p:sldId id="279" r:id="rId24"/>
+    <p:sldId id="280" r:id="rId25"/>
+    <p:sldId id="281" r:id="rId26"/>
   </p:sldIdLst>
   <p:sldSz cx="12192000" cy="6858000"/>
   <p:notesSz cx="7105650" cy="10236200"/>
@@ -179,6 +184,15 @@
           <p14:sldIdLst>
             <p14:sldId id="275"/>
             <p14:sldId id="276"/>
+          </p14:sldIdLst>
+        </p14:section>
+        <p14:section name="검색기능 구현" id="{186DEF88-0874-4EC2-BCEC-6419E0CC96F5}">
+          <p14:sldIdLst>
+            <p14:sldId id="277"/>
+            <p14:sldId id="278"/>
+            <p14:sldId id="279"/>
+            <p14:sldId id="280"/>
+            <p14:sldId id="281"/>
           </p14:sldIdLst>
         </p14:section>
       </p14:sectionLst>
@@ -11345,6 +11359,3233 @@
 </p:sld>
 </file>
 
+<file path=ppt/slides/slide21.xml><?xml version="1.0" encoding="utf-8"?>
+<p:sld xmlns:a="http://schemas.openxmlformats.org/drawingml/2006/main" xmlns:r="http://schemas.openxmlformats.org/officeDocument/2006/relationships" xmlns:p="http://schemas.openxmlformats.org/presentationml/2006/main">
+  <p:cSld>
+    <p:spTree>
+      <p:nvGrpSpPr>
+        <p:cNvPr id="1" name=""/>
+        <p:cNvGrpSpPr/>
+        <p:nvPr/>
+      </p:nvGrpSpPr>
+      <p:grpSpPr>
+        <a:xfrm>
+          <a:off x="0" y="0"/>
+          <a:ext cx="0" cy="0"/>
+          <a:chOff x="0" y="0"/>
+          <a:chExt cx="0" cy="0"/>
+        </a:xfrm>
+      </p:grpSpPr>
+      <p:sp>
+        <p:nvSpPr>
+          <p:cNvPr id="2" name="제목 1">
+            <a:extLst>
+              <a:ext uri="{FF2B5EF4-FFF2-40B4-BE49-F238E27FC236}">
+                <a16:creationId xmlns:a16="http://schemas.microsoft.com/office/drawing/2014/main" id="{B4E1C4CF-EFF1-B053-444D-F43040CB25B3}"/>
+              </a:ext>
+            </a:extLst>
+          </p:cNvPr>
+          <p:cNvSpPr>
+            <a:spLocks noGrp="1"/>
+          </p:cNvSpPr>
+          <p:nvPr>
+            <p:ph type="title"/>
+          </p:nvPr>
+        </p:nvSpPr>
+        <p:spPr/>
+        <p:txBody>
+          <a:bodyPr/>
+          <a:lstStyle/>
+          <a:p>
+            <a:r>
+              <a:rPr lang="ko-KR" altLang="en-US"/>
+              <a:t>검색 </a:t>
+            </a:r>
+            <a:r>
+              <a:rPr lang="en-US" altLang="ko-KR"/>
+              <a:t>URL </a:t>
+            </a:r>
+            <a:r>
+              <a:rPr lang="ko-KR" altLang="en-US"/>
+              <a:t>작성 </a:t>
+            </a:r>
+            <a:r>
+              <a:rPr lang="en-US" altLang="ko-KR"/>
+              <a:t>- ProductController</a:t>
+            </a:r>
+            <a:endParaRPr lang="ko-KR" altLang="en-US"/>
+          </a:p>
+        </p:txBody>
+      </p:sp>
+      <p:pic>
+        <p:nvPicPr>
+          <p:cNvPr id="4" name="그림 3">
+            <a:extLst>
+              <a:ext uri="{FF2B5EF4-FFF2-40B4-BE49-F238E27FC236}">
+                <a16:creationId xmlns:a16="http://schemas.microsoft.com/office/drawing/2014/main" id="{D026E97C-28FF-860A-3E23-9BDC68B2E217}"/>
+              </a:ext>
+            </a:extLst>
+          </p:cNvPr>
+          <p:cNvPicPr>
+            <a:picLocks noChangeAspect="1"/>
+          </p:cNvPicPr>
+          <p:nvPr/>
+        </p:nvPicPr>
+        <p:blipFill>
+          <a:blip r:embed="rId2"/>
+          <a:stretch>
+            <a:fillRect/>
+          </a:stretch>
+        </p:blipFill>
+        <p:spPr>
+          <a:xfrm>
+            <a:off x="4216423" y="2086293"/>
+            <a:ext cx="6820852" cy="3877216"/>
+          </a:xfrm>
+          <a:prstGeom prst="rect">
+            <a:avLst/>
+          </a:prstGeom>
+        </p:spPr>
+      </p:pic>
+      <p:grpSp>
+        <p:nvGrpSpPr>
+          <p:cNvPr id="8" name="그룹 7">
+            <a:extLst>
+              <a:ext uri="{FF2B5EF4-FFF2-40B4-BE49-F238E27FC236}">
+                <a16:creationId xmlns:a16="http://schemas.microsoft.com/office/drawing/2014/main" id="{21E7F5BC-72AA-103F-AC2F-F4CF6D4D1D2D}"/>
+              </a:ext>
+            </a:extLst>
+          </p:cNvPr>
+          <p:cNvGrpSpPr/>
+          <p:nvPr/>
+        </p:nvGrpSpPr>
+        <p:grpSpPr>
+          <a:xfrm>
+            <a:off x="1286381" y="2086293"/>
+            <a:ext cx="2715004" cy="3829584"/>
+            <a:chOff x="1286381" y="2086293"/>
+            <a:chExt cx="2715004" cy="3829584"/>
+          </a:xfrm>
+        </p:grpSpPr>
+        <p:pic>
+          <p:nvPicPr>
+            <p:cNvPr id="6" name="그림 5">
+              <a:extLst>
+                <a:ext uri="{FF2B5EF4-FFF2-40B4-BE49-F238E27FC236}">
+                  <a16:creationId xmlns:a16="http://schemas.microsoft.com/office/drawing/2014/main" id="{1A8F232B-9913-5FC2-9906-8C61DAF39F84}"/>
+                </a:ext>
+              </a:extLst>
+            </p:cNvPr>
+            <p:cNvPicPr>
+              <a:picLocks noChangeAspect="1"/>
+            </p:cNvPicPr>
+            <p:nvPr/>
+          </p:nvPicPr>
+          <p:blipFill>
+            <a:blip r:embed="rId3"/>
+            <a:stretch>
+              <a:fillRect/>
+            </a:stretch>
+          </p:blipFill>
+          <p:spPr>
+            <a:xfrm>
+              <a:off x="1286381" y="2086293"/>
+              <a:ext cx="2715004" cy="3829584"/>
+            </a:xfrm>
+            <a:prstGeom prst="rect">
+              <a:avLst/>
+            </a:prstGeom>
+          </p:spPr>
+        </p:pic>
+        <p:sp>
+          <p:nvSpPr>
+            <p:cNvPr id="7" name="직사각형 6">
+              <a:extLst>
+                <a:ext uri="{FF2B5EF4-FFF2-40B4-BE49-F238E27FC236}">
+                  <a16:creationId xmlns:a16="http://schemas.microsoft.com/office/drawing/2014/main" id="{8D71E875-120F-BE08-8012-E9080F77B7E7}"/>
+                </a:ext>
+              </a:extLst>
+            </p:cNvPr>
+            <p:cNvSpPr/>
+            <p:nvPr/>
+          </p:nvSpPr>
+          <p:spPr>
+            <a:xfrm>
+              <a:off x="1571946" y="5661061"/>
+              <a:ext cx="1458930" cy="254816"/>
+            </a:xfrm>
+            <a:prstGeom prst="rect">
+              <a:avLst/>
+            </a:prstGeom>
+            <a:noFill/>
+            <a:ln>
+              <a:solidFill>
+                <a:srgbClr val="FF0000"/>
+              </a:solidFill>
+            </a:ln>
+          </p:spPr>
+          <p:style>
+            <a:lnRef idx="2">
+              <a:schemeClr val="accent1">
+                <a:shade val="15000"/>
+              </a:schemeClr>
+            </a:lnRef>
+            <a:fillRef idx="1">
+              <a:schemeClr val="accent1"/>
+            </a:fillRef>
+            <a:effectRef idx="0">
+              <a:schemeClr val="accent1"/>
+            </a:effectRef>
+            <a:fontRef idx="minor">
+              <a:schemeClr val="lt1"/>
+            </a:fontRef>
+          </p:style>
+          <p:txBody>
+            <a:bodyPr rtlCol="0" anchor="ctr"/>
+            <a:lstStyle/>
+            <a:p>
+              <a:pPr algn="ctr"/>
+              <a:endParaRPr lang="ko-KR" altLang="en-US"/>
+            </a:p>
+          </p:txBody>
+        </p:sp>
+      </p:grpSp>
+      <p:sp>
+        <p:nvSpPr>
+          <p:cNvPr id="9" name="직사각형 8">
+            <a:extLst>
+              <a:ext uri="{FF2B5EF4-FFF2-40B4-BE49-F238E27FC236}">
+                <a16:creationId xmlns:a16="http://schemas.microsoft.com/office/drawing/2014/main" id="{3E7D8119-7D72-D537-DD76-24C171882A6A}"/>
+              </a:ext>
+            </a:extLst>
+          </p:cNvPr>
+          <p:cNvSpPr/>
+          <p:nvPr/>
+        </p:nvSpPr>
+        <p:spPr>
+          <a:xfrm>
+            <a:off x="6760396" y="4315146"/>
+            <a:ext cx="4276879" cy="1202076"/>
+          </a:xfrm>
+          <a:prstGeom prst="rect">
+            <a:avLst/>
+          </a:prstGeom>
+          <a:solidFill>
+            <a:schemeClr val="bg1"/>
+          </a:solidFill>
+        </p:spPr>
+        <p:style>
+          <a:lnRef idx="2">
+            <a:schemeClr val="accent1">
+              <a:shade val="15000"/>
+            </a:schemeClr>
+          </a:lnRef>
+          <a:fillRef idx="1">
+            <a:schemeClr val="accent1"/>
+          </a:fillRef>
+          <a:effectRef idx="0">
+            <a:schemeClr val="accent1"/>
+          </a:effectRef>
+          <a:fontRef idx="minor">
+            <a:schemeClr val="lt1"/>
+          </a:fontRef>
+        </p:style>
+        <p:txBody>
+          <a:bodyPr rtlCol="0" anchor="ctr"/>
+          <a:lstStyle/>
+          <a:p>
+            <a:pPr algn="ctr"/>
+            <a:r>
+              <a:rPr lang="en-US" altLang="ko-KR" sz="1050">
+                <a:solidFill>
+                  <a:schemeClr val="tx1"/>
+                </a:solidFill>
+              </a:rPr>
+              <a:t>query </a:t>
+            </a:r>
+            <a:r>
+              <a:rPr lang="en-US" altLang="ko-KR" sz="1050">
+                <a:solidFill>
+                  <a:schemeClr val="tx1"/>
+                </a:solidFill>
+                <a:sym typeface="Wingdings" panose="05000000000000000000" pitchFamily="2" charset="2"/>
+              </a:rPr>
+              <a:t> </a:t>
+            </a:r>
+            <a:r>
+              <a:rPr lang="ko-KR" altLang="en-US" sz="1050">
+                <a:solidFill>
+                  <a:schemeClr val="tx1"/>
+                </a:solidFill>
+                <a:sym typeface="Wingdings" panose="05000000000000000000" pitchFamily="2" charset="2"/>
+              </a:rPr>
+              <a:t>검색할 문자열</a:t>
+            </a:r>
+            <a:r>
+              <a:rPr lang="en-US" altLang="ko-KR" sz="1050">
+                <a:solidFill>
+                  <a:schemeClr val="tx1"/>
+                </a:solidFill>
+                <a:sym typeface="Wingdings" panose="05000000000000000000" pitchFamily="2" charset="2"/>
+              </a:rPr>
+              <a:t>(</a:t>
+            </a:r>
+            <a:r>
+              <a:rPr lang="ko-KR" altLang="en-US" sz="1050">
+                <a:solidFill>
+                  <a:schemeClr val="tx1"/>
+                </a:solidFill>
+                <a:sym typeface="Wingdings" panose="05000000000000000000" pitchFamily="2" charset="2"/>
+              </a:rPr>
+              <a:t>상품명</a:t>
+            </a:r>
+            <a:r>
+              <a:rPr lang="en-US" altLang="ko-KR" sz="1050">
+                <a:solidFill>
+                  <a:schemeClr val="tx1"/>
+                </a:solidFill>
+                <a:sym typeface="Wingdings" panose="05000000000000000000" pitchFamily="2" charset="2"/>
+              </a:rPr>
+              <a:t>)</a:t>
+            </a:r>
+          </a:p>
+          <a:p>
+            <a:pPr algn="ctr"/>
+            <a:r>
+              <a:rPr lang="en-US" altLang="ko-KR" sz="1050">
+                <a:solidFill>
+                  <a:schemeClr val="tx1"/>
+                </a:solidFill>
+                <a:sym typeface="Wingdings" panose="05000000000000000000" pitchFamily="2" charset="2"/>
+              </a:rPr>
+              <a:t>category</a:t>
+            </a:r>
+            <a:r>
+              <a:rPr lang="ko-KR" altLang="en-US" sz="1050">
+                <a:solidFill>
+                  <a:schemeClr val="tx1"/>
+                </a:solidFill>
+                <a:sym typeface="Wingdings" panose="05000000000000000000" pitchFamily="2" charset="2"/>
+              </a:rPr>
+              <a:t> </a:t>
+            </a:r>
+            <a:r>
+              <a:rPr lang="en-US" altLang="ko-KR" sz="1050">
+                <a:solidFill>
+                  <a:schemeClr val="tx1"/>
+                </a:solidFill>
+                <a:sym typeface="Wingdings" panose="05000000000000000000" pitchFamily="2" charset="2"/>
+              </a:rPr>
+              <a:t></a:t>
+            </a:r>
+            <a:r>
+              <a:rPr lang="ko-KR" altLang="en-US" sz="1050">
+                <a:solidFill>
+                  <a:schemeClr val="tx1"/>
+                </a:solidFill>
+                <a:sym typeface="Wingdings" panose="05000000000000000000" pitchFamily="2" charset="2"/>
+              </a:rPr>
+              <a:t> </a:t>
+            </a:r>
+            <a:r>
+              <a:rPr lang="en-US" altLang="ko-KR" sz="1050">
+                <a:solidFill>
+                  <a:schemeClr val="tx1"/>
+                </a:solidFill>
+                <a:sym typeface="Wingdings" panose="05000000000000000000" pitchFamily="2" charset="2"/>
+              </a:rPr>
+              <a:t>text,</a:t>
+            </a:r>
+            <a:r>
+              <a:rPr lang="ko-KR" altLang="en-US" sz="1050">
+                <a:solidFill>
+                  <a:schemeClr val="tx1"/>
+                </a:solidFill>
+                <a:sym typeface="Wingdings" panose="05000000000000000000" pitchFamily="2" charset="2"/>
+              </a:rPr>
+              <a:t> </a:t>
+            </a:r>
+            <a:r>
+              <a:rPr lang="en-US" altLang="ko-KR" sz="1050">
+                <a:solidFill>
+                  <a:schemeClr val="tx1"/>
+                </a:solidFill>
+                <a:sym typeface="Wingdings" panose="05000000000000000000" pitchFamily="2" charset="2"/>
+              </a:rPr>
+              <a:t>keyword</a:t>
+            </a:r>
+            <a:r>
+              <a:rPr lang="ko-KR" altLang="en-US" sz="1050">
+                <a:solidFill>
+                  <a:schemeClr val="tx1"/>
+                </a:solidFill>
+                <a:sym typeface="Wingdings" panose="05000000000000000000" pitchFamily="2" charset="2"/>
+              </a:rPr>
+              <a:t> 멀티 필드 검색 유형 파라미터</a:t>
+            </a:r>
+            <a:r>
+              <a:rPr lang="en-US" altLang="ko-KR" sz="1050">
+                <a:solidFill>
+                  <a:schemeClr val="tx1"/>
+                </a:solidFill>
+                <a:sym typeface="Wingdings" panose="05000000000000000000" pitchFamily="2" charset="2"/>
+              </a:rPr>
+              <a:t>(</a:t>
+            </a:r>
+            <a:r>
+              <a:rPr lang="ko-KR" altLang="en-US" sz="1050">
+                <a:solidFill>
+                  <a:schemeClr val="tx1"/>
+                </a:solidFill>
+                <a:sym typeface="Wingdings" panose="05000000000000000000" pitchFamily="2" charset="2"/>
+              </a:rPr>
+              <a:t>문자열</a:t>
+            </a:r>
+            <a:r>
+              <a:rPr lang="en-US" altLang="ko-KR" sz="1050">
+                <a:solidFill>
+                  <a:schemeClr val="tx1"/>
+                </a:solidFill>
+                <a:sym typeface="Wingdings" panose="05000000000000000000" pitchFamily="2" charset="2"/>
+              </a:rPr>
+              <a:t>)</a:t>
+            </a:r>
+          </a:p>
+          <a:p>
+            <a:pPr algn="ctr"/>
+            <a:r>
+              <a:rPr lang="en-US" altLang="ko-KR" sz="1050">
+                <a:solidFill>
+                  <a:schemeClr val="tx1"/>
+                </a:solidFill>
+                <a:sym typeface="Wingdings" panose="05000000000000000000" pitchFamily="2" charset="2"/>
+              </a:rPr>
+              <a:t>minPrice,maxPrice  range </a:t>
+            </a:r>
+            <a:r>
+              <a:rPr lang="ko-KR" altLang="en-US" sz="1050">
+                <a:solidFill>
+                  <a:schemeClr val="tx1"/>
+                </a:solidFill>
+                <a:sym typeface="Wingdings" panose="05000000000000000000" pitchFamily="2" charset="2"/>
+              </a:rPr>
+              <a:t>조회를 위한 파라미터</a:t>
+            </a:r>
+            <a:endParaRPr lang="en-US" altLang="ko-KR" sz="1050">
+              <a:solidFill>
+                <a:schemeClr val="tx1"/>
+              </a:solidFill>
+              <a:sym typeface="Wingdings" panose="05000000000000000000" pitchFamily="2" charset="2"/>
+            </a:endParaRPr>
+          </a:p>
+          <a:p>
+            <a:pPr algn="ctr"/>
+            <a:r>
+              <a:rPr lang="en-US" altLang="ko-KR" sz="1050">
+                <a:solidFill>
+                  <a:schemeClr val="tx1"/>
+                </a:solidFill>
+                <a:sym typeface="Wingdings" panose="05000000000000000000" pitchFamily="2" charset="2"/>
+              </a:rPr>
+              <a:t>page, size  </a:t>
+            </a:r>
+            <a:r>
+              <a:rPr lang="ko-KR" altLang="en-US" sz="1050">
+                <a:solidFill>
+                  <a:schemeClr val="tx1"/>
+                </a:solidFill>
+                <a:sym typeface="Wingdings" panose="05000000000000000000" pitchFamily="2" charset="2"/>
+              </a:rPr>
+              <a:t>페이지 당 </a:t>
+            </a:r>
+            <a:r>
+              <a:rPr lang="en-US" altLang="ko-KR" sz="1050">
+                <a:solidFill>
+                  <a:schemeClr val="tx1"/>
+                </a:solidFill>
+                <a:sym typeface="Wingdings" panose="05000000000000000000" pitchFamily="2" charset="2"/>
+              </a:rPr>
+              <a:t>5</a:t>
+            </a:r>
+            <a:r>
+              <a:rPr lang="ko-KR" altLang="en-US" sz="1050">
+                <a:solidFill>
+                  <a:schemeClr val="tx1"/>
+                </a:solidFill>
+                <a:sym typeface="Wingdings" panose="05000000000000000000" pitchFamily="2" charset="2"/>
+              </a:rPr>
+              <a:t>건의 제품 조회를 위한 조건</a:t>
+            </a:r>
+            <a:endParaRPr lang="ko-KR" altLang="en-US" sz="1050">
+              <a:solidFill>
+                <a:schemeClr val="tx1"/>
+              </a:solidFill>
+            </a:endParaRPr>
+          </a:p>
+        </p:txBody>
+      </p:sp>
+    </p:spTree>
+    <p:extLst>
+      <p:ext uri="{BB962C8B-B14F-4D97-AF65-F5344CB8AC3E}">
+        <p14:creationId xmlns:p14="http://schemas.microsoft.com/office/powerpoint/2010/main" val="2997956665"/>
+      </p:ext>
+    </p:extLst>
+  </p:cSld>
+  <p:clrMapOvr>
+    <a:masterClrMapping/>
+  </p:clrMapOvr>
+</p:sld>
+</file>
+
+<file path=ppt/slides/slide22.xml><?xml version="1.0" encoding="utf-8"?>
+<p:sld xmlns:a="http://schemas.openxmlformats.org/drawingml/2006/main" xmlns:r="http://schemas.openxmlformats.org/officeDocument/2006/relationships" xmlns:p="http://schemas.openxmlformats.org/presentationml/2006/main">
+  <p:cSld>
+    <p:spTree>
+      <p:nvGrpSpPr>
+        <p:cNvPr id="1" name=""/>
+        <p:cNvGrpSpPr/>
+        <p:nvPr/>
+      </p:nvGrpSpPr>
+      <p:grpSpPr>
+        <a:xfrm>
+          <a:off x="0" y="0"/>
+          <a:ext cx="0" cy="0"/>
+          <a:chOff x="0" y="0"/>
+          <a:chExt cx="0" cy="0"/>
+        </a:xfrm>
+      </p:grpSpPr>
+      <p:sp>
+        <p:nvSpPr>
+          <p:cNvPr id="2" name="제목 1">
+            <a:extLst>
+              <a:ext uri="{FF2B5EF4-FFF2-40B4-BE49-F238E27FC236}">
+                <a16:creationId xmlns:a16="http://schemas.microsoft.com/office/drawing/2014/main" id="{D8112AA5-9629-6FEA-1EA8-345961013F48}"/>
+              </a:ext>
+            </a:extLst>
+          </p:cNvPr>
+          <p:cNvSpPr>
+            <a:spLocks noGrp="1"/>
+          </p:cNvSpPr>
+          <p:nvPr>
+            <p:ph type="title"/>
+          </p:nvPr>
+        </p:nvSpPr>
+        <p:spPr/>
+        <p:txBody>
+          <a:bodyPr>
+            <a:normAutofit/>
+          </a:bodyPr>
+          <a:lstStyle/>
+          <a:p>
+            <a:r>
+              <a:rPr lang="en-US" altLang="ko-KR" sz="2800"/>
+              <a:t>Kibana /products/search </a:t>
+            </a:r>
+            <a:r>
+              <a:rPr lang="ko-KR" altLang="en-US" sz="2800"/>
+              <a:t>쿼리를 </a:t>
+            </a:r>
+            <a:r>
+              <a:rPr lang="en-US" altLang="ko-KR" sz="2800"/>
+              <a:t>ProductService</a:t>
+            </a:r>
+            <a:r>
+              <a:rPr lang="ko-KR" altLang="en-US" sz="2800"/>
+              <a:t>에 작성하기</a:t>
+            </a:r>
+            <a:r>
+              <a:rPr lang="en-US" altLang="ko-KR" sz="2800"/>
+              <a:t>-1</a:t>
+            </a:r>
+            <a:endParaRPr lang="ko-KR" altLang="en-US" sz="2800"/>
+          </a:p>
+        </p:txBody>
+      </p:sp>
+      <p:grpSp>
+        <p:nvGrpSpPr>
+          <p:cNvPr id="6" name="그룹 5">
+            <a:extLst>
+              <a:ext uri="{FF2B5EF4-FFF2-40B4-BE49-F238E27FC236}">
+                <a16:creationId xmlns:a16="http://schemas.microsoft.com/office/drawing/2014/main" id="{2F17CC20-A68A-8D72-72ED-5B40038A33F5}"/>
+              </a:ext>
+            </a:extLst>
+          </p:cNvPr>
+          <p:cNvGrpSpPr/>
+          <p:nvPr/>
+        </p:nvGrpSpPr>
+        <p:grpSpPr>
+          <a:xfrm>
+            <a:off x="674223" y="1913022"/>
+            <a:ext cx="2562583" cy="4658375"/>
+            <a:chOff x="674223" y="1913022"/>
+            <a:chExt cx="2562583" cy="4658375"/>
+          </a:xfrm>
+        </p:grpSpPr>
+        <p:pic>
+          <p:nvPicPr>
+            <p:cNvPr id="4" name="그림 3">
+              <a:extLst>
+                <a:ext uri="{FF2B5EF4-FFF2-40B4-BE49-F238E27FC236}">
+                  <a16:creationId xmlns:a16="http://schemas.microsoft.com/office/drawing/2014/main" id="{81E4038E-551C-DD19-2598-F40B0B11F04C}"/>
+                </a:ext>
+              </a:extLst>
+            </p:cNvPr>
+            <p:cNvPicPr>
+              <a:picLocks noChangeAspect="1"/>
+            </p:cNvPicPr>
+            <p:nvPr/>
+          </p:nvPicPr>
+          <p:blipFill>
+            <a:blip r:embed="rId2"/>
+            <a:stretch>
+              <a:fillRect/>
+            </a:stretch>
+          </p:blipFill>
+          <p:spPr>
+            <a:xfrm>
+              <a:off x="674223" y="1913022"/>
+              <a:ext cx="2562583" cy="4658375"/>
+            </a:xfrm>
+            <a:prstGeom prst="rect">
+              <a:avLst/>
+            </a:prstGeom>
+          </p:spPr>
+        </p:pic>
+        <p:sp>
+          <p:nvSpPr>
+            <p:cNvPr id="5" name="직사각형 4">
+              <a:extLst>
+                <a:ext uri="{FF2B5EF4-FFF2-40B4-BE49-F238E27FC236}">
+                  <a16:creationId xmlns:a16="http://schemas.microsoft.com/office/drawing/2014/main" id="{750AFB08-2886-6900-19D0-AD363D76FAC2}"/>
+                </a:ext>
+              </a:extLst>
+            </p:cNvPr>
+            <p:cNvSpPr/>
+            <p:nvPr/>
+          </p:nvSpPr>
+          <p:spPr>
+            <a:xfrm>
+              <a:off x="914401" y="5974915"/>
+              <a:ext cx="1335640" cy="210128"/>
+            </a:xfrm>
+            <a:prstGeom prst="rect">
+              <a:avLst/>
+            </a:prstGeom>
+            <a:noFill/>
+            <a:ln>
+              <a:solidFill>
+                <a:srgbClr val="00B050"/>
+              </a:solidFill>
+            </a:ln>
+          </p:spPr>
+          <p:style>
+            <a:lnRef idx="2">
+              <a:schemeClr val="accent1">
+                <a:shade val="15000"/>
+              </a:schemeClr>
+            </a:lnRef>
+            <a:fillRef idx="1">
+              <a:schemeClr val="accent1"/>
+            </a:fillRef>
+            <a:effectRef idx="0">
+              <a:schemeClr val="accent1"/>
+            </a:effectRef>
+            <a:fontRef idx="minor">
+              <a:schemeClr val="lt1"/>
+            </a:fontRef>
+          </p:style>
+          <p:txBody>
+            <a:bodyPr rtlCol="0" anchor="ctr"/>
+            <a:lstStyle/>
+            <a:p>
+              <a:pPr algn="ctr"/>
+              <a:endParaRPr lang="ko-KR" altLang="en-US"/>
+            </a:p>
+          </p:txBody>
+        </p:sp>
+      </p:grpSp>
+      <p:pic>
+        <p:nvPicPr>
+          <p:cNvPr id="10" name="그림 9">
+            <a:extLst>
+              <a:ext uri="{FF2B5EF4-FFF2-40B4-BE49-F238E27FC236}">
+                <a16:creationId xmlns:a16="http://schemas.microsoft.com/office/drawing/2014/main" id="{ECB5E902-F27C-54B4-657C-C3D96902A4E4}"/>
+              </a:ext>
+            </a:extLst>
+          </p:cNvPr>
+          <p:cNvPicPr>
+            <a:picLocks noChangeAspect="1"/>
+          </p:cNvPicPr>
+          <p:nvPr/>
+        </p:nvPicPr>
+        <p:blipFill>
+          <a:blip r:embed="rId3"/>
+          <a:stretch>
+            <a:fillRect/>
+          </a:stretch>
+        </p:blipFill>
+        <p:spPr>
+          <a:xfrm>
+            <a:off x="7830569" y="1913022"/>
+            <a:ext cx="3417804" cy="1400739"/>
+          </a:xfrm>
+          <a:prstGeom prst="rect">
+            <a:avLst/>
+          </a:prstGeom>
+        </p:spPr>
+      </p:pic>
+      <p:pic>
+        <p:nvPicPr>
+          <p:cNvPr id="12" name="그림 11">
+            <a:extLst>
+              <a:ext uri="{FF2B5EF4-FFF2-40B4-BE49-F238E27FC236}">
+                <a16:creationId xmlns:a16="http://schemas.microsoft.com/office/drawing/2014/main" id="{4C570140-4AC9-6556-7909-5D9590BBA24F}"/>
+              </a:ext>
+            </a:extLst>
+          </p:cNvPr>
+          <p:cNvPicPr>
+            <a:picLocks noChangeAspect="1"/>
+          </p:cNvPicPr>
+          <p:nvPr/>
+        </p:nvPicPr>
+        <p:blipFill>
+          <a:blip r:embed="rId4"/>
+          <a:stretch>
+            <a:fillRect/>
+          </a:stretch>
+        </p:blipFill>
+        <p:spPr>
+          <a:xfrm>
+            <a:off x="7861883" y="3350712"/>
+            <a:ext cx="2340565" cy="1859042"/>
+          </a:xfrm>
+          <a:prstGeom prst="rect">
+            <a:avLst/>
+          </a:prstGeom>
+        </p:spPr>
+      </p:pic>
+      <p:grpSp>
+        <p:nvGrpSpPr>
+          <p:cNvPr id="22" name="그룹 21">
+            <a:extLst>
+              <a:ext uri="{FF2B5EF4-FFF2-40B4-BE49-F238E27FC236}">
+                <a16:creationId xmlns:a16="http://schemas.microsoft.com/office/drawing/2014/main" id="{4F3AC827-E477-FC75-6984-376AFB039EB2}"/>
+              </a:ext>
+            </a:extLst>
+          </p:cNvPr>
+          <p:cNvGrpSpPr/>
+          <p:nvPr/>
+        </p:nvGrpSpPr>
+        <p:grpSpPr>
+          <a:xfrm>
+            <a:off x="3236806" y="1913022"/>
+            <a:ext cx="4482412" cy="4204222"/>
+            <a:chOff x="3301876" y="1913022"/>
+            <a:chExt cx="4482412" cy="4204222"/>
+          </a:xfrm>
+        </p:grpSpPr>
+        <p:pic>
+          <p:nvPicPr>
+            <p:cNvPr id="8" name="그림 7">
+              <a:extLst>
+                <a:ext uri="{FF2B5EF4-FFF2-40B4-BE49-F238E27FC236}">
+                  <a16:creationId xmlns:a16="http://schemas.microsoft.com/office/drawing/2014/main" id="{A03E3AFE-4771-B109-A18B-24BF91DBC7C4}"/>
+                </a:ext>
+              </a:extLst>
+            </p:cNvPr>
+            <p:cNvPicPr>
+              <a:picLocks noChangeAspect="1"/>
+            </p:cNvPicPr>
+            <p:nvPr/>
+          </p:nvPicPr>
+          <p:blipFill>
+            <a:blip r:embed="rId5"/>
+            <a:stretch>
+              <a:fillRect/>
+            </a:stretch>
+          </p:blipFill>
+          <p:spPr>
+            <a:xfrm>
+              <a:off x="3301876" y="1913022"/>
+              <a:ext cx="4482412" cy="3342087"/>
+            </a:xfrm>
+            <a:prstGeom prst="rect">
+              <a:avLst/>
+            </a:prstGeom>
+          </p:spPr>
+        </p:pic>
+        <p:pic>
+          <p:nvPicPr>
+            <p:cNvPr id="21" name="그림 20">
+              <a:extLst>
+                <a:ext uri="{FF2B5EF4-FFF2-40B4-BE49-F238E27FC236}">
+                  <a16:creationId xmlns:a16="http://schemas.microsoft.com/office/drawing/2014/main" id="{3FD63CE0-4432-AD80-4684-8281268D6410}"/>
+                </a:ext>
+              </a:extLst>
+            </p:cNvPr>
+            <p:cNvPicPr>
+              <a:picLocks noChangeAspect="1"/>
+            </p:cNvPicPr>
+            <p:nvPr/>
+          </p:nvPicPr>
+          <p:blipFill>
+            <a:blip r:embed="rId6"/>
+            <a:stretch>
+              <a:fillRect/>
+            </a:stretch>
+          </p:blipFill>
+          <p:spPr>
+            <a:xfrm>
+              <a:off x="3301876" y="5255110"/>
+              <a:ext cx="3706436" cy="862134"/>
+            </a:xfrm>
+            <a:prstGeom prst="rect">
+              <a:avLst/>
+            </a:prstGeom>
+          </p:spPr>
+        </p:pic>
+      </p:grpSp>
+      <p:grpSp>
+        <p:nvGrpSpPr>
+          <p:cNvPr id="24" name="그룹 23">
+            <a:extLst>
+              <a:ext uri="{FF2B5EF4-FFF2-40B4-BE49-F238E27FC236}">
+                <a16:creationId xmlns:a16="http://schemas.microsoft.com/office/drawing/2014/main" id="{24E0C4C6-3F45-2E55-267E-DB19EC02C69C}"/>
+              </a:ext>
+            </a:extLst>
+          </p:cNvPr>
+          <p:cNvGrpSpPr/>
+          <p:nvPr/>
+        </p:nvGrpSpPr>
+        <p:grpSpPr>
+          <a:xfrm>
+            <a:off x="3851754" y="4363323"/>
+            <a:ext cx="6281802" cy="1611592"/>
+            <a:chOff x="3851754" y="4363323"/>
+            <a:chExt cx="6281802" cy="1611592"/>
+          </a:xfrm>
+        </p:grpSpPr>
+        <p:sp>
+          <p:nvSpPr>
+            <p:cNvPr id="17" name="직사각형 16">
+              <a:extLst>
+                <a:ext uri="{FF2B5EF4-FFF2-40B4-BE49-F238E27FC236}">
+                  <a16:creationId xmlns:a16="http://schemas.microsoft.com/office/drawing/2014/main" id="{14384BC4-D110-4A91-6B1F-62D9ACB162A2}"/>
+                </a:ext>
+              </a:extLst>
+            </p:cNvPr>
+            <p:cNvSpPr/>
+            <p:nvPr/>
+          </p:nvSpPr>
+          <p:spPr>
+            <a:xfrm>
+              <a:off x="8931058" y="4363323"/>
+              <a:ext cx="1202498" cy="622036"/>
+            </a:xfrm>
+            <a:prstGeom prst="rect">
+              <a:avLst/>
+            </a:prstGeom>
+            <a:noFill/>
+            <a:ln>
+              <a:solidFill>
+                <a:srgbClr val="FF0000"/>
+              </a:solidFill>
+            </a:ln>
+          </p:spPr>
+          <p:style>
+            <a:lnRef idx="2">
+              <a:schemeClr val="accent1">
+                <a:shade val="15000"/>
+              </a:schemeClr>
+            </a:lnRef>
+            <a:fillRef idx="1">
+              <a:schemeClr val="accent1"/>
+            </a:fillRef>
+            <a:effectRef idx="0">
+              <a:schemeClr val="accent1"/>
+            </a:effectRef>
+            <a:fontRef idx="minor">
+              <a:schemeClr val="lt1"/>
+            </a:fontRef>
+          </p:style>
+          <p:txBody>
+            <a:bodyPr rtlCol="0" anchor="ctr"/>
+            <a:lstStyle/>
+            <a:p>
+              <a:pPr algn="ctr"/>
+              <a:endParaRPr lang="ko-KR" altLang="en-US"/>
+            </a:p>
+          </p:txBody>
+        </p:sp>
+        <p:sp>
+          <p:nvSpPr>
+            <p:cNvPr id="23" name="직사각형 22">
+              <a:extLst>
+                <a:ext uri="{FF2B5EF4-FFF2-40B4-BE49-F238E27FC236}">
+                  <a16:creationId xmlns:a16="http://schemas.microsoft.com/office/drawing/2014/main" id="{AA1416F2-D94B-B730-D702-030C9DCFE758}"/>
+                </a:ext>
+              </a:extLst>
+            </p:cNvPr>
+            <p:cNvSpPr/>
+            <p:nvPr/>
+          </p:nvSpPr>
+          <p:spPr>
+            <a:xfrm>
+              <a:off x="3851754" y="5255110"/>
+              <a:ext cx="2956142" cy="719805"/>
+            </a:xfrm>
+            <a:prstGeom prst="rect">
+              <a:avLst/>
+            </a:prstGeom>
+            <a:noFill/>
+            <a:ln>
+              <a:solidFill>
+                <a:srgbClr val="FF0000"/>
+              </a:solidFill>
+            </a:ln>
+          </p:spPr>
+          <p:style>
+            <a:lnRef idx="2">
+              <a:schemeClr val="accent1">
+                <a:shade val="15000"/>
+              </a:schemeClr>
+            </a:lnRef>
+            <a:fillRef idx="1">
+              <a:schemeClr val="accent1"/>
+            </a:fillRef>
+            <a:effectRef idx="0">
+              <a:schemeClr val="accent1"/>
+            </a:effectRef>
+            <a:fontRef idx="minor">
+              <a:schemeClr val="lt1"/>
+            </a:fontRef>
+          </p:style>
+          <p:txBody>
+            <a:bodyPr rtlCol="0" anchor="ctr"/>
+            <a:lstStyle/>
+            <a:p>
+              <a:pPr algn="ctr"/>
+              <a:endParaRPr lang="ko-KR" altLang="en-US"/>
+            </a:p>
+          </p:txBody>
+        </p:sp>
+      </p:grpSp>
+      <p:grpSp>
+        <p:nvGrpSpPr>
+          <p:cNvPr id="26" name="그룹 25">
+            <a:extLst>
+              <a:ext uri="{FF2B5EF4-FFF2-40B4-BE49-F238E27FC236}">
+                <a16:creationId xmlns:a16="http://schemas.microsoft.com/office/drawing/2014/main" id="{263B508B-46BE-5403-394D-C49B52DC68A1}"/>
+              </a:ext>
+            </a:extLst>
+          </p:cNvPr>
+          <p:cNvGrpSpPr/>
+          <p:nvPr/>
+        </p:nvGrpSpPr>
+        <p:grpSpPr>
+          <a:xfrm>
+            <a:off x="3964488" y="3640989"/>
+            <a:ext cx="6169068" cy="1288003"/>
+            <a:chOff x="3964488" y="3640989"/>
+            <a:chExt cx="6169068" cy="1288003"/>
+          </a:xfrm>
+        </p:grpSpPr>
+        <p:sp>
+          <p:nvSpPr>
+            <p:cNvPr id="14" name="직사각형 13">
+              <a:extLst>
+                <a:ext uri="{FF2B5EF4-FFF2-40B4-BE49-F238E27FC236}">
+                  <a16:creationId xmlns:a16="http://schemas.microsoft.com/office/drawing/2014/main" id="{9AE515B1-DE21-C703-D6F7-B4496E36E2C3}"/>
+                </a:ext>
+              </a:extLst>
+            </p:cNvPr>
+            <p:cNvSpPr/>
+            <p:nvPr/>
+          </p:nvSpPr>
+          <p:spPr>
+            <a:xfrm>
+              <a:off x="8931058" y="3640989"/>
+              <a:ext cx="1202498" cy="548967"/>
+            </a:xfrm>
+            <a:prstGeom prst="rect">
+              <a:avLst/>
+            </a:prstGeom>
+            <a:noFill/>
+            <a:ln>
+              <a:solidFill>
+                <a:srgbClr val="FFC000"/>
+              </a:solidFill>
+            </a:ln>
+          </p:spPr>
+          <p:style>
+            <a:lnRef idx="2">
+              <a:schemeClr val="accent1">
+                <a:shade val="15000"/>
+              </a:schemeClr>
+            </a:lnRef>
+            <a:fillRef idx="1">
+              <a:schemeClr val="accent1"/>
+            </a:fillRef>
+            <a:effectRef idx="0">
+              <a:schemeClr val="accent1"/>
+            </a:effectRef>
+            <a:fontRef idx="minor">
+              <a:schemeClr val="lt1"/>
+            </a:fontRef>
+          </p:style>
+          <p:txBody>
+            <a:bodyPr rtlCol="0" anchor="ctr"/>
+            <a:lstStyle/>
+            <a:p>
+              <a:pPr algn="ctr"/>
+              <a:endParaRPr lang="ko-KR" altLang="en-US"/>
+            </a:p>
+          </p:txBody>
+        </p:sp>
+        <p:sp>
+          <p:nvSpPr>
+            <p:cNvPr id="25" name="직사각형 24">
+              <a:extLst>
+                <a:ext uri="{FF2B5EF4-FFF2-40B4-BE49-F238E27FC236}">
+                  <a16:creationId xmlns:a16="http://schemas.microsoft.com/office/drawing/2014/main" id="{770D51C3-100C-F786-A9C2-6B333E41347F}"/>
+                </a:ext>
+              </a:extLst>
+            </p:cNvPr>
+            <p:cNvSpPr/>
+            <p:nvPr/>
+          </p:nvSpPr>
+          <p:spPr>
+            <a:xfrm>
+              <a:off x="3964488" y="4427951"/>
+              <a:ext cx="2373682" cy="501041"/>
+            </a:xfrm>
+            <a:prstGeom prst="rect">
+              <a:avLst/>
+            </a:prstGeom>
+            <a:noFill/>
+            <a:ln>
+              <a:solidFill>
+                <a:srgbClr val="FFC000"/>
+              </a:solidFill>
+            </a:ln>
+          </p:spPr>
+          <p:style>
+            <a:lnRef idx="2">
+              <a:schemeClr val="accent1">
+                <a:shade val="15000"/>
+              </a:schemeClr>
+            </a:lnRef>
+            <a:fillRef idx="1">
+              <a:schemeClr val="accent1"/>
+            </a:fillRef>
+            <a:effectRef idx="0">
+              <a:schemeClr val="accent1"/>
+            </a:effectRef>
+            <a:fontRef idx="minor">
+              <a:schemeClr val="lt1"/>
+            </a:fontRef>
+          </p:style>
+          <p:txBody>
+            <a:bodyPr rtlCol="0" anchor="ctr"/>
+            <a:lstStyle/>
+            <a:p>
+              <a:pPr algn="ctr"/>
+              <a:endParaRPr lang="ko-KR" altLang="en-US"/>
+            </a:p>
+          </p:txBody>
+        </p:sp>
+      </p:grpSp>
+      <p:grpSp>
+        <p:nvGrpSpPr>
+          <p:cNvPr id="28" name="그룹 27">
+            <a:extLst>
+              <a:ext uri="{FF2B5EF4-FFF2-40B4-BE49-F238E27FC236}">
+                <a16:creationId xmlns:a16="http://schemas.microsoft.com/office/drawing/2014/main" id="{6F5A9370-92F4-4754-FF8A-67078BE2CCA7}"/>
+              </a:ext>
+            </a:extLst>
+          </p:cNvPr>
+          <p:cNvGrpSpPr/>
+          <p:nvPr/>
+        </p:nvGrpSpPr>
+        <p:grpSpPr>
+          <a:xfrm>
+            <a:off x="3834217" y="2488607"/>
+            <a:ext cx="7414156" cy="1563563"/>
+            <a:chOff x="3834217" y="2488607"/>
+            <a:chExt cx="7414156" cy="1563563"/>
+          </a:xfrm>
+        </p:grpSpPr>
+        <p:sp>
+          <p:nvSpPr>
+            <p:cNvPr id="13" name="직사각형 12">
+              <a:extLst>
+                <a:ext uri="{FF2B5EF4-FFF2-40B4-BE49-F238E27FC236}">
+                  <a16:creationId xmlns:a16="http://schemas.microsoft.com/office/drawing/2014/main" id="{01F2A040-E1B4-B404-CB62-7A8337003CFB}"/>
+                </a:ext>
+              </a:extLst>
+            </p:cNvPr>
+            <p:cNvSpPr/>
+            <p:nvPr/>
+          </p:nvSpPr>
+          <p:spPr>
+            <a:xfrm>
+              <a:off x="8931058" y="2488607"/>
+              <a:ext cx="2317315" cy="592213"/>
+            </a:xfrm>
+            <a:prstGeom prst="rect">
+              <a:avLst/>
+            </a:prstGeom>
+            <a:noFill/>
+            <a:ln>
+              <a:solidFill>
+                <a:srgbClr val="0070C0"/>
+              </a:solidFill>
+            </a:ln>
+          </p:spPr>
+          <p:style>
+            <a:lnRef idx="2">
+              <a:schemeClr val="accent1">
+                <a:shade val="15000"/>
+              </a:schemeClr>
+            </a:lnRef>
+            <a:fillRef idx="1">
+              <a:schemeClr val="accent1"/>
+            </a:fillRef>
+            <a:effectRef idx="0">
+              <a:schemeClr val="accent1"/>
+            </a:effectRef>
+            <a:fontRef idx="minor">
+              <a:schemeClr val="lt1"/>
+            </a:fontRef>
+          </p:style>
+          <p:txBody>
+            <a:bodyPr rtlCol="0" anchor="ctr"/>
+            <a:lstStyle/>
+            <a:p>
+              <a:pPr algn="ctr"/>
+              <a:endParaRPr lang="ko-KR" altLang="en-US"/>
+            </a:p>
+          </p:txBody>
+        </p:sp>
+        <p:sp>
+          <p:nvSpPr>
+            <p:cNvPr id="27" name="직사각형 26">
+              <a:extLst>
+                <a:ext uri="{FF2B5EF4-FFF2-40B4-BE49-F238E27FC236}">
+                  <a16:creationId xmlns:a16="http://schemas.microsoft.com/office/drawing/2014/main" id="{3F5C5674-184C-BCDB-C9F5-4FEE56E5DF8E}"/>
+                </a:ext>
+              </a:extLst>
+            </p:cNvPr>
+            <p:cNvSpPr/>
+            <p:nvPr/>
+          </p:nvSpPr>
+          <p:spPr>
+            <a:xfrm>
+              <a:off x="3834217" y="3313761"/>
+              <a:ext cx="3885001" cy="738409"/>
+            </a:xfrm>
+            <a:prstGeom prst="rect">
+              <a:avLst/>
+            </a:prstGeom>
+            <a:noFill/>
+            <a:ln>
+              <a:solidFill>
+                <a:srgbClr val="0070C0"/>
+              </a:solidFill>
+            </a:ln>
+          </p:spPr>
+          <p:style>
+            <a:lnRef idx="2">
+              <a:schemeClr val="accent1">
+                <a:shade val="15000"/>
+              </a:schemeClr>
+            </a:lnRef>
+            <a:fillRef idx="1">
+              <a:schemeClr val="accent1"/>
+            </a:fillRef>
+            <a:effectRef idx="0">
+              <a:schemeClr val="accent1"/>
+            </a:effectRef>
+            <a:fontRef idx="minor">
+              <a:schemeClr val="lt1"/>
+            </a:fontRef>
+          </p:style>
+          <p:txBody>
+            <a:bodyPr rtlCol="0" anchor="ctr"/>
+            <a:lstStyle/>
+            <a:p>
+              <a:pPr algn="ctr"/>
+              <a:endParaRPr lang="ko-KR" altLang="en-US"/>
+            </a:p>
+          </p:txBody>
+        </p:sp>
+      </p:grpSp>
+      <p:grpSp>
+        <p:nvGrpSpPr>
+          <p:cNvPr id="31" name="그룹 30">
+            <a:extLst>
+              <a:ext uri="{FF2B5EF4-FFF2-40B4-BE49-F238E27FC236}">
+                <a16:creationId xmlns:a16="http://schemas.microsoft.com/office/drawing/2014/main" id="{291C2969-B160-F584-2DF7-581AD619C8B8}"/>
+              </a:ext>
+            </a:extLst>
+          </p:cNvPr>
+          <p:cNvGrpSpPr/>
+          <p:nvPr/>
+        </p:nvGrpSpPr>
+        <p:grpSpPr>
+          <a:xfrm>
+            <a:off x="3851753" y="4935255"/>
+            <a:ext cx="1741118" cy="1176954"/>
+            <a:chOff x="3851753" y="4935255"/>
+            <a:chExt cx="1741118" cy="1176954"/>
+          </a:xfrm>
+        </p:grpSpPr>
+        <p:sp>
+          <p:nvSpPr>
+            <p:cNvPr id="29" name="직사각형 28">
+              <a:extLst>
+                <a:ext uri="{FF2B5EF4-FFF2-40B4-BE49-F238E27FC236}">
+                  <a16:creationId xmlns:a16="http://schemas.microsoft.com/office/drawing/2014/main" id="{6F101840-094F-BF05-DB42-91B862749941}"/>
+                </a:ext>
+              </a:extLst>
+            </p:cNvPr>
+            <p:cNvSpPr/>
+            <p:nvPr/>
+          </p:nvSpPr>
+          <p:spPr>
+            <a:xfrm>
+              <a:off x="3960313" y="4935255"/>
+              <a:ext cx="1632558" cy="152400"/>
+            </a:xfrm>
+            <a:prstGeom prst="rect">
+              <a:avLst/>
+            </a:prstGeom>
+            <a:noFill/>
+            <a:ln>
+              <a:solidFill>
+                <a:srgbClr val="92D050"/>
+              </a:solidFill>
+            </a:ln>
+          </p:spPr>
+          <p:style>
+            <a:lnRef idx="2">
+              <a:schemeClr val="accent1">
+                <a:shade val="15000"/>
+              </a:schemeClr>
+            </a:lnRef>
+            <a:fillRef idx="1">
+              <a:schemeClr val="accent1"/>
+            </a:fillRef>
+            <a:effectRef idx="0">
+              <a:schemeClr val="accent1"/>
+            </a:effectRef>
+            <a:fontRef idx="minor">
+              <a:schemeClr val="lt1"/>
+            </a:fontRef>
+          </p:style>
+          <p:txBody>
+            <a:bodyPr rtlCol="0" anchor="ctr"/>
+            <a:lstStyle/>
+            <a:p>
+              <a:pPr algn="ctr"/>
+              <a:endParaRPr lang="ko-KR" altLang="en-US"/>
+            </a:p>
+          </p:txBody>
+        </p:sp>
+        <p:sp>
+          <p:nvSpPr>
+            <p:cNvPr id="30" name="직사각형 29">
+              <a:extLst>
+                <a:ext uri="{FF2B5EF4-FFF2-40B4-BE49-F238E27FC236}">
+                  <a16:creationId xmlns:a16="http://schemas.microsoft.com/office/drawing/2014/main" id="{78369AA5-090E-A96A-91D6-DCB6EED42ADC}"/>
+                </a:ext>
+              </a:extLst>
+            </p:cNvPr>
+            <p:cNvSpPr/>
+            <p:nvPr/>
+          </p:nvSpPr>
+          <p:spPr>
+            <a:xfrm>
+              <a:off x="3851753" y="5959809"/>
+              <a:ext cx="1741117" cy="152400"/>
+            </a:xfrm>
+            <a:prstGeom prst="rect">
+              <a:avLst/>
+            </a:prstGeom>
+            <a:noFill/>
+            <a:ln>
+              <a:solidFill>
+                <a:srgbClr val="92D050"/>
+              </a:solidFill>
+            </a:ln>
+          </p:spPr>
+          <p:style>
+            <a:lnRef idx="2">
+              <a:schemeClr val="accent1">
+                <a:shade val="15000"/>
+              </a:schemeClr>
+            </a:lnRef>
+            <a:fillRef idx="1">
+              <a:schemeClr val="accent1"/>
+            </a:fillRef>
+            <a:effectRef idx="0">
+              <a:schemeClr val="accent1"/>
+            </a:effectRef>
+            <a:fontRef idx="minor">
+              <a:schemeClr val="lt1"/>
+            </a:fontRef>
+          </p:style>
+          <p:txBody>
+            <a:bodyPr rtlCol="0" anchor="ctr"/>
+            <a:lstStyle/>
+            <a:p>
+              <a:pPr algn="ctr"/>
+              <a:endParaRPr lang="ko-KR" altLang="en-US"/>
+            </a:p>
+          </p:txBody>
+        </p:sp>
+      </p:grpSp>
+      <p:grpSp>
+        <p:nvGrpSpPr>
+          <p:cNvPr id="34" name="그룹 33">
+            <a:extLst>
+              <a:ext uri="{FF2B5EF4-FFF2-40B4-BE49-F238E27FC236}">
+                <a16:creationId xmlns:a16="http://schemas.microsoft.com/office/drawing/2014/main" id="{ED39F4CD-E970-7A5E-6ABA-5794C3322A7D}"/>
+              </a:ext>
+            </a:extLst>
+          </p:cNvPr>
+          <p:cNvGrpSpPr/>
+          <p:nvPr/>
+        </p:nvGrpSpPr>
+        <p:grpSpPr>
+          <a:xfrm>
+            <a:off x="3851752" y="3344882"/>
+            <a:ext cx="5242144" cy="915615"/>
+            <a:chOff x="3851752" y="3344882"/>
+            <a:chExt cx="5242144" cy="915615"/>
+          </a:xfrm>
+        </p:grpSpPr>
+        <p:sp>
+          <p:nvSpPr>
+            <p:cNvPr id="32" name="직사각형 31">
+              <a:extLst>
+                <a:ext uri="{FF2B5EF4-FFF2-40B4-BE49-F238E27FC236}">
+                  <a16:creationId xmlns:a16="http://schemas.microsoft.com/office/drawing/2014/main" id="{50233E48-2614-589A-9295-E3CD6523FD82}"/>
+                </a:ext>
+              </a:extLst>
+            </p:cNvPr>
+            <p:cNvSpPr/>
+            <p:nvPr/>
+          </p:nvSpPr>
+          <p:spPr>
+            <a:xfrm>
+              <a:off x="8611644" y="3344882"/>
+              <a:ext cx="482252" cy="142246"/>
+            </a:xfrm>
+            <a:prstGeom prst="rect">
+              <a:avLst/>
+            </a:prstGeom>
+            <a:noFill/>
+            <a:ln>
+              <a:solidFill>
+                <a:srgbClr val="92D050"/>
+              </a:solidFill>
+            </a:ln>
+          </p:spPr>
+          <p:style>
+            <a:lnRef idx="2">
+              <a:schemeClr val="accent1">
+                <a:shade val="15000"/>
+              </a:schemeClr>
+            </a:lnRef>
+            <a:fillRef idx="1">
+              <a:schemeClr val="accent1"/>
+            </a:fillRef>
+            <a:effectRef idx="0">
+              <a:schemeClr val="accent1"/>
+            </a:effectRef>
+            <a:fontRef idx="minor">
+              <a:schemeClr val="lt1"/>
+            </a:fontRef>
+          </p:style>
+          <p:txBody>
+            <a:bodyPr rtlCol="0" anchor="ctr"/>
+            <a:lstStyle/>
+            <a:p>
+              <a:pPr algn="ctr"/>
+              <a:endParaRPr lang="ko-KR" altLang="en-US"/>
+            </a:p>
+          </p:txBody>
+        </p:sp>
+        <p:sp>
+          <p:nvSpPr>
+            <p:cNvPr id="33" name="직사각형 32">
+              <a:extLst>
+                <a:ext uri="{FF2B5EF4-FFF2-40B4-BE49-F238E27FC236}">
+                  <a16:creationId xmlns:a16="http://schemas.microsoft.com/office/drawing/2014/main" id="{FF75FDF8-BBAE-CBB3-79B7-D37B83F0B56D}"/>
+                </a:ext>
+              </a:extLst>
+            </p:cNvPr>
+            <p:cNvSpPr/>
+            <p:nvPr/>
+          </p:nvSpPr>
+          <p:spPr>
+            <a:xfrm>
+              <a:off x="3851752" y="4148635"/>
+              <a:ext cx="2244247" cy="111862"/>
+            </a:xfrm>
+            <a:prstGeom prst="rect">
+              <a:avLst/>
+            </a:prstGeom>
+            <a:noFill/>
+            <a:ln>
+              <a:solidFill>
+                <a:srgbClr val="92D050"/>
+              </a:solidFill>
+            </a:ln>
+          </p:spPr>
+          <p:style>
+            <a:lnRef idx="2">
+              <a:schemeClr val="accent1">
+                <a:shade val="15000"/>
+              </a:schemeClr>
+            </a:lnRef>
+            <a:fillRef idx="1">
+              <a:schemeClr val="accent1"/>
+            </a:fillRef>
+            <a:effectRef idx="0">
+              <a:schemeClr val="accent1"/>
+            </a:effectRef>
+            <a:fontRef idx="minor">
+              <a:schemeClr val="lt1"/>
+            </a:fontRef>
+          </p:style>
+          <p:txBody>
+            <a:bodyPr rtlCol="0" anchor="ctr"/>
+            <a:lstStyle/>
+            <a:p>
+              <a:pPr algn="ctr"/>
+              <a:endParaRPr lang="ko-KR" altLang="en-US"/>
+            </a:p>
+          </p:txBody>
+        </p:sp>
+      </p:grpSp>
+    </p:spTree>
+    <p:extLst>
+      <p:ext uri="{BB962C8B-B14F-4D97-AF65-F5344CB8AC3E}">
+        <p14:creationId xmlns:p14="http://schemas.microsoft.com/office/powerpoint/2010/main" val="2526136250"/>
+      </p:ext>
+    </p:extLst>
+  </p:cSld>
+  <p:clrMapOvr>
+    <a:masterClrMapping/>
+  </p:clrMapOvr>
+</p:sld>
+</file>
+
+<file path=ppt/slides/slide23.xml><?xml version="1.0" encoding="utf-8"?>
+<p:sld xmlns:a="http://schemas.openxmlformats.org/drawingml/2006/main" xmlns:r="http://schemas.openxmlformats.org/officeDocument/2006/relationships" xmlns:p="http://schemas.openxmlformats.org/presentationml/2006/main">
+  <p:cSld>
+    <p:spTree>
+      <p:nvGrpSpPr>
+        <p:cNvPr id="1" name=""/>
+        <p:cNvGrpSpPr/>
+        <p:nvPr/>
+      </p:nvGrpSpPr>
+      <p:grpSpPr>
+        <a:xfrm>
+          <a:off x="0" y="0"/>
+          <a:ext cx="0" cy="0"/>
+          <a:chOff x="0" y="0"/>
+          <a:chExt cx="0" cy="0"/>
+        </a:xfrm>
+      </p:grpSpPr>
+      <p:sp>
+        <p:nvSpPr>
+          <p:cNvPr id="2" name="제목 1">
+            <a:extLst>
+              <a:ext uri="{FF2B5EF4-FFF2-40B4-BE49-F238E27FC236}">
+                <a16:creationId xmlns:a16="http://schemas.microsoft.com/office/drawing/2014/main" id="{5EF76BF9-7F62-618B-E66A-68B7AC1FC7A9}"/>
+              </a:ext>
+            </a:extLst>
+          </p:cNvPr>
+          <p:cNvSpPr>
+            <a:spLocks noGrp="1"/>
+          </p:cNvSpPr>
+          <p:nvPr>
+            <p:ph type="title"/>
+          </p:nvPr>
+        </p:nvSpPr>
+        <p:spPr/>
+        <p:txBody>
+          <a:bodyPr>
+            <a:normAutofit/>
+          </a:bodyPr>
+          <a:lstStyle/>
+          <a:p>
+            <a:r>
+              <a:rPr lang="en-US" altLang="ko-KR" sz="2800"/>
+              <a:t>Kibana /products/search </a:t>
+            </a:r>
+            <a:r>
+              <a:rPr lang="ko-KR" altLang="en-US" sz="2800"/>
+              <a:t>쿼리를 </a:t>
+            </a:r>
+            <a:r>
+              <a:rPr lang="en-US" altLang="ko-KR" sz="2800"/>
+              <a:t>ProductService</a:t>
+            </a:r>
+            <a:r>
+              <a:rPr lang="ko-KR" altLang="en-US" sz="2800"/>
+              <a:t>에 작성하기</a:t>
+            </a:r>
+            <a:r>
+              <a:rPr lang="en-US" altLang="ko-KR" sz="2800"/>
+              <a:t>-2</a:t>
+            </a:r>
+            <a:endParaRPr lang="ko-KR" altLang="en-US" sz="2800"/>
+          </a:p>
+        </p:txBody>
+      </p:sp>
+      <p:grpSp>
+        <p:nvGrpSpPr>
+          <p:cNvPr id="7" name="그룹 6">
+            <a:extLst>
+              <a:ext uri="{FF2B5EF4-FFF2-40B4-BE49-F238E27FC236}">
+                <a16:creationId xmlns:a16="http://schemas.microsoft.com/office/drawing/2014/main" id="{FCE0EE57-A7CF-7C84-5F4D-E16F33EB85F6}"/>
+              </a:ext>
+            </a:extLst>
+          </p:cNvPr>
+          <p:cNvGrpSpPr/>
+          <p:nvPr/>
+        </p:nvGrpSpPr>
+        <p:grpSpPr>
+          <a:xfrm>
+            <a:off x="674223" y="1913022"/>
+            <a:ext cx="2562583" cy="4658375"/>
+            <a:chOff x="674223" y="1913022"/>
+            <a:chExt cx="2562583" cy="4658375"/>
+          </a:xfrm>
+        </p:grpSpPr>
+        <p:pic>
+          <p:nvPicPr>
+            <p:cNvPr id="5" name="그림 4">
+              <a:extLst>
+                <a:ext uri="{FF2B5EF4-FFF2-40B4-BE49-F238E27FC236}">
+                  <a16:creationId xmlns:a16="http://schemas.microsoft.com/office/drawing/2014/main" id="{8029219B-19AA-FD46-1AF1-C584EF167EB1}"/>
+                </a:ext>
+              </a:extLst>
+            </p:cNvPr>
+            <p:cNvPicPr>
+              <a:picLocks noChangeAspect="1"/>
+            </p:cNvPicPr>
+            <p:nvPr/>
+          </p:nvPicPr>
+          <p:blipFill>
+            <a:blip r:embed="rId2"/>
+            <a:stretch>
+              <a:fillRect/>
+            </a:stretch>
+          </p:blipFill>
+          <p:spPr>
+            <a:xfrm>
+              <a:off x="674223" y="1913022"/>
+              <a:ext cx="2562583" cy="4658375"/>
+            </a:xfrm>
+            <a:prstGeom prst="rect">
+              <a:avLst/>
+            </a:prstGeom>
+          </p:spPr>
+        </p:pic>
+        <p:sp>
+          <p:nvSpPr>
+            <p:cNvPr id="6" name="직사각형 5">
+              <a:extLst>
+                <a:ext uri="{FF2B5EF4-FFF2-40B4-BE49-F238E27FC236}">
+                  <a16:creationId xmlns:a16="http://schemas.microsoft.com/office/drawing/2014/main" id="{68AC22A3-C4F0-A61E-6D3E-6678A3497754}"/>
+                </a:ext>
+              </a:extLst>
+            </p:cNvPr>
+            <p:cNvSpPr/>
+            <p:nvPr/>
+          </p:nvSpPr>
+          <p:spPr>
+            <a:xfrm>
+              <a:off x="914401" y="5959011"/>
+              <a:ext cx="1304817" cy="226032"/>
+            </a:xfrm>
+            <a:prstGeom prst="rect">
+              <a:avLst/>
+            </a:prstGeom>
+            <a:noFill/>
+            <a:ln>
+              <a:solidFill>
+                <a:srgbClr val="00B050"/>
+              </a:solidFill>
+            </a:ln>
+          </p:spPr>
+          <p:style>
+            <a:lnRef idx="2">
+              <a:schemeClr val="accent1">
+                <a:shade val="15000"/>
+              </a:schemeClr>
+            </a:lnRef>
+            <a:fillRef idx="1">
+              <a:schemeClr val="accent1"/>
+            </a:fillRef>
+            <a:effectRef idx="0">
+              <a:schemeClr val="accent1"/>
+            </a:effectRef>
+            <a:fontRef idx="minor">
+              <a:schemeClr val="lt1"/>
+            </a:fontRef>
+          </p:style>
+          <p:txBody>
+            <a:bodyPr rtlCol="0" anchor="ctr"/>
+            <a:lstStyle/>
+            <a:p>
+              <a:pPr algn="ctr"/>
+              <a:endParaRPr lang="ko-KR" altLang="en-US"/>
+            </a:p>
+          </p:txBody>
+        </p:sp>
+      </p:grpSp>
+      <p:pic>
+        <p:nvPicPr>
+          <p:cNvPr id="9" name="그림 8">
+            <a:extLst>
+              <a:ext uri="{FF2B5EF4-FFF2-40B4-BE49-F238E27FC236}">
+                <a16:creationId xmlns:a16="http://schemas.microsoft.com/office/drawing/2014/main" id="{E703D3FE-EEF7-1E8F-79AA-53985AE28E72}"/>
+              </a:ext>
+            </a:extLst>
+          </p:cNvPr>
+          <p:cNvPicPr>
+            <a:picLocks noChangeAspect="1"/>
+          </p:cNvPicPr>
+          <p:nvPr/>
+        </p:nvPicPr>
+        <p:blipFill>
+          <a:blip r:embed="rId3"/>
+          <a:stretch>
+            <a:fillRect/>
+          </a:stretch>
+        </p:blipFill>
+        <p:spPr>
+          <a:xfrm>
+            <a:off x="3431585" y="1931002"/>
+            <a:ext cx="4363059" cy="752580"/>
+          </a:xfrm>
+          <a:prstGeom prst="rect">
+            <a:avLst/>
+          </a:prstGeom>
+          <a:ln w="28575">
+            <a:solidFill>
+              <a:srgbClr val="FF0000"/>
+            </a:solidFill>
+          </a:ln>
+        </p:spPr>
+      </p:pic>
+      <p:pic>
+        <p:nvPicPr>
+          <p:cNvPr id="13" name="그림 12">
+            <a:extLst>
+              <a:ext uri="{FF2B5EF4-FFF2-40B4-BE49-F238E27FC236}">
+                <a16:creationId xmlns:a16="http://schemas.microsoft.com/office/drawing/2014/main" id="{EAD513B4-7F76-6EFC-68F9-3057BDA1E462}"/>
+              </a:ext>
+            </a:extLst>
+          </p:cNvPr>
+          <p:cNvPicPr>
+            <a:picLocks noChangeAspect="1"/>
+          </p:cNvPicPr>
+          <p:nvPr/>
+        </p:nvPicPr>
+        <p:blipFill>
+          <a:blip r:embed="rId4"/>
+          <a:stretch>
+            <a:fillRect/>
+          </a:stretch>
+        </p:blipFill>
+        <p:spPr>
+          <a:xfrm>
+            <a:off x="3431585" y="2928867"/>
+            <a:ext cx="3591426" cy="1000265"/>
+          </a:xfrm>
+          <a:prstGeom prst="rect">
+            <a:avLst/>
+          </a:prstGeom>
+          <a:ln w="28575">
+            <a:solidFill>
+              <a:srgbClr val="0000FF"/>
+            </a:solidFill>
+          </a:ln>
+        </p:spPr>
+      </p:pic>
+      <p:grpSp>
+        <p:nvGrpSpPr>
+          <p:cNvPr id="16" name="그룹 15">
+            <a:extLst>
+              <a:ext uri="{FF2B5EF4-FFF2-40B4-BE49-F238E27FC236}">
+                <a16:creationId xmlns:a16="http://schemas.microsoft.com/office/drawing/2014/main" id="{C8EEFC25-294C-12BB-92AF-B8B786821833}"/>
+              </a:ext>
+            </a:extLst>
+          </p:cNvPr>
+          <p:cNvGrpSpPr/>
+          <p:nvPr/>
+        </p:nvGrpSpPr>
+        <p:grpSpPr>
+          <a:xfrm>
+            <a:off x="8154707" y="1931001"/>
+            <a:ext cx="3363071" cy="4790507"/>
+            <a:chOff x="8154707" y="1931001"/>
+            <a:chExt cx="3363071" cy="4790507"/>
+          </a:xfrm>
+        </p:grpSpPr>
+        <p:pic>
+          <p:nvPicPr>
+            <p:cNvPr id="11" name="그림 10">
+              <a:extLst>
+                <a:ext uri="{FF2B5EF4-FFF2-40B4-BE49-F238E27FC236}">
+                  <a16:creationId xmlns:a16="http://schemas.microsoft.com/office/drawing/2014/main" id="{38A47660-1E9E-7D0D-8459-A95E55085309}"/>
+                </a:ext>
+              </a:extLst>
+            </p:cNvPr>
+            <p:cNvPicPr>
+              <a:picLocks noChangeAspect="1"/>
+            </p:cNvPicPr>
+            <p:nvPr/>
+          </p:nvPicPr>
+          <p:blipFill>
+            <a:blip r:embed="rId5"/>
+            <a:stretch>
+              <a:fillRect/>
+            </a:stretch>
+          </p:blipFill>
+          <p:spPr>
+            <a:xfrm>
+              <a:off x="8154707" y="1931001"/>
+              <a:ext cx="3363070" cy="4790507"/>
+            </a:xfrm>
+            <a:prstGeom prst="rect">
+              <a:avLst/>
+            </a:prstGeom>
+          </p:spPr>
+        </p:pic>
+        <p:sp>
+          <p:nvSpPr>
+            <p:cNvPr id="14" name="직사각형 13">
+              <a:extLst>
+                <a:ext uri="{FF2B5EF4-FFF2-40B4-BE49-F238E27FC236}">
+                  <a16:creationId xmlns:a16="http://schemas.microsoft.com/office/drawing/2014/main" id="{C4F47EA5-3B60-4DE3-9C07-9018712AC331}"/>
+                </a:ext>
+              </a:extLst>
+            </p:cNvPr>
+            <p:cNvSpPr/>
+            <p:nvPr/>
+          </p:nvSpPr>
+          <p:spPr>
+            <a:xfrm>
+              <a:off x="8722760" y="5702157"/>
+              <a:ext cx="1160979" cy="657546"/>
+            </a:xfrm>
+            <a:prstGeom prst="rect">
+              <a:avLst/>
+            </a:prstGeom>
+            <a:noFill/>
+            <a:ln>
+              <a:solidFill>
+                <a:srgbClr val="FF0000"/>
+              </a:solidFill>
+            </a:ln>
+          </p:spPr>
+          <p:style>
+            <a:lnRef idx="2">
+              <a:schemeClr val="accent1">
+                <a:shade val="15000"/>
+              </a:schemeClr>
+            </a:lnRef>
+            <a:fillRef idx="1">
+              <a:schemeClr val="accent1"/>
+            </a:fillRef>
+            <a:effectRef idx="0">
+              <a:schemeClr val="accent1"/>
+            </a:effectRef>
+            <a:fontRef idx="minor">
+              <a:schemeClr val="lt1"/>
+            </a:fontRef>
+          </p:style>
+          <p:txBody>
+            <a:bodyPr rtlCol="0" anchor="ctr"/>
+            <a:lstStyle/>
+            <a:p>
+              <a:pPr algn="ctr"/>
+              <a:endParaRPr lang="ko-KR" altLang="en-US"/>
+            </a:p>
+          </p:txBody>
+        </p:sp>
+        <p:sp>
+          <p:nvSpPr>
+            <p:cNvPr id="15" name="직사각형 14">
+              <a:extLst>
+                <a:ext uri="{FF2B5EF4-FFF2-40B4-BE49-F238E27FC236}">
+                  <a16:creationId xmlns:a16="http://schemas.microsoft.com/office/drawing/2014/main" id="{B307A341-C088-7903-32D9-4256F23B2285}"/>
+                </a:ext>
+              </a:extLst>
+            </p:cNvPr>
+            <p:cNvSpPr/>
+            <p:nvPr/>
+          </p:nvSpPr>
+          <p:spPr>
+            <a:xfrm>
+              <a:off x="8311794" y="2095927"/>
+              <a:ext cx="3205984" cy="4475469"/>
+            </a:xfrm>
+            <a:prstGeom prst="rect">
+              <a:avLst/>
+            </a:prstGeom>
+            <a:noFill/>
+            <a:ln>
+              <a:solidFill>
+                <a:srgbClr val="0000FF"/>
+              </a:solidFill>
+            </a:ln>
+          </p:spPr>
+          <p:style>
+            <a:lnRef idx="2">
+              <a:schemeClr val="accent1">
+                <a:shade val="15000"/>
+              </a:schemeClr>
+            </a:lnRef>
+            <a:fillRef idx="1">
+              <a:schemeClr val="accent1"/>
+            </a:fillRef>
+            <a:effectRef idx="0">
+              <a:schemeClr val="accent1"/>
+            </a:effectRef>
+            <a:fontRef idx="minor">
+              <a:schemeClr val="lt1"/>
+            </a:fontRef>
+          </p:style>
+          <p:txBody>
+            <a:bodyPr rtlCol="0" anchor="ctr"/>
+            <a:lstStyle/>
+            <a:p>
+              <a:pPr algn="ctr"/>
+              <a:endParaRPr lang="ko-KR" altLang="en-US"/>
+            </a:p>
+          </p:txBody>
+        </p:sp>
+      </p:grpSp>
+      <p:sp>
+        <p:nvSpPr>
+          <p:cNvPr id="17" name="TextBox 16">
+            <a:extLst>
+              <a:ext uri="{FF2B5EF4-FFF2-40B4-BE49-F238E27FC236}">
+                <a16:creationId xmlns:a16="http://schemas.microsoft.com/office/drawing/2014/main" id="{3DBED31C-881A-60FE-D3E0-50032F0D81B4}"/>
+              </a:ext>
+            </a:extLst>
+          </p:cNvPr>
+          <p:cNvSpPr txBox="1"/>
+          <p:nvPr/>
+        </p:nvSpPr>
+        <p:spPr>
+          <a:xfrm>
+            <a:off x="3431585" y="4068566"/>
+            <a:ext cx="4592532" cy="646331"/>
+          </a:xfrm>
+          <a:prstGeom prst="rect">
+            <a:avLst/>
+          </a:prstGeom>
+          <a:noFill/>
+        </p:spPr>
+        <p:txBody>
+          <a:bodyPr wrap="square" rtlCol="0">
+            <a:spAutoFit/>
+          </a:bodyPr>
+          <a:lstStyle/>
+          <a:p>
+            <a:r>
+              <a:rPr lang="ko-KR" altLang="en-US" sz="1200"/>
+              <a:t>앞에서 작성한 작은 단위의 조건들을 결합하여</a:t>
+            </a:r>
+            <a:r>
+              <a:rPr lang="en-US" altLang="ko-KR" sz="1200"/>
+              <a:t>, bool </a:t>
+            </a:r>
+            <a:r>
+              <a:rPr lang="ko-KR" altLang="en-US" sz="1200"/>
+              <a:t>조건을 완성한다</a:t>
+            </a:r>
+            <a:r>
+              <a:rPr lang="en-US" altLang="ko-KR" sz="1200"/>
+              <a:t>.</a:t>
+            </a:r>
+          </a:p>
+          <a:p>
+            <a:endParaRPr lang="ko-KR" altLang="en-US" sz="1200"/>
+          </a:p>
+        </p:txBody>
+      </p:sp>
+    </p:spTree>
+    <p:extLst>
+      <p:ext uri="{BB962C8B-B14F-4D97-AF65-F5344CB8AC3E}">
+        <p14:creationId xmlns:p14="http://schemas.microsoft.com/office/powerpoint/2010/main" val="3068010160"/>
+      </p:ext>
+    </p:extLst>
+  </p:cSld>
+  <p:clrMapOvr>
+    <a:masterClrMapping/>
+  </p:clrMapOvr>
+</p:sld>
+</file>
+
+<file path=ppt/slides/slide24.xml><?xml version="1.0" encoding="utf-8"?>
+<p:sld xmlns:a="http://schemas.openxmlformats.org/drawingml/2006/main" xmlns:r="http://schemas.openxmlformats.org/officeDocument/2006/relationships" xmlns:p="http://schemas.openxmlformats.org/presentationml/2006/main">
+  <p:cSld>
+    <p:spTree>
+      <p:nvGrpSpPr>
+        <p:cNvPr id="1" name="">
+          <a:extLst>
+            <a:ext uri="{FF2B5EF4-FFF2-40B4-BE49-F238E27FC236}">
+              <a16:creationId xmlns:a16="http://schemas.microsoft.com/office/drawing/2014/main" id="{65BC0570-596C-5777-E5C6-A3C2A53BC734}"/>
+            </a:ext>
+          </a:extLst>
+        </p:cNvPr>
+        <p:cNvGrpSpPr/>
+        <p:nvPr/>
+      </p:nvGrpSpPr>
+      <p:grpSpPr>
+        <a:xfrm>
+          <a:off x="0" y="0"/>
+          <a:ext cx="0" cy="0"/>
+          <a:chOff x="0" y="0"/>
+          <a:chExt cx="0" cy="0"/>
+        </a:xfrm>
+      </p:grpSpPr>
+      <p:sp>
+        <p:nvSpPr>
+          <p:cNvPr id="2" name="제목 1">
+            <a:extLst>
+              <a:ext uri="{FF2B5EF4-FFF2-40B4-BE49-F238E27FC236}">
+                <a16:creationId xmlns:a16="http://schemas.microsoft.com/office/drawing/2014/main" id="{490BB96D-D9BD-0545-E8A3-857413F9EA61}"/>
+              </a:ext>
+            </a:extLst>
+          </p:cNvPr>
+          <p:cNvSpPr>
+            <a:spLocks noGrp="1"/>
+          </p:cNvSpPr>
+          <p:nvPr>
+            <p:ph type="title"/>
+          </p:nvPr>
+        </p:nvSpPr>
+        <p:spPr/>
+        <p:txBody>
+          <a:bodyPr>
+            <a:normAutofit/>
+          </a:bodyPr>
+          <a:lstStyle/>
+          <a:p>
+            <a:r>
+              <a:rPr lang="en-US" altLang="ko-KR" sz="2800"/>
+              <a:t>Kibana /products/search </a:t>
+            </a:r>
+            <a:r>
+              <a:rPr lang="ko-KR" altLang="en-US" sz="2800"/>
+              <a:t>쿼리를 </a:t>
+            </a:r>
+            <a:r>
+              <a:rPr lang="en-US" altLang="ko-KR" sz="2800"/>
+              <a:t>ProductService</a:t>
+            </a:r>
+            <a:r>
+              <a:rPr lang="ko-KR" altLang="en-US" sz="2800"/>
+              <a:t>에 작성하기</a:t>
+            </a:r>
+            <a:r>
+              <a:rPr lang="en-US" altLang="ko-KR" sz="2800"/>
+              <a:t>-2</a:t>
+            </a:r>
+            <a:endParaRPr lang="ko-KR" altLang="en-US" sz="2800"/>
+          </a:p>
+        </p:txBody>
+      </p:sp>
+      <p:grpSp>
+        <p:nvGrpSpPr>
+          <p:cNvPr id="7" name="그룹 6">
+            <a:extLst>
+              <a:ext uri="{FF2B5EF4-FFF2-40B4-BE49-F238E27FC236}">
+                <a16:creationId xmlns:a16="http://schemas.microsoft.com/office/drawing/2014/main" id="{550E96A8-947A-CA75-7050-540CECDA4CA2}"/>
+              </a:ext>
+            </a:extLst>
+          </p:cNvPr>
+          <p:cNvGrpSpPr/>
+          <p:nvPr/>
+        </p:nvGrpSpPr>
+        <p:grpSpPr>
+          <a:xfrm>
+            <a:off x="222160" y="1913022"/>
+            <a:ext cx="2562583" cy="4658375"/>
+            <a:chOff x="674223" y="1913022"/>
+            <a:chExt cx="2562583" cy="4658375"/>
+          </a:xfrm>
+        </p:grpSpPr>
+        <p:pic>
+          <p:nvPicPr>
+            <p:cNvPr id="5" name="그림 4">
+              <a:extLst>
+                <a:ext uri="{FF2B5EF4-FFF2-40B4-BE49-F238E27FC236}">
+                  <a16:creationId xmlns:a16="http://schemas.microsoft.com/office/drawing/2014/main" id="{DA2203D6-EC59-CC02-6441-80C092B78573}"/>
+                </a:ext>
+              </a:extLst>
+            </p:cNvPr>
+            <p:cNvPicPr>
+              <a:picLocks noChangeAspect="1"/>
+            </p:cNvPicPr>
+            <p:nvPr/>
+          </p:nvPicPr>
+          <p:blipFill>
+            <a:blip r:embed="rId2"/>
+            <a:stretch>
+              <a:fillRect/>
+            </a:stretch>
+          </p:blipFill>
+          <p:spPr>
+            <a:xfrm>
+              <a:off x="674223" y="1913022"/>
+              <a:ext cx="2562583" cy="4658375"/>
+            </a:xfrm>
+            <a:prstGeom prst="rect">
+              <a:avLst/>
+            </a:prstGeom>
+          </p:spPr>
+        </p:pic>
+        <p:sp>
+          <p:nvSpPr>
+            <p:cNvPr id="6" name="직사각형 5">
+              <a:extLst>
+                <a:ext uri="{FF2B5EF4-FFF2-40B4-BE49-F238E27FC236}">
+                  <a16:creationId xmlns:a16="http://schemas.microsoft.com/office/drawing/2014/main" id="{1CB482A5-0AF2-819C-F7BC-893D8EA229DA}"/>
+                </a:ext>
+              </a:extLst>
+            </p:cNvPr>
+            <p:cNvSpPr/>
+            <p:nvPr/>
+          </p:nvSpPr>
+          <p:spPr>
+            <a:xfrm>
+              <a:off x="914401" y="5959011"/>
+              <a:ext cx="1304817" cy="226032"/>
+            </a:xfrm>
+            <a:prstGeom prst="rect">
+              <a:avLst/>
+            </a:prstGeom>
+            <a:noFill/>
+            <a:ln>
+              <a:solidFill>
+                <a:srgbClr val="00B050"/>
+              </a:solidFill>
+            </a:ln>
+          </p:spPr>
+          <p:style>
+            <a:lnRef idx="2">
+              <a:schemeClr val="accent1">
+                <a:shade val="15000"/>
+              </a:schemeClr>
+            </a:lnRef>
+            <a:fillRef idx="1">
+              <a:schemeClr val="accent1"/>
+            </a:fillRef>
+            <a:effectRef idx="0">
+              <a:schemeClr val="accent1"/>
+            </a:effectRef>
+            <a:fontRef idx="minor">
+              <a:schemeClr val="lt1"/>
+            </a:fontRef>
+          </p:style>
+          <p:txBody>
+            <a:bodyPr rtlCol="0" anchor="ctr"/>
+            <a:lstStyle/>
+            <a:p>
+              <a:pPr algn="ctr"/>
+              <a:endParaRPr lang="ko-KR" altLang="en-US"/>
+            </a:p>
+          </p:txBody>
+        </p:sp>
+      </p:grpSp>
+      <p:sp>
+        <p:nvSpPr>
+          <p:cNvPr id="17" name="TextBox 16">
+            <a:extLst>
+              <a:ext uri="{FF2B5EF4-FFF2-40B4-BE49-F238E27FC236}">
+                <a16:creationId xmlns:a16="http://schemas.microsoft.com/office/drawing/2014/main" id="{E42F8C96-E73E-978A-542C-C499704AE03E}"/>
+              </a:ext>
+            </a:extLst>
+          </p:cNvPr>
+          <p:cNvSpPr txBox="1"/>
+          <p:nvPr/>
+        </p:nvSpPr>
+        <p:spPr>
+          <a:xfrm>
+            <a:off x="2964310" y="3611344"/>
+            <a:ext cx="6325024" cy="1015663"/>
+          </a:xfrm>
+          <a:prstGeom prst="rect">
+            <a:avLst/>
+          </a:prstGeom>
+          <a:noFill/>
+        </p:spPr>
+        <p:txBody>
+          <a:bodyPr wrap="square" rtlCol="0">
+            <a:spAutoFit/>
+          </a:bodyPr>
+          <a:lstStyle/>
+          <a:p>
+            <a:r>
+              <a:rPr lang="en-US" altLang="ko-KR" sz="1200"/>
+              <a:t>HighlightFieldParameter / Highlight / HighlightQuery </a:t>
+            </a:r>
+            <a:r>
+              <a:rPr lang="ko-KR" altLang="en-US" sz="1200"/>
+              <a:t>는 각각의 박스에 해당하는 코드라고 보면 된다</a:t>
+            </a:r>
+            <a:r>
+              <a:rPr lang="en-US" altLang="ko-KR" sz="1200"/>
+              <a:t>. </a:t>
+            </a:r>
+            <a:br>
+              <a:rPr lang="en-US" altLang="ko-KR" sz="1200"/>
+            </a:br>
+            <a:r>
+              <a:rPr lang="en-US" altLang="ko-KR" sz="1200"/>
+              <a:t>( Highlight </a:t>
+            </a:r>
+            <a:r>
+              <a:rPr lang="en-US" altLang="ko-KR" sz="1200">
+                <a:sym typeface="Wingdings" panose="05000000000000000000" pitchFamily="2" charset="2"/>
+              </a:rPr>
+              <a:t> List.of</a:t>
+            </a:r>
+            <a:r>
+              <a:rPr lang="ko-KR" altLang="en-US" sz="1200">
+                <a:sym typeface="Wingdings" panose="05000000000000000000" pitchFamily="2" charset="2"/>
+              </a:rPr>
+              <a:t> 에 나열된 </a:t>
+            </a:r>
+            <a:r>
+              <a:rPr lang="en-US" altLang="ko-KR" sz="1200">
+                <a:sym typeface="Wingdings" panose="05000000000000000000" pitchFamily="2" charset="2"/>
+              </a:rPr>
+              <a:t>HighlightField </a:t>
+            </a:r>
+            <a:r>
+              <a:rPr lang="ko-KR" altLang="en-US" sz="1200">
+                <a:sym typeface="Wingdings" panose="05000000000000000000" pitchFamily="2" charset="2"/>
+              </a:rPr>
+              <a:t>객체들 </a:t>
+            </a:r>
+            <a:r>
+              <a:rPr lang="en-US" altLang="ko-KR" sz="1200">
+                <a:sym typeface="Wingdings" panose="05000000000000000000" pitchFamily="2" charset="2"/>
+              </a:rPr>
+              <a:t>(</a:t>
+            </a:r>
+            <a:r>
+              <a:rPr lang="ko-KR" altLang="en-US" sz="1200">
+                <a:sym typeface="Wingdings" panose="05000000000000000000" pitchFamily="2" charset="2"/>
+              </a:rPr>
+              <a:t>복수 지정 시</a:t>
+            </a:r>
+            <a:r>
+              <a:rPr lang="en-US" altLang="ko-KR" sz="1200">
+                <a:sym typeface="Wingdings" panose="05000000000000000000" pitchFamily="2" charset="2"/>
+              </a:rPr>
+              <a:t>) </a:t>
+            </a:r>
+            <a:r>
+              <a:rPr lang="ko-KR" altLang="en-US" sz="1200">
+                <a:sym typeface="Wingdings" panose="05000000000000000000" pitchFamily="2" charset="2"/>
+              </a:rPr>
+              <a:t>을 포함함으로 </a:t>
+            </a:r>
+            <a:r>
+              <a:rPr lang="en-US" altLang="ko-KR" sz="1200">
+                <a:sym typeface="Wingdings" panose="05000000000000000000" pitchFamily="2" charset="2"/>
+              </a:rPr>
+              <a:t>fields </a:t>
+            </a:r>
+            <a:r>
+              <a:rPr lang="ko-KR" altLang="en-US" sz="1200">
+                <a:sym typeface="Wingdings" panose="05000000000000000000" pitchFamily="2" charset="2"/>
+              </a:rPr>
+              <a:t>라고 보는게 직관적이다</a:t>
+            </a:r>
+            <a:r>
+              <a:rPr lang="en-US" altLang="ko-KR" sz="1200">
+                <a:sym typeface="Wingdings" panose="05000000000000000000" pitchFamily="2" charset="2"/>
+              </a:rPr>
+              <a:t>.)</a:t>
+            </a:r>
+          </a:p>
+          <a:p>
+            <a:endParaRPr lang="ko-KR" altLang="en-US" sz="1200"/>
+          </a:p>
+        </p:txBody>
+      </p:sp>
+      <p:pic>
+        <p:nvPicPr>
+          <p:cNvPr id="10" name="그림 9">
+            <a:extLst>
+              <a:ext uri="{FF2B5EF4-FFF2-40B4-BE49-F238E27FC236}">
+                <a16:creationId xmlns:a16="http://schemas.microsoft.com/office/drawing/2014/main" id="{C67450B0-568E-E1A0-7EBF-575AC4E5ABDB}"/>
+              </a:ext>
+            </a:extLst>
+          </p:cNvPr>
+          <p:cNvPicPr>
+            <a:picLocks noChangeAspect="1"/>
+          </p:cNvPicPr>
+          <p:nvPr/>
+        </p:nvPicPr>
+        <p:blipFill>
+          <a:blip r:embed="rId3"/>
+          <a:stretch>
+            <a:fillRect/>
+          </a:stretch>
+        </p:blipFill>
+        <p:spPr>
+          <a:xfrm>
+            <a:off x="9407257" y="1921526"/>
+            <a:ext cx="2682058" cy="1569985"/>
+          </a:xfrm>
+          <a:prstGeom prst="rect">
+            <a:avLst/>
+          </a:prstGeom>
+        </p:spPr>
+      </p:pic>
+      <p:pic>
+        <p:nvPicPr>
+          <p:cNvPr id="18" name="그림 17">
+            <a:extLst>
+              <a:ext uri="{FF2B5EF4-FFF2-40B4-BE49-F238E27FC236}">
+                <a16:creationId xmlns:a16="http://schemas.microsoft.com/office/drawing/2014/main" id="{57F16188-3F27-869E-8BA7-BB3AE92BACA4}"/>
+              </a:ext>
+            </a:extLst>
+          </p:cNvPr>
+          <p:cNvPicPr>
+            <a:picLocks noChangeAspect="1"/>
+          </p:cNvPicPr>
+          <p:nvPr/>
+        </p:nvPicPr>
+        <p:blipFill>
+          <a:blip r:embed="rId4"/>
+          <a:stretch>
+            <a:fillRect/>
+          </a:stretch>
+        </p:blipFill>
+        <p:spPr>
+          <a:xfrm>
+            <a:off x="2933488" y="1927794"/>
+            <a:ext cx="6200238" cy="1518745"/>
+          </a:xfrm>
+          <a:prstGeom prst="rect">
+            <a:avLst/>
+          </a:prstGeom>
+        </p:spPr>
+      </p:pic>
+      <p:grpSp>
+        <p:nvGrpSpPr>
+          <p:cNvPr id="21" name="그룹 20">
+            <a:extLst>
+              <a:ext uri="{FF2B5EF4-FFF2-40B4-BE49-F238E27FC236}">
+                <a16:creationId xmlns:a16="http://schemas.microsoft.com/office/drawing/2014/main" id="{7CA23966-7FED-D0BD-20FD-1CA7565A1A37}"/>
+              </a:ext>
+            </a:extLst>
+          </p:cNvPr>
+          <p:cNvGrpSpPr/>
+          <p:nvPr/>
+        </p:nvGrpSpPr>
+        <p:grpSpPr>
+          <a:xfrm>
+            <a:off x="3542872" y="1952349"/>
+            <a:ext cx="8354602" cy="698384"/>
+            <a:chOff x="3542872" y="1952349"/>
+            <a:chExt cx="8354602" cy="698384"/>
+          </a:xfrm>
+        </p:grpSpPr>
+        <p:sp>
+          <p:nvSpPr>
+            <p:cNvPr id="19" name="직사각형 18">
+              <a:extLst>
+                <a:ext uri="{FF2B5EF4-FFF2-40B4-BE49-F238E27FC236}">
+                  <a16:creationId xmlns:a16="http://schemas.microsoft.com/office/drawing/2014/main" id="{40801F97-D9D7-86A4-6B68-C9BA2BDDA537}"/>
+                </a:ext>
+              </a:extLst>
+            </p:cNvPr>
+            <p:cNvSpPr/>
+            <p:nvPr/>
+          </p:nvSpPr>
+          <p:spPr>
+            <a:xfrm>
+              <a:off x="10685124" y="2363056"/>
+              <a:ext cx="1212350" cy="287677"/>
+            </a:xfrm>
+            <a:prstGeom prst="rect">
+              <a:avLst/>
+            </a:prstGeom>
+            <a:noFill/>
+            <a:ln>
+              <a:solidFill>
+                <a:srgbClr val="0000FF"/>
+              </a:solidFill>
+            </a:ln>
+          </p:spPr>
+          <p:style>
+            <a:lnRef idx="2">
+              <a:schemeClr val="accent1">
+                <a:shade val="15000"/>
+              </a:schemeClr>
+            </a:lnRef>
+            <a:fillRef idx="1">
+              <a:schemeClr val="accent1"/>
+            </a:fillRef>
+            <a:effectRef idx="0">
+              <a:schemeClr val="accent1"/>
+            </a:effectRef>
+            <a:fontRef idx="minor">
+              <a:schemeClr val="lt1"/>
+            </a:fontRef>
+          </p:style>
+          <p:txBody>
+            <a:bodyPr rtlCol="0" anchor="ctr"/>
+            <a:lstStyle/>
+            <a:p>
+              <a:pPr algn="ctr"/>
+              <a:endParaRPr lang="ko-KR" altLang="en-US"/>
+            </a:p>
+          </p:txBody>
+        </p:sp>
+        <p:sp>
+          <p:nvSpPr>
+            <p:cNvPr id="20" name="직사각형 19">
+              <a:extLst>
+                <a:ext uri="{FF2B5EF4-FFF2-40B4-BE49-F238E27FC236}">
+                  <a16:creationId xmlns:a16="http://schemas.microsoft.com/office/drawing/2014/main" id="{FB92420F-C4A7-DB34-91EB-18A484573ADB}"/>
+                </a:ext>
+              </a:extLst>
+            </p:cNvPr>
+            <p:cNvSpPr/>
+            <p:nvPr/>
+          </p:nvSpPr>
+          <p:spPr>
+            <a:xfrm>
+              <a:off x="3542872" y="1952349"/>
+              <a:ext cx="4717550" cy="595642"/>
+            </a:xfrm>
+            <a:prstGeom prst="rect">
+              <a:avLst/>
+            </a:prstGeom>
+            <a:noFill/>
+            <a:ln>
+              <a:solidFill>
+                <a:srgbClr val="0000FF"/>
+              </a:solidFill>
+            </a:ln>
+          </p:spPr>
+          <p:style>
+            <a:lnRef idx="2">
+              <a:schemeClr val="accent1">
+                <a:shade val="15000"/>
+              </a:schemeClr>
+            </a:lnRef>
+            <a:fillRef idx="1">
+              <a:schemeClr val="accent1"/>
+            </a:fillRef>
+            <a:effectRef idx="0">
+              <a:schemeClr val="accent1"/>
+            </a:effectRef>
+            <a:fontRef idx="minor">
+              <a:schemeClr val="lt1"/>
+            </a:fontRef>
+          </p:style>
+          <p:txBody>
+            <a:bodyPr rtlCol="0" anchor="ctr"/>
+            <a:lstStyle/>
+            <a:p>
+              <a:pPr algn="ctr"/>
+              <a:endParaRPr lang="ko-KR" altLang="en-US"/>
+            </a:p>
+          </p:txBody>
+        </p:sp>
+      </p:grpSp>
+      <p:grpSp>
+        <p:nvGrpSpPr>
+          <p:cNvPr id="24" name="그룹 23">
+            <a:extLst>
+              <a:ext uri="{FF2B5EF4-FFF2-40B4-BE49-F238E27FC236}">
+                <a16:creationId xmlns:a16="http://schemas.microsoft.com/office/drawing/2014/main" id="{22045DFA-E1C1-CACB-652E-F54EBF0F30F3}"/>
+              </a:ext>
+            </a:extLst>
+          </p:cNvPr>
+          <p:cNvGrpSpPr/>
+          <p:nvPr/>
+        </p:nvGrpSpPr>
+        <p:grpSpPr>
+          <a:xfrm>
+            <a:off x="3542872" y="2106204"/>
+            <a:ext cx="8426968" cy="1013032"/>
+            <a:chOff x="4171308" y="2107634"/>
+            <a:chExt cx="7798532" cy="871872"/>
+          </a:xfrm>
+        </p:grpSpPr>
+        <p:sp>
+          <p:nvSpPr>
+            <p:cNvPr id="22" name="직사각형 21">
+              <a:extLst>
+                <a:ext uri="{FF2B5EF4-FFF2-40B4-BE49-F238E27FC236}">
+                  <a16:creationId xmlns:a16="http://schemas.microsoft.com/office/drawing/2014/main" id="{12BA19E4-1947-1319-EB17-1D9800E9361F}"/>
+                </a:ext>
+              </a:extLst>
+            </p:cNvPr>
+            <p:cNvSpPr/>
+            <p:nvPr/>
+          </p:nvSpPr>
+          <p:spPr>
+            <a:xfrm>
+              <a:off x="4171308" y="2576288"/>
+              <a:ext cx="3338881" cy="403218"/>
+            </a:xfrm>
+            <a:prstGeom prst="rect">
+              <a:avLst/>
+            </a:prstGeom>
+            <a:noFill/>
+            <a:ln>
+              <a:solidFill>
+                <a:srgbClr val="92D050"/>
+              </a:solidFill>
+            </a:ln>
+          </p:spPr>
+          <p:style>
+            <a:lnRef idx="2">
+              <a:schemeClr val="accent1">
+                <a:shade val="15000"/>
+              </a:schemeClr>
+            </a:lnRef>
+            <a:fillRef idx="1">
+              <a:schemeClr val="accent1"/>
+            </a:fillRef>
+            <a:effectRef idx="0">
+              <a:schemeClr val="accent1"/>
+            </a:effectRef>
+            <a:fontRef idx="minor">
+              <a:schemeClr val="lt1"/>
+            </a:fontRef>
+          </p:style>
+          <p:txBody>
+            <a:bodyPr rtlCol="0" anchor="ctr"/>
+            <a:lstStyle/>
+            <a:p>
+              <a:pPr algn="ctr"/>
+              <a:endParaRPr lang="ko-KR" altLang="en-US"/>
+            </a:p>
+          </p:txBody>
+        </p:sp>
+        <p:sp>
+          <p:nvSpPr>
+            <p:cNvPr id="23" name="직사각형 22">
+              <a:extLst>
+                <a:ext uri="{FF2B5EF4-FFF2-40B4-BE49-F238E27FC236}">
+                  <a16:creationId xmlns:a16="http://schemas.microsoft.com/office/drawing/2014/main" id="{21A9ED64-5439-E07B-AF6F-46430C8DA500}"/>
+                </a:ext>
+              </a:extLst>
+            </p:cNvPr>
+            <p:cNvSpPr/>
+            <p:nvPr/>
+          </p:nvSpPr>
+          <p:spPr>
+            <a:xfrm>
+              <a:off x="10274156" y="2107634"/>
+              <a:ext cx="1695684" cy="820502"/>
+            </a:xfrm>
+            <a:prstGeom prst="rect">
+              <a:avLst/>
+            </a:prstGeom>
+            <a:noFill/>
+            <a:ln>
+              <a:solidFill>
+                <a:srgbClr val="92D050"/>
+              </a:solidFill>
+            </a:ln>
+          </p:spPr>
+          <p:style>
+            <a:lnRef idx="2">
+              <a:schemeClr val="accent1">
+                <a:shade val="15000"/>
+              </a:schemeClr>
+            </a:lnRef>
+            <a:fillRef idx="1">
+              <a:schemeClr val="accent1"/>
+            </a:fillRef>
+            <a:effectRef idx="0">
+              <a:schemeClr val="accent1"/>
+            </a:effectRef>
+            <a:fontRef idx="minor">
+              <a:schemeClr val="lt1"/>
+            </a:fontRef>
+          </p:style>
+          <p:txBody>
+            <a:bodyPr rtlCol="0" anchor="ctr"/>
+            <a:lstStyle/>
+            <a:p>
+              <a:pPr algn="ctr"/>
+              <a:endParaRPr lang="ko-KR" altLang="en-US"/>
+            </a:p>
+          </p:txBody>
+        </p:sp>
+      </p:grpSp>
+      <p:grpSp>
+        <p:nvGrpSpPr>
+          <p:cNvPr id="27" name="그룹 26">
+            <a:extLst>
+              <a:ext uri="{FF2B5EF4-FFF2-40B4-BE49-F238E27FC236}">
+                <a16:creationId xmlns:a16="http://schemas.microsoft.com/office/drawing/2014/main" id="{55EC6192-C64E-0658-7BA1-7DF58C61F367}"/>
+              </a:ext>
+            </a:extLst>
+          </p:cNvPr>
+          <p:cNvGrpSpPr/>
+          <p:nvPr/>
+        </p:nvGrpSpPr>
+        <p:grpSpPr>
+          <a:xfrm>
+            <a:off x="3542872" y="1913022"/>
+            <a:ext cx="8511066" cy="1578489"/>
+            <a:chOff x="3542872" y="1913022"/>
+            <a:chExt cx="8511066" cy="1578489"/>
+          </a:xfrm>
+        </p:grpSpPr>
+        <p:sp>
+          <p:nvSpPr>
+            <p:cNvPr id="25" name="직사각형 24">
+              <a:extLst>
+                <a:ext uri="{FF2B5EF4-FFF2-40B4-BE49-F238E27FC236}">
+                  <a16:creationId xmlns:a16="http://schemas.microsoft.com/office/drawing/2014/main" id="{5DEEC7D6-80A9-0A56-E31B-D10C1D247A61}"/>
+                </a:ext>
+              </a:extLst>
+            </p:cNvPr>
+            <p:cNvSpPr/>
+            <p:nvPr/>
+          </p:nvSpPr>
+          <p:spPr>
+            <a:xfrm>
+              <a:off x="3542872" y="3221980"/>
+              <a:ext cx="5590854" cy="249114"/>
+            </a:xfrm>
+            <a:prstGeom prst="rect">
+              <a:avLst/>
+            </a:prstGeom>
+            <a:noFill/>
+            <a:ln>
+              <a:solidFill>
+                <a:srgbClr val="00B0F0"/>
+              </a:solidFill>
+            </a:ln>
+          </p:spPr>
+          <p:style>
+            <a:lnRef idx="2">
+              <a:schemeClr val="accent1">
+                <a:shade val="15000"/>
+              </a:schemeClr>
+            </a:lnRef>
+            <a:fillRef idx="1">
+              <a:schemeClr val="accent1"/>
+            </a:fillRef>
+            <a:effectRef idx="0">
+              <a:schemeClr val="accent1"/>
+            </a:effectRef>
+            <a:fontRef idx="minor">
+              <a:schemeClr val="lt1"/>
+            </a:fontRef>
+          </p:style>
+          <p:txBody>
+            <a:bodyPr rtlCol="0" anchor="ctr"/>
+            <a:lstStyle/>
+            <a:p>
+              <a:pPr algn="ctr"/>
+              <a:endParaRPr lang="ko-KR" altLang="en-US"/>
+            </a:p>
+          </p:txBody>
+        </p:sp>
+        <p:sp>
+          <p:nvSpPr>
+            <p:cNvPr id="26" name="직사각형 25">
+              <a:extLst>
+                <a:ext uri="{FF2B5EF4-FFF2-40B4-BE49-F238E27FC236}">
+                  <a16:creationId xmlns:a16="http://schemas.microsoft.com/office/drawing/2014/main" id="{0C23F58D-8E9D-7658-4CBF-A4CF5F20BA28}"/>
+                </a:ext>
+              </a:extLst>
+            </p:cNvPr>
+            <p:cNvSpPr/>
+            <p:nvPr/>
+          </p:nvSpPr>
+          <p:spPr>
+            <a:xfrm>
+              <a:off x="9491355" y="1913022"/>
+              <a:ext cx="2562583" cy="1578489"/>
+            </a:xfrm>
+            <a:prstGeom prst="rect">
+              <a:avLst/>
+            </a:prstGeom>
+            <a:noFill/>
+            <a:ln>
+              <a:solidFill>
+                <a:srgbClr val="00B0F0"/>
+              </a:solidFill>
+            </a:ln>
+          </p:spPr>
+          <p:style>
+            <a:lnRef idx="2">
+              <a:schemeClr val="accent1">
+                <a:shade val="15000"/>
+              </a:schemeClr>
+            </a:lnRef>
+            <a:fillRef idx="1">
+              <a:schemeClr val="accent1"/>
+            </a:fillRef>
+            <a:effectRef idx="0">
+              <a:schemeClr val="accent1"/>
+            </a:effectRef>
+            <a:fontRef idx="minor">
+              <a:schemeClr val="lt1"/>
+            </a:fontRef>
+          </p:style>
+          <p:txBody>
+            <a:bodyPr rtlCol="0" anchor="ctr"/>
+            <a:lstStyle/>
+            <a:p>
+              <a:pPr algn="ctr"/>
+              <a:endParaRPr lang="ko-KR" altLang="en-US"/>
+            </a:p>
+          </p:txBody>
+        </p:sp>
+      </p:grpSp>
+    </p:spTree>
+    <p:extLst>
+      <p:ext uri="{BB962C8B-B14F-4D97-AF65-F5344CB8AC3E}">
+        <p14:creationId xmlns:p14="http://schemas.microsoft.com/office/powerpoint/2010/main" val="583557308"/>
+      </p:ext>
+    </p:extLst>
+  </p:cSld>
+  <p:clrMapOvr>
+    <a:masterClrMapping/>
+  </p:clrMapOvr>
+</p:sld>
+</file>
+
+<file path=ppt/slides/slide25.xml><?xml version="1.0" encoding="utf-8"?>
+<p:sld xmlns:a="http://schemas.openxmlformats.org/drawingml/2006/main" xmlns:r="http://schemas.openxmlformats.org/officeDocument/2006/relationships" xmlns:p="http://schemas.openxmlformats.org/presentationml/2006/main">
+  <p:cSld>
+    <p:spTree>
+      <p:nvGrpSpPr>
+        <p:cNvPr id="1" name=""/>
+        <p:cNvGrpSpPr/>
+        <p:nvPr/>
+      </p:nvGrpSpPr>
+      <p:grpSpPr>
+        <a:xfrm>
+          <a:off x="0" y="0"/>
+          <a:ext cx="0" cy="0"/>
+          <a:chOff x="0" y="0"/>
+          <a:chExt cx="0" cy="0"/>
+        </a:xfrm>
+      </p:grpSpPr>
+      <p:sp>
+        <p:nvSpPr>
+          <p:cNvPr id="2" name="제목 1">
+            <a:extLst>
+              <a:ext uri="{FF2B5EF4-FFF2-40B4-BE49-F238E27FC236}">
+                <a16:creationId xmlns:a16="http://schemas.microsoft.com/office/drawing/2014/main" id="{85B5BCAE-B6DE-D2E1-4803-25A599E8DE33}"/>
+              </a:ext>
+            </a:extLst>
+          </p:cNvPr>
+          <p:cNvSpPr>
+            <a:spLocks noGrp="1"/>
+          </p:cNvSpPr>
+          <p:nvPr>
+            <p:ph type="title"/>
+          </p:nvPr>
+        </p:nvSpPr>
+        <p:spPr/>
+        <p:txBody>
+          <a:bodyPr>
+            <a:normAutofit/>
+          </a:bodyPr>
+          <a:lstStyle/>
+          <a:p>
+            <a:r>
+              <a:rPr lang="en-US" altLang="ko-KR" sz="2800"/>
+              <a:t>Kibana /products/search </a:t>
+            </a:r>
+            <a:r>
+              <a:rPr lang="ko-KR" altLang="en-US" sz="2800"/>
+              <a:t>쿼리를 </a:t>
+            </a:r>
+            <a:r>
+              <a:rPr lang="en-US" altLang="ko-KR" sz="2800"/>
+              <a:t>ProductService</a:t>
+            </a:r>
+            <a:r>
+              <a:rPr lang="ko-KR" altLang="en-US" sz="2800"/>
+              <a:t>에 작성하기</a:t>
+            </a:r>
+            <a:r>
+              <a:rPr lang="en-US" altLang="ko-KR" sz="2800"/>
+              <a:t>-3</a:t>
+            </a:r>
+            <a:endParaRPr lang="ko-KR" altLang="en-US" sz="2800"/>
+          </a:p>
+        </p:txBody>
+      </p:sp>
+      <p:grpSp>
+        <p:nvGrpSpPr>
+          <p:cNvPr id="5" name="그룹 4">
+            <a:extLst>
+              <a:ext uri="{FF2B5EF4-FFF2-40B4-BE49-F238E27FC236}">
+                <a16:creationId xmlns:a16="http://schemas.microsoft.com/office/drawing/2014/main" id="{DFF1075C-7565-A421-17CE-5CE3D002E3C4}"/>
+              </a:ext>
+            </a:extLst>
+          </p:cNvPr>
+          <p:cNvGrpSpPr/>
+          <p:nvPr/>
+        </p:nvGrpSpPr>
+        <p:grpSpPr>
+          <a:xfrm>
+            <a:off x="499562" y="1913022"/>
+            <a:ext cx="2562583" cy="4658375"/>
+            <a:chOff x="674223" y="1913022"/>
+            <a:chExt cx="2562583" cy="4658375"/>
+          </a:xfrm>
+        </p:grpSpPr>
+        <p:pic>
+          <p:nvPicPr>
+            <p:cNvPr id="6" name="그림 5">
+              <a:extLst>
+                <a:ext uri="{FF2B5EF4-FFF2-40B4-BE49-F238E27FC236}">
+                  <a16:creationId xmlns:a16="http://schemas.microsoft.com/office/drawing/2014/main" id="{9A0FCEE6-4D8E-9113-F7BA-9F31981D3477}"/>
+                </a:ext>
+              </a:extLst>
+            </p:cNvPr>
+            <p:cNvPicPr>
+              <a:picLocks noChangeAspect="1"/>
+            </p:cNvPicPr>
+            <p:nvPr/>
+          </p:nvPicPr>
+          <p:blipFill>
+            <a:blip r:embed="rId2"/>
+            <a:stretch>
+              <a:fillRect/>
+            </a:stretch>
+          </p:blipFill>
+          <p:spPr>
+            <a:xfrm>
+              <a:off x="674223" y="1913022"/>
+              <a:ext cx="2562583" cy="4658375"/>
+            </a:xfrm>
+            <a:prstGeom prst="rect">
+              <a:avLst/>
+            </a:prstGeom>
+          </p:spPr>
+        </p:pic>
+        <p:sp>
+          <p:nvSpPr>
+            <p:cNvPr id="7" name="직사각형 6">
+              <a:extLst>
+                <a:ext uri="{FF2B5EF4-FFF2-40B4-BE49-F238E27FC236}">
+                  <a16:creationId xmlns:a16="http://schemas.microsoft.com/office/drawing/2014/main" id="{680134F3-7509-C636-F123-FE8C82CC8CFC}"/>
+                </a:ext>
+              </a:extLst>
+            </p:cNvPr>
+            <p:cNvSpPr/>
+            <p:nvPr/>
+          </p:nvSpPr>
+          <p:spPr>
+            <a:xfrm>
+              <a:off x="914401" y="5959011"/>
+              <a:ext cx="1304817" cy="226032"/>
+            </a:xfrm>
+            <a:prstGeom prst="rect">
+              <a:avLst/>
+            </a:prstGeom>
+            <a:noFill/>
+            <a:ln>
+              <a:solidFill>
+                <a:srgbClr val="00B050"/>
+              </a:solidFill>
+            </a:ln>
+          </p:spPr>
+          <p:style>
+            <a:lnRef idx="2">
+              <a:schemeClr val="accent1">
+                <a:shade val="15000"/>
+              </a:schemeClr>
+            </a:lnRef>
+            <a:fillRef idx="1">
+              <a:schemeClr val="accent1"/>
+            </a:fillRef>
+            <a:effectRef idx="0">
+              <a:schemeClr val="accent1"/>
+            </a:effectRef>
+            <a:fontRef idx="minor">
+              <a:schemeClr val="lt1"/>
+            </a:fontRef>
+          </p:style>
+          <p:txBody>
+            <a:bodyPr rtlCol="0" anchor="ctr"/>
+            <a:lstStyle/>
+            <a:p>
+              <a:pPr algn="ctr"/>
+              <a:endParaRPr lang="ko-KR" altLang="en-US"/>
+            </a:p>
+          </p:txBody>
+        </p:sp>
+      </p:grpSp>
+      <p:pic>
+        <p:nvPicPr>
+          <p:cNvPr id="9" name="그림 8">
+            <a:extLst>
+              <a:ext uri="{FF2B5EF4-FFF2-40B4-BE49-F238E27FC236}">
+                <a16:creationId xmlns:a16="http://schemas.microsoft.com/office/drawing/2014/main" id="{01F79585-B888-817C-67E5-DA8530A6F5D7}"/>
+              </a:ext>
+            </a:extLst>
+          </p:cNvPr>
+          <p:cNvPicPr>
+            <a:picLocks noChangeAspect="1"/>
+          </p:cNvPicPr>
+          <p:nvPr/>
+        </p:nvPicPr>
+        <p:blipFill>
+          <a:blip r:embed="rId3"/>
+          <a:stretch>
+            <a:fillRect/>
+          </a:stretch>
+        </p:blipFill>
+        <p:spPr>
+          <a:xfrm>
+            <a:off x="3172786" y="1913022"/>
+            <a:ext cx="5694376" cy="2319931"/>
+          </a:xfrm>
+          <a:prstGeom prst="rect">
+            <a:avLst/>
+          </a:prstGeom>
+        </p:spPr>
+      </p:pic>
+      <p:grpSp>
+        <p:nvGrpSpPr>
+          <p:cNvPr id="16" name="그룹 15">
+            <a:extLst>
+              <a:ext uri="{FF2B5EF4-FFF2-40B4-BE49-F238E27FC236}">
+                <a16:creationId xmlns:a16="http://schemas.microsoft.com/office/drawing/2014/main" id="{7ADE5E64-4B9F-421E-6753-AB614C0359A2}"/>
+              </a:ext>
+            </a:extLst>
+          </p:cNvPr>
+          <p:cNvGrpSpPr/>
+          <p:nvPr/>
+        </p:nvGrpSpPr>
+        <p:grpSpPr>
+          <a:xfrm>
+            <a:off x="8856888" y="1913022"/>
+            <a:ext cx="2979386" cy="4977029"/>
+            <a:chOff x="8856888" y="1913022"/>
+            <a:chExt cx="2979386" cy="4977029"/>
+          </a:xfrm>
+        </p:grpSpPr>
+        <p:pic>
+          <p:nvPicPr>
+            <p:cNvPr id="11" name="그림 10">
+              <a:extLst>
+                <a:ext uri="{FF2B5EF4-FFF2-40B4-BE49-F238E27FC236}">
+                  <a16:creationId xmlns:a16="http://schemas.microsoft.com/office/drawing/2014/main" id="{8DCEEDB6-795E-4D0A-95A3-A17EAAF4141D}"/>
+                </a:ext>
+              </a:extLst>
+            </p:cNvPr>
+            <p:cNvPicPr>
+              <a:picLocks noChangeAspect="1"/>
+            </p:cNvPicPr>
+            <p:nvPr/>
+          </p:nvPicPr>
+          <p:blipFill>
+            <a:blip r:embed="rId4"/>
+            <a:stretch>
+              <a:fillRect/>
+            </a:stretch>
+          </p:blipFill>
+          <p:spPr>
+            <a:xfrm>
+              <a:off x="8977803" y="1913022"/>
+              <a:ext cx="1867161" cy="695422"/>
+            </a:xfrm>
+            <a:prstGeom prst="rect">
+              <a:avLst/>
+            </a:prstGeom>
+          </p:spPr>
+        </p:pic>
+        <p:pic>
+          <p:nvPicPr>
+            <p:cNvPr id="13" name="그림 12">
+              <a:extLst>
+                <a:ext uri="{FF2B5EF4-FFF2-40B4-BE49-F238E27FC236}">
+                  <a16:creationId xmlns:a16="http://schemas.microsoft.com/office/drawing/2014/main" id="{CB1B1DDF-221E-9CAE-8B3B-20DFD40CB533}"/>
+                </a:ext>
+              </a:extLst>
+            </p:cNvPr>
+            <p:cNvPicPr>
+              <a:picLocks noChangeAspect="1"/>
+            </p:cNvPicPr>
+            <p:nvPr/>
+          </p:nvPicPr>
+          <p:blipFill>
+            <a:blip r:embed="rId5"/>
+            <a:stretch>
+              <a:fillRect/>
+            </a:stretch>
+          </p:blipFill>
+          <p:spPr>
+            <a:xfrm>
+              <a:off x="8856888" y="2930202"/>
+              <a:ext cx="2931923" cy="1744540"/>
+            </a:xfrm>
+            <a:prstGeom prst="rect">
+              <a:avLst/>
+            </a:prstGeom>
+          </p:spPr>
+        </p:pic>
+        <p:pic>
+          <p:nvPicPr>
+            <p:cNvPr id="15" name="그림 14">
+              <a:extLst>
+                <a:ext uri="{FF2B5EF4-FFF2-40B4-BE49-F238E27FC236}">
+                  <a16:creationId xmlns:a16="http://schemas.microsoft.com/office/drawing/2014/main" id="{32172CA7-9BFF-6A41-7DC1-87A5F996A123}"/>
+                </a:ext>
+              </a:extLst>
+            </p:cNvPr>
+            <p:cNvPicPr>
+              <a:picLocks noChangeAspect="1"/>
+            </p:cNvPicPr>
+            <p:nvPr/>
+          </p:nvPicPr>
+          <p:blipFill>
+            <a:blip r:embed="rId6"/>
+            <a:stretch>
+              <a:fillRect/>
+            </a:stretch>
+          </p:blipFill>
+          <p:spPr>
+            <a:xfrm>
+              <a:off x="9010998" y="4826856"/>
+              <a:ext cx="2825276" cy="2063195"/>
+            </a:xfrm>
+            <a:prstGeom prst="rect">
+              <a:avLst/>
+            </a:prstGeom>
+          </p:spPr>
+        </p:pic>
+      </p:grpSp>
+      <p:sp>
+        <p:nvSpPr>
+          <p:cNvPr id="17" name="TextBox 16">
+            <a:extLst>
+              <a:ext uri="{FF2B5EF4-FFF2-40B4-BE49-F238E27FC236}">
+                <a16:creationId xmlns:a16="http://schemas.microsoft.com/office/drawing/2014/main" id="{D13ADD16-1433-092C-61B2-3B94B7A707EF}"/>
+              </a:ext>
+            </a:extLst>
+          </p:cNvPr>
+          <p:cNvSpPr txBox="1"/>
+          <p:nvPr/>
+        </p:nvSpPr>
+        <p:spPr>
+          <a:xfrm>
+            <a:off x="3267182" y="4469258"/>
+            <a:ext cx="5599980" cy="2492990"/>
+          </a:xfrm>
+          <a:prstGeom prst="rect">
+            <a:avLst/>
+          </a:prstGeom>
+          <a:noFill/>
+        </p:spPr>
+        <p:txBody>
+          <a:bodyPr wrap="square" rtlCol="0">
+            <a:spAutoFit/>
+          </a:bodyPr>
+          <a:lstStyle/>
+          <a:p>
+            <a:r>
+              <a:rPr lang="en-US" altLang="ko-KR" sz="1200"/>
+              <a:t>164~168 Line </a:t>
+            </a:r>
+            <a:r>
+              <a:rPr lang="en-US" altLang="ko-KR" sz="1200">
+                <a:sym typeface="Wingdings" panose="05000000000000000000" pitchFamily="2" charset="2"/>
+              </a:rPr>
+              <a:t></a:t>
+            </a:r>
+            <a:endParaRPr lang="en-US" altLang="ko-KR" sz="1200"/>
+          </a:p>
+          <a:p>
+            <a:r>
+              <a:rPr lang="en-US" altLang="ko-KR" sz="1200"/>
+              <a:t>NativeQuery </a:t>
+            </a:r>
+            <a:r>
+              <a:rPr lang="ko-KR" altLang="en-US" sz="1200"/>
+              <a:t>의 </a:t>
+            </a:r>
+            <a:r>
+              <a:rPr lang="en-US" altLang="ko-KR" sz="1200"/>
+              <a:t>withQuery </a:t>
+            </a:r>
+            <a:r>
+              <a:rPr lang="ko-KR" altLang="en-US" sz="1200"/>
+              <a:t>메소드를 통해 </a:t>
+            </a:r>
+            <a:r>
+              <a:rPr lang="en-US" altLang="ko-KR" sz="1200"/>
+              <a:t>"query"</a:t>
+            </a:r>
+            <a:r>
+              <a:rPr lang="ko-KR" altLang="en-US" sz="1200"/>
+              <a:t>를 셋팅</a:t>
+            </a:r>
+            <a:endParaRPr lang="en-US" altLang="ko-KR" sz="1200"/>
+          </a:p>
+          <a:p>
+            <a:r>
+              <a:rPr lang="ko-KR" altLang="en-US" sz="1200"/>
+              <a:t>마찬가지로 </a:t>
+            </a:r>
+            <a:r>
+              <a:rPr lang="en-US" altLang="ko-KR" sz="1200"/>
+              <a:t>withHighlightQuery</a:t>
+            </a:r>
+            <a:r>
+              <a:rPr lang="ko-KR" altLang="en-US" sz="1200"/>
+              <a:t> 메소드를 통해 </a:t>
+            </a:r>
+            <a:r>
+              <a:rPr lang="en-US" altLang="ko-KR" sz="1200"/>
+              <a:t>"highlight" </a:t>
+            </a:r>
+            <a:r>
+              <a:rPr lang="ko-KR" altLang="en-US" sz="1200"/>
+              <a:t>를 셋팅</a:t>
+            </a:r>
+            <a:endParaRPr lang="en-US" altLang="ko-KR" sz="1200"/>
+          </a:p>
+          <a:p>
+            <a:r>
+              <a:rPr lang="en-US" altLang="ko-KR" sz="1200"/>
+              <a:t>withPageable </a:t>
+            </a:r>
+            <a:r>
+              <a:rPr lang="ko-KR" altLang="en-US" sz="1200"/>
+              <a:t>메소드를 통해 </a:t>
+            </a:r>
+            <a:r>
+              <a:rPr lang="en-US" altLang="ko-KR" sz="1200"/>
+              <a:t>from, size</a:t>
+            </a:r>
+            <a:r>
+              <a:rPr lang="ko-KR" altLang="en-US" sz="1200"/>
+              <a:t>에 대한 정보로 페이지 처리를 해준다</a:t>
+            </a:r>
+            <a:r>
+              <a:rPr lang="en-US" altLang="ko-KR" sz="1200"/>
+              <a:t>.</a:t>
+            </a:r>
+          </a:p>
+          <a:p>
+            <a:endParaRPr lang="en-US" altLang="ko-KR" sz="1200"/>
+          </a:p>
+          <a:p>
+            <a:r>
+              <a:rPr lang="en-US" altLang="ko-KR" sz="1200"/>
+              <a:t>170~171Line </a:t>
+            </a:r>
+            <a:r>
+              <a:rPr lang="en-US" altLang="ko-KR" sz="1200">
+                <a:sym typeface="Wingdings" panose="05000000000000000000" pitchFamily="2" charset="2"/>
+              </a:rPr>
+              <a:t> elasticsearchOperations</a:t>
+            </a:r>
+            <a:r>
+              <a:rPr lang="ko-KR" altLang="en-US" sz="1200">
+                <a:sym typeface="Wingdings" panose="05000000000000000000" pitchFamily="2" charset="2"/>
+              </a:rPr>
+              <a:t>의 </a:t>
+            </a:r>
+            <a:r>
+              <a:rPr lang="en-US" altLang="ko-KR" sz="1200">
+                <a:sym typeface="Wingdings" panose="05000000000000000000" pitchFamily="2" charset="2"/>
+              </a:rPr>
+              <a:t>searc</a:t>
+            </a:r>
+            <a:r>
+              <a:rPr lang="ko-KR" altLang="en-US" sz="1200">
+                <a:sym typeface="Wingdings" panose="05000000000000000000" pitchFamily="2" charset="2"/>
+              </a:rPr>
+              <a:t>메소드를 통해 작성한 </a:t>
+            </a:r>
+            <a:r>
+              <a:rPr lang="en-US" altLang="ko-KR" sz="1200">
+                <a:sym typeface="Wingdings" panose="05000000000000000000" pitchFamily="2" charset="2"/>
+              </a:rPr>
+              <a:t>nativeQuery</a:t>
+            </a:r>
+            <a:r>
+              <a:rPr lang="ko-KR" altLang="en-US" sz="1200">
+                <a:sym typeface="Wingdings" panose="05000000000000000000" pitchFamily="2" charset="2"/>
+              </a:rPr>
+              <a:t>의 실행</a:t>
+            </a:r>
+            <a:r>
+              <a:rPr lang="en-US" altLang="ko-KR" sz="1200">
+                <a:sym typeface="Wingdings" panose="05000000000000000000" pitchFamily="2" charset="2"/>
+              </a:rPr>
+              <a:t>.</a:t>
+            </a:r>
+          </a:p>
+          <a:p>
+            <a:endParaRPr lang="en-US" altLang="ko-KR" sz="1200">
+              <a:sym typeface="Wingdings" panose="05000000000000000000" pitchFamily="2" charset="2"/>
+            </a:endParaRPr>
+          </a:p>
+          <a:p>
+            <a:r>
+              <a:rPr lang="en-US" altLang="ko-KR" sz="1200">
+                <a:sym typeface="Wingdings" panose="05000000000000000000" pitchFamily="2" charset="2"/>
+              </a:rPr>
+              <a:t>172~180Line  </a:t>
+            </a:r>
+            <a:r>
+              <a:rPr lang="ko-KR" altLang="en-US" sz="1200">
+                <a:sym typeface="Wingdings" panose="05000000000000000000" pitchFamily="2" charset="2"/>
+              </a:rPr>
+              <a:t>조건 검색 결과를 </a:t>
+            </a:r>
+            <a:r>
+              <a:rPr lang="en-US" altLang="ko-KR" sz="1200">
+                <a:sym typeface="Wingdings" panose="05000000000000000000" pitchFamily="2" charset="2"/>
+              </a:rPr>
+              <a:t>ProductDocument</a:t>
+            </a:r>
+            <a:r>
+              <a:rPr lang="ko-KR" altLang="en-US" sz="1200">
+                <a:sym typeface="Wingdings" panose="05000000000000000000" pitchFamily="2" charset="2"/>
+              </a:rPr>
+              <a:t>로 감싸 리스트화 반환</a:t>
+            </a:r>
+            <a:br>
+              <a:rPr lang="en-US" altLang="ko-KR" sz="1200">
+                <a:sym typeface="Wingdings" panose="05000000000000000000" pitchFamily="2" charset="2"/>
+              </a:rPr>
+            </a:br>
+            <a:r>
+              <a:rPr lang="en-US" altLang="ko-KR" sz="1200">
+                <a:sym typeface="Wingdings" panose="05000000000000000000" pitchFamily="2" charset="2"/>
+              </a:rPr>
+              <a:t>                             </a:t>
+            </a:r>
+            <a:r>
+              <a:rPr lang="ko-KR" altLang="en-US" sz="1200">
+                <a:sym typeface="Wingdings" panose="05000000000000000000" pitchFamily="2" charset="2"/>
+              </a:rPr>
+              <a:t>상품 명의 경우 </a:t>
+            </a:r>
+            <a:r>
+              <a:rPr lang="en-US" altLang="ko-KR" sz="1200">
+                <a:sym typeface="Wingdings" panose="05000000000000000000" pitchFamily="2" charset="2"/>
+              </a:rPr>
+              <a:t>highlight </a:t>
+            </a:r>
+            <a:r>
+              <a:rPr lang="ko-KR" altLang="en-US" sz="1200">
+                <a:sym typeface="Wingdings" panose="05000000000000000000" pitchFamily="2" charset="2"/>
+              </a:rPr>
+              <a:t>처리된 문자열로 반환해야함으로</a:t>
+            </a:r>
+            <a:r>
+              <a:rPr lang="en-US" altLang="ko-KR" sz="1200">
+                <a:sym typeface="Wingdings" panose="05000000000000000000" pitchFamily="2" charset="2"/>
+              </a:rPr>
+              <a:t>.</a:t>
+            </a:r>
+            <a:br>
+              <a:rPr lang="en-US" altLang="ko-KR" sz="1200">
+                <a:sym typeface="Wingdings" panose="05000000000000000000" pitchFamily="2" charset="2"/>
+              </a:rPr>
+            </a:br>
+            <a:r>
+              <a:rPr lang="en-US" altLang="ko-KR" sz="1200">
+                <a:sym typeface="Wingdings" panose="05000000000000000000" pitchFamily="2" charset="2"/>
+              </a:rPr>
+              <a:t>                              hit.getHighlightFields().get("name").get(0) </a:t>
+            </a:r>
+            <a:r>
+              <a:rPr lang="ko-KR" altLang="en-US" sz="1200">
+                <a:sym typeface="Wingdings" panose="05000000000000000000" pitchFamily="2" charset="2"/>
+              </a:rPr>
+              <a:t>로 </a:t>
+            </a:r>
+            <a:r>
+              <a:rPr lang="en-US" altLang="ko-KR" sz="1200">
+                <a:sym typeface="Wingdings" panose="05000000000000000000" pitchFamily="2" charset="2"/>
+              </a:rPr>
+              <a:t>highlight </a:t>
+            </a:r>
+            <a:r>
+              <a:rPr lang="ko-KR" altLang="en-US" sz="1200">
+                <a:sym typeface="Wingdings" panose="05000000000000000000" pitchFamily="2" charset="2"/>
+              </a:rPr>
+              <a:t>처리된 </a:t>
+            </a:r>
+            <a:br>
+              <a:rPr lang="en-US" altLang="ko-KR" sz="1200">
+                <a:sym typeface="Wingdings" panose="05000000000000000000" pitchFamily="2" charset="2"/>
+              </a:rPr>
+            </a:br>
+            <a:r>
+              <a:rPr lang="en-US" altLang="ko-KR" sz="1200">
+                <a:sym typeface="Wingdings" panose="05000000000000000000" pitchFamily="2" charset="2"/>
+              </a:rPr>
+              <a:t>                             </a:t>
+            </a:r>
+            <a:r>
+              <a:rPr lang="ko-KR" altLang="en-US" sz="1200">
+                <a:sym typeface="Wingdings" panose="05000000000000000000" pitchFamily="2" charset="2"/>
+              </a:rPr>
+              <a:t>문자열을 셋팅하여 반환한다</a:t>
+            </a:r>
+            <a:r>
+              <a:rPr lang="en-US" altLang="ko-KR" sz="1200">
+                <a:sym typeface="Wingdings" panose="05000000000000000000" pitchFamily="2" charset="2"/>
+              </a:rPr>
+              <a:t>.</a:t>
+            </a:r>
+            <a:endParaRPr lang="en-US" altLang="ko-KR" sz="1200"/>
+          </a:p>
+          <a:p>
+            <a:endParaRPr lang="ko-KR" altLang="en-US" sz="1200"/>
+          </a:p>
+        </p:txBody>
+      </p:sp>
+    </p:spTree>
+    <p:extLst>
+      <p:ext uri="{BB962C8B-B14F-4D97-AF65-F5344CB8AC3E}">
+        <p14:creationId xmlns:p14="http://schemas.microsoft.com/office/powerpoint/2010/main" val="2193458202"/>
+      </p:ext>
+    </p:extLst>
+  </p:cSld>
+  <p:clrMapOvr>
+    <a:masterClrMapping/>
+  </p:clrMapOvr>
+</p:sld>
+</file>
+
 <file path=ppt/slides/slide3.xml><?xml version="1.0" encoding="utf-8"?>
 <p:sld xmlns:a="http://schemas.openxmlformats.org/drawingml/2006/main" xmlns:r="http://schemas.openxmlformats.org/officeDocument/2006/relationships" xmlns:p="http://schemas.openxmlformats.org/presentationml/2006/main">
   <p:cSld>

</xml_diff>